<commit_message>
docs: redesign EvalCall six-step overview
</commit_message>
<xml_diff>
--- a/submission/EvalCall决赛提交包-20260715/01_EvalCall决赛PPT-最终提交版.pptx
+++ b/submission/EvalCall决赛提交包-20260715/01_EvalCall决赛PPT-最终提交版.pptx
@@ -2,21 +2,21 @@
 <file path=ppt/presentation.xml><?xml version="1.0" encoding="utf-8"?>
 <p:presentation xmlns:p="http://schemas.openxmlformats.org/presentationml/2006/main">
   <p:sldMasterIdLst>
-    <p:sldMasterId xmlns:r="http://schemas.openxmlformats.org/officeDocument/2006/relationships" id="2147483648" r:id="Rfe9f91867e2b4350"/>
+    <p:sldMasterId xmlns:r="http://schemas.openxmlformats.org/officeDocument/2006/relationships" id="2147483648" r:id="Raccf9b20c2d845a7"/>
   </p:sldMasterIdLst>
   <p:notesMasterIdLst>
-    <p:notesMasterId xmlns:r="http://schemas.openxmlformats.org/officeDocument/2006/relationships" r:id="Ra05e5ddf8fc148e1"/>
+    <p:notesMasterId xmlns:r="http://schemas.openxmlformats.org/officeDocument/2006/relationships" r:id="Ra877ad6c90384a43"/>
   </p:notesMasterIdLst>
   <p:sldIdLst>
-    <p:sldId xmlns:r="http://schemas.openxmlformats.org/officeDocument/2006/relationships" id="256" r:id="R3ec07cfae2b84cfe"/>
-    <p:sldId xmlns:r="http://schemas.openxmlformats.org/officeDocument/2006/relationships" id="257" r:id="Rfdd8f2a0fe4f4a10"/>
-    <p:sldId xmlns:r="http://schemas.openxmlformats.org/officeDocument/2006/relationships" id="258" r:id="Rf4bd7e9e826e4513"/>
-    <p:sldId xmlns:r="http://schemas.openxmlformats.org/officeDocument/2006/relationships" id="259" r:id="R4b1c180705564481"/>
-    <p:sldId xmlns:r="http://schemas.openxmlformats.org/officeDocument/2006/relationships" id="260" r:id="R56d139750c214727"/>
-    <p:sldId xmlns:r="http://schemas.openxmlformats.org/officeDocument/2006/relationships" id="261" r:id="Rc67adf09bcd34757"/>
-    <p:sldId xmlns:r="http://schemas.openxmlformats.org/officeDocument/2006/relationships" id="262" r:id="R7d5c7607607a448c"/>
-    <p:sldId xmlns:r="http://schemas.openxmlformats.org/officeDocument/2006/relationships" id="263" r:id="Rccdd674f480040c6"/>
-    <p:sldId xmlns:r="http://schemas.openxmlformats.org/officeDocument/2006/relationships" id="264" r:id="R39ce073740c04d56"/>
+    <p:sldId xmlns:r="http://schemas.openxmlformats.org/officeDocument/2006/relationships" id="256" r:id="R20738b59c50d436f"/>
+    <p:sldId xmlns:r="http://schemas.openxmlformats.org/officeDocument/2006/relationships" id="257" r:id="R0f1a63dca1c14cdf"/>
+    <p:sldId xmlns:r="http://schemas.openxmlformats.org/officeDocument/2006/relationships" id="258" r:id="R1ecb4381e19140e8"/>
+    <p:sldId xmlns:r="http://schemas.openxmlformats.org/officeDocument/2006/relationships" id="259" r:id="R7f3ef8aec69d4ecd"/>
+    <p:sldId xmlns:r="http://schemas.openxmlformats.org/officeDocument/2006/relationships" id="260" r:id="R5fec3e7b371b4619"/>
+    <p:sldId xmlns:r="http://schemas.openxmlformats.org/officeDocument/2006/relationships" id="261" r:id="Rd48c294b4c0a432f"/>
+    <p:sldId xmlns:r="http://schemas.openxmlformats.org/officeDocument/2006/relationships" id="262" r:id="Re33e345d80de4b55"/>
+    <p:sldId xmlns:r="http://schemas.openxmlformats.org/officeDocument/2006/relationships" id="263" r:id="Red15dd8fc50d48b3"/>
+    <p:sldId xmlns:r="http://schemas.openxmlformats.org/officeDocument/2006/relationships" id="264" r:id="R2c813f8b44574722"/>
   </p:sldIdLst>
   <p:sldSz cx="12192000" cy="6858000"/>
   <p:notesSz cx="6858000" cy="9144000"/>
@@ -1238,7 +1238,7 @@
   </p:cSld>
   <p:clrMap bg1="lt1" tx1="dk1" bg2="lt2" tx2="dk2" accent1="accent1" accent2="accent2" accent3="accent3" accent4="accent4" accent5="accent5" accent6="accent6" hlink="hlink" folHlink="folHlink"/>
   <p:sldLayoutIdLst>
-    <p:sldLayoutId xmlns:r="http://schemas.openxmlformats.org/officeDocument/2006/relationships" id="2147483649" r:id="R7bbd6a40754d496a"/>
+    <p:sldLayoutId xmlns:r="http://schemas.openxmlformats.org/officeDocument/2006/relationships" id="2147483649" r:id="R2078dab3c8f54e11"/>
   </p:sldLayoutIdLst>
   <p:txStyles>
     <p:titleStyle>
@@ -1793,7 +1793,7 @@
           <p:nvPr/>
         </p:nvPicPr>
         <p:blipFill>
-          <a:blip xmlns:r="http://schemas.openxmlformats.org/officeDocument/2006/relationships" xmlns:a="http://schemas.openxmlformats.org/drawingml/2006/main" r:embed="R26c7083d0dc14c01"/>
+          <a:blip xmlns:r="http://schemas.openxmlformats.org/officeDocument/2006/relationships" xmlns:a="http://schemas.openxmlformats.org/drawingml/2006/main" r:embed="R842447d322514666"/>
           <a:srcRect xmlns:a="http://schemas.openxmlformats.org/drawingml/2006/main" l="0" t="27" r="0" b="27"/>
           <a:stretch xmlns:a="http://schemas.openxmlformats.org/drawingml/2006/main">
             <a:fillRect l="0" t="0" r="0" b="0"/>
@@ -1873,6 +1873,7 @@
           <a:lstStyle xmlns:a="http://schemas.openxmlformats.org/drawingml/2006/main"/>
           <a:p xmlns:a="http://schemas.openxmlformats.org/drawingml/2006/main">
             <a:pPr algn="l">
+              <a:buNone/>
               <a:defRPr sz="1050" b="1">
                 <a:solidFill>
                   <a:srgbClr val="6E7A90"/>
@@ -1925,6 +1926,7 @@
           <a:lstStyle xmlns:a="http://schemas.openxmlformats.org/drawingml/2006/main"/>
           <a:p xmlns:a="http://schemas.openxmlformats.org/drawingml/2006/main">
             <a:pPr algn="l">
+              <a:buNone/>
               <a:defRPr sz="3000" b="1">
                 <a:solidFill>
                   <a:srgbClr val="111C31"/>
@@ -2008,6 +2010,7 @@
           <a:lstStyle xmlns:a="http://schemas.openxmlformats.org/drawingml/2006/main"/>
           <a:p xmlns:a="http://schemas.openxmlformats.org/drawingml/2006/main">
             <a:pPr algn="r">
+              <a:buNone/>
               <a:defRPr sz="1350" b="1">
                 <a:solidFill>
                   <a:srgbClr val="1D2B46"/>
@@ -2060,6 +2063,7 @@
           <a:lstStyle xmlns:a="http://schemas.openxmlformats.org/drawingml/2006/main"/>
           <a:p xmlns:a="http://schemas.openxmlformats.org/drawingml/2006/main">
             <a:pPr algn="ctr">
+              <a:buNone/>
               <a:defRPr sz="2850" b="1">
                 <a:solidFill>
                   <a:srgbClr val="C48800"/>
@@ -2112,6 +2116,7 @@
           <a:lstStyle xmlns:a="http://schemas.openxmlformats.org/drawingml/2006/main"/>
           <a:p xmlns:a="http://schemas.openxmlformats.org/drawingml/2006/main">
             <a:pPr algn="l">
+              <a:buNone/>
               <a:defRPr sz="1350" b="1">
                 <a:solidFill>
                   <a:srgbClr val="1D2B46"/>
@@ -2296,6 +2301,7 @@
           <a:lstStyle xmlns:a="http://schemas.openxmlformats.org/drawingml/2006/main"/>
           <a:p xmlns:a="http://schemas.openxmlformats.org/drawingml/2006/main">
             <a:pPr algn="ctr">
+              <a:buNone/>
               <a:defRPr sz="975" b="1">
                 <a:solidFill>
                   <a:srgbClr val="FFFFFF"/>
@@ -2348,6 +2354,7 @@
           <a:lstStyle xmlns:a="http://schemas.openxmlformats.org/drawingml/2006/main"/>
           <a:p xmlns:a="http://schemas.openxmlformats.org/drawingml/2006/main">
             <a:pPr algn="l">
+              <a:buNone/>
               <a:defRPr sz="1275" b="1">
                 <a:solidFill>
                   <a:srgbClr val="111C31"/>
@@ -2431,6 +2438,7 @@
           <a:lstStyle xmlns:a="http://schemas.openxmlformats.org/drawingml/2006/main"/>
           <a:p xmlns:a="http://schemas.openxmlformats.org/drawingml/2006/main">
             <a:pPr algn="l">
+              <a:buNone/>
               <a:defRPr sz="1013" b="0">
                 <a:solidFill>
                   <a:srgbClr val="1D2B46"/>
@@ -2582,6 +2590,7 @@
           <a:lstStyle xmlns:a="http://schemas.openxmlformats.org/drawingml/2006/main"/>
           <a:p xmlns:a="http://schemas.openxmlformats.org/drawingml/2006/main">
             <a:pPr algn="ctr">
+              <a:buNone/>
               <a:defRPr sz="975" b="1">
                 <a:solidFill>
                   <a:srgbClr val="FFFFFF"/>
@@ -2634,6 +2643,7 @@
           <a:lstStyle xmlns:a="http://schemas.openxmlformats.org/drawingml/2006/main"/>
           <a:p xmlns:a="http://schemas.openxmlformats.org/drawingml/2006/main">
             <a:pPr algn="l">
+              <a:buNone/>
               <a:defRPr sz="1275" b="1">
                 <a:solidFill>
                   <a:srgbClr val="111C31"/>
@@ -2717,6 +2727,7 @@
           <a:lstStyle xmlns:a="http://schemas.openxmlformats.org/drawingml/2006/main"/>
           <a:p xmlns:a="http://schemas.openxmlformats.org/drawingml/2006/main">
             <a:pPr algn="l">
+              <a:buNone/>
               <a:defRPr sz="1013" b="0">
                 <a:solidFill>
                   <a:srgbClr val="1D2B46"/>
@@ -2868,6 +2879,7 @@
           <a:lstStyle xmlns:a="http://schemas.openxmlformats.org/drawingml/2006/main"/>
           <a:p xmlns:a="http://schemas.openxmlformats.org/drawingml/2006/main">
             <a:pPr algn="ctr">
+              <a:buNone/>
               <a:defRPr sz="975" b="1">
                 <a:solidFill>
                   <a:srgbClr val="FFFFFF"/>
@@ -2920,6 +2932,7 @@
           <a:lstStyle xmlns:a="http://schemas.openxmlformats.org/drawingml/2006/main"/>
           <a:p xmlns:a="http://schemas.openxmlformats.org/drawingml/2006/main">
             <a:pPr algn="l">
+              <a:buNone/>
               <a:defRPr sz="1275" b="1">
                 <a:solidFill>
                   <a:srgbClr val="111C31"/>
@@ -3003,6 +3016,7 @@
           <a:lstStyle xmlns:a="http://schemas.openxmlformats.org/drawingml/2006/main"/>
           <a:p xmlns:a="http://schemas.openxmlformats.org/drawingml/2006/main">
             <a:pPr algn="l">
+              <a:buNone/>
               <a:defRPr sz="1013" b="0">
                 <a:solidFill>
                   <a:srgbClr val="1D2B46"/>
@@ -3154,6 +3168,7 @@
           <a:lstStyle xmlns:a="http://schemas.openxmlformats.org/drawingml/2006/main"/>
           <a:p xmlns:a="http://schemas.openxmlformats.org/drawingml/2006/main">
             <a:pPr algn="ctr">
+              <a:buNone/>
               <a:defRPr sz="975" b="1">
                 <a:solidFill>
                   <a:srgbClr val="FFFFFF"/>
@@ -3206,6 +3221,7 @@
           <a:lstStyle xmlns:a="http://schemas.openxmlformats.org/drawingml/2006/main"/>
           <a:p xmlns:a="http://schemas.openxmlformats.org/drawingml/2006/main">
             <a:pPr algn="l">
+              <a:buNone/>
               <a:defRPr sz="1275" b="1">
                 <a:solidFill>
                   <a:srgbClr val="111C31"/>
@@ -3289,6 +3305,7 @@
           <a:lstStyle xmlns:a="http://schemas.openxmlformats.org/drawingml/2006/main"/>
           <a:p xmlns:a="http://schemas.openxmlformats.org/drawingml/2006/main">
             <a:pPr algn="l">
+              <a:buNone/>
               <a:defRPr sz="1013" b="0">
                 <a:solidFill>
                   <a:srgbClr val="1D2B46"/>
@@ -3440,6 +3457,7 @@
           <a:lstStyle xmlns:a="http://schemas.openxmlformats.org/drawingml/2006/main"/>
           <a:p xmlns:a="http://schemas.openxmlformats.org/drawingml/2006/main">
             <a:pPr algn="ctr">
+              <a:buNone/>
               <a:defRPr sz="975" b="1">
                 <a:solidFill>
                   <a:srgbClr val="FFFFFF"/>
@@ -3492,6 +3510,7 @@
           <a:lstStyle xmlns:a="http://schemas.openxmlformats.org/drawingml/2006/main"/>
           <a:p xmlns:a="http://schemas.openxmlformats.org/drawingml/2006/main">
             <a:pPr algn="l">
+              <a:buNone/>
               <a:defRPr sz="1275" b="1">
                 <a:solidFill>
                   <a:srgbClr val="111C31"/>
@@ -3575,6 +3594,7 @@
           <a:lstStyle xmlns:a="http://schemas.openxmlformats.org/drawingml/2006/main"/>
           <a:p xmlns:a="http://schemas.openxmlformats.org/drawingml/2006/main">
             <a:pPr algn="l">
+              <a:buNone/>
               <a:defRPr sz="1013" b="0">
                 <a:solidFill>
                   <a:srgbClr val="1D2B46"/>
@@ -3658,6 +3678,7 @@
           <a:lstStyle xmlns:a="http://schemas.openxmlformats.org/drawingml/2006/main"/>
           <a:p xmlns:a="http://schemas.openxmlformats.org/drawingml/2006/main">
             <a:pPr algn="l">
+              <a:buNone/>
               <a:defRPr sz="2325" b="1">
                 <a:solidFill>
                   <a:srgbClr val="111C31"/>
@@ -3743,6 +3764,7 @@
           <a:lstStyle xmlns:a="http://schemas.openxmlformats.org/drawingml/2006/main"/>
           <a:p xmlns:a="http://schemas.openxmlformats.org/drawingml/2006/main">
             <a:pPr algn="l">
+              <a:buNone/>
               <a:defRPr sz="2025" b="1">
                 <a:solidFill>
                   <a:srgbClr val="C48800"/>
@@ -3828,6 +3850,7 @@
           <a:lstStyle xmlns:a="http://schemas.openxmlformats.org/drawingml/2006/main"/>
           <a:p xmlns:a="http://schemas.openxmlformats.org/drawingml/2006/main">
             <a:pPr algn="r">
+              <a:buNone/>
               <a:defRPr sz="750" b="0">
                 <a:solidFill>
                   <a:srgbClr val="6E7A90"/>
@@ -3861,7 +3884,7 @@
     <p:bg>
       <p:bgPr>
         <a:solidFill xmlns:a="http://schemas.openxmlformats.org/drawingml/2006/main">
-          <a:srgbClr val="FFFFFF"/>
+          <a:srgbClr val="FCFCFB"/>
         </a:solidFill>
       </p:bgPr>
     </p:bg>
@@ -3876,1606 +3899,6 @@
       </p:grpSpPr>
       <p:sp>
         <p:nvSpPr>
-          <p:cNvPr id="1" name="kicker">
-            <a:extLst xmlns:a="http://schemas.openxmlformats.org/drawingml/2006/main">
-              <a:ext uri="{FF2B5EF4-FFF2-40B4-BE49-F238E27FC236}">
-                <a16:creationId xmlns:a16="http://schemas.microsoft.com/office/drawing/2014/main" id="{AEFFADB3-C24B-464A-A482-53E431FC053A}"/>
-              </a:ext>
-            </a:extLst>
-          </p:cNvPr>
-          <p:cNvSpPr>
-            <a:spLocks xmlns:a="http://schemas.openxmlformats.org/drawingml/2006/main" noGrp="1"/>
-          </p:cNvSpPr>
-          <p:nvPr/>
-        </p:nvSpPr>
-        <p:spPr>
-          <a:xfrm xmlns:a="http://schemas.openxmlformats.org/drawingml/2006/main">
-            <a:off x="533400" y="323850"/>
-            <a:ext cx="6858000" cy="266700"/>
-          </a:xfrm>
-          <a:prstGeom xmlns:a="http://schemas.openxmlformats.org/drawingml/2006/main" prst="rect">
-            <a:avLst/>
-          </a:prstGeom>
-          <a:noFill xmlns:a="http://schemas.openxmlformats.org/drawingml/2006/main"/>
-          <a:ln xmlns:a="http://schemas.openxmlformats.org/drawingml/2006/main" w="0">
-            <a:noFill/>
-            <a:prstDash val="solid"/>
-          </a:ln>
-        </p:spPr>
-        <p:txBody>
-          <a:bodyPr xmlns:a="http://schemas.openxmlformats.org/drawingml/2006/main" anchor="t">
-            <a:normAutofit fontScale="95833"/>
-          </a:bodyPr>
-          <a:lstStyle xmlns:a="http://schemas.openxmlformats.org/drawingml/2006/main"/>
-          <a:p xmlns:a="http://schemas.openxmlformats.org/drawingml/2006/main">
-            <a:pPr algn="l">
-              <a:buNone/>
-              <a:defRPr sz="1200" b="1">
-                <a:solidFill>
-                  <a:srgbClr val="667085"/>
-                </a:solidFill>
-                <a:latin typeface="PingFang SC"/>
-                <a:ea typeface="PingFang SC"/>
-                <a:cs typeface="PingFang SC"/>
-              </a:defRPr>
-            </a:pPr>
-            <a:r>
-              <a:rPr sz="1200" b="1">
-                <a:solidFill>
-                  <a:srgbClr val="667085"/>
-                </a:solidFill>
-                <a:latin typeface="PingFang SC"/>
-                <a:ea typeface="PingFang SC"/>
-                <a:cs typeface="PingFang SC"/>
-              </a:rPr>
-              <a:t>EVALCALL · 外呼模型上线前的自动化指令遵循评测</a:t>
-            </a:r>
-          </a:p>
-        </p:txBody>
-      </p:sp>
-      <p:sp>
-        <p:nvSpPr>
-          <p:cNvPr id="2" name="title">
-            <a:extLst xmlns:a="http://schemas.openxmlformats.org/drawingml/2006/main">
-              <a:ext uri="{FF2B5EF4-FFF2-40B4-BE49-F238E27FC236}">
-                <a16:creationId xmlns:a16="http://schemas.microsoft.com/office/drawing/2014/main" id="{165D2154-B96E-43F0-B2E9-7CEAA53D049D}"/>
-              </a:ext>
-            </a:extLst>
-          </p:cNvPr>
-          <p:cNvSpPr>
-            <a:spLocks xmlns:a="http://schemas.openxmlformats.org/drawingml/2006/main" noGrp="1"/>
-          </p:cNvSpPr>
-          <p:nvPr/>
-        </p:nvSpPr>
-        <p:spPr>
-          <a:xfrm xmlns:a="http://schemas.openxmlformats.org/drawingml/2006/main">
-            <a:off x="533400" y="666750"/>
-            <a:ext cx="11125200" cy="742950"/>
-          </a:xfrm>
-          <a:prstGeom xmlns:a="http://schemas.openxmlformats.org/drawingml/2006/main" prst="rect">
-            <a:avLst/>
-          </a:prstGeom>
-          <a:noFill xmlns:a="http://schemas.openxmlformats.org/drawingml/2006/main"/>
-          <a:ln xmlns:a="http://schemas.openxmlformats.org/drawingml/2006/main" w="0">
-            <a:noFill/>
-            <a:prstDash val="solid"/>
-          </a:ln>
-        </p:spPr>
-        <p:txBody>
-          <a:bodyPr xmlns:a="http://schemas.openxmlformats.org/drawingml/2006/main" anchor="t">
-            <a:normAutofit fontScale="100000"/>
-          </a:bodyPr>
-          <a:lstStyle xmlns:a="http://schemas.openxmlformats.org/drawingml/2006/main"/>
-          <a:p xmlns:a="http://schemas.openxmlformats.org/drawingml/2006/main">
-            <a:pPr algn="l">
-              <a:buNone/>
-              <a:defRPr sz="3150" b="1">
-                <a:solidFill>
-                  <a:srgbClr val="111827"/>
-                </a:solidFill>
-                <a:latin typeface="PingFang SC"/>
-                <a:ea typeface="PingFang SC"/>
-                <a:cs typeface="PingFang SC"/>
-              </a:defRPr>
-            </a:pPr>
-            <a:r>
-              <a:rPr sz="3150" b="1">
-                <a:solidFill>
-                  <a:srgbClr val="111827"/>
-                </a:solidFill>
-                <a:latin typeface="PingFang SC"/>
-                <a:ea typeface="PingFang SC"/>
-                <a:cs typeface="PingFang SC"/>
-              </a:rPr>
-              <a:t>让外呼模型在上线前，先失败十次</a:t>
-            </a:r>
-          </a:p>
-        </p:txBody>
-      </p:sp>
-      <p:sp>
-        <p:nvSpPr>
-          <p:cNvPr id="3" name="title-rule">
-            <a:extLst xmlns:a="http://schemas.openxmlformats.org/drawingml/2006/main">
-              <a:ext uri="{FF2B5EF4-FFF2-40B4-BE49-F238E27FC236}">
-                <a16:creationId xmlns:a16="http://schemas.microsoft.com/office/drawing/2014/main" id="{7866D9FB-778F-4E38-BBD2-5560C320B2CA}"/>
-              </a:ext>
-            </a:extLst>
-          </p:cNvPr>
-          <p:cNvSpPr>
-            <a:spLocks xmlns:a="http://schemas.openxmlformats.org/drawingml/2006/main" noGrp="1"/>
-          </p:cNvSpPr>
-          <p:nvPr/>
-        </p:nvSpPr>
-        <p:spPr>
-          <a:xfrm xmlns:a="http://schemas.openxmlformats.org/drawingml/2006/main">
-            <a:off x="533400" y="1457325"/>
-            <a:ext cx="11125200" cy="19050"/>
-          </a:xfrm>
-          <a:prstGeom xmlns:a="http://schemas.openxmlformats.org/drawingml/2006/main" prst="rect">
-            <a:avLst/>
-          </a:prstGeom>
-          <a:solidFill xmlns:a="http://schemas.openxmlformats.org/drawingml/2006/main">
-            <a:srgbClr val="111827"/>
-          </a:solidFill>
-          <a:ln xmlns:a="http://schemas.openxmlformats.org/drawingml/2006/main" w="0">
-            <a:noFill/>
-            <a:prstDash val="solid"/>
-          </a:ln>
-        </p:spPr>
-      </p:sp>
-      <p:sp>
-        <p:nvSpPr>
-          <p:cNvPr id="4" name="page">
-            <a:extLst xmlns:a="http://schemas.openxmlformats.org/drawingml/2006/main">
-              <a:ext uri="{FF2B5EF4-FFF2-40B4-BE49-F238E27FC236}">
-                <a16:creationId xmlns:a16="http://schemas.microsoft.com/office/drawing/2014/main" id="{B9DC85EB-6A27-49A6-A6DB-FF60299953B8}"/>
-              </a:ext>
-            </a:extLst>
-          </p:cNvPr>
-          <p:cNvSpPr>
-            <a:spLocks xmlns:a="http://schemas.openxmlformats.org/drawingml/2006/main" noGrp="1"/>
-          </p:cNvSpPr>
-          <p:nvPr/>
-        </p:nvSpPr>
-        <p:spPr>
-          <a:xfrm xmlns:a="http://schemas.openxmlformats.org/drawingml/2006/main">
-            <a:off x="11144250" y="6381750"/>
-            <a:ext cx="514350" cy="209550"/>
-          </a:xfrm>
-          <a:prstGeom xmlns:a="http://schemas.openxmlformats.org/drawingml/2006/main" prst="rect">
-            <a:avLst/>
-          </a:prstGeom>
-          <a:noFill xmlns:a="http://schemas.openxmlformats.org/drawingml/2006/main"/>
-          <a:ln xmlns:a="http://schemas.openxmlformats.org/drawingml/2006/main" w="0">
-            <a:noFill/>
-            <a:prstDash val="solid"/>
-          </a:ln>
-        </p:spPr>
-        <p:txBody>
-          <a:bodyPr xmlns:a="http://schemas.openxmlformats.org/drawingml/2006/main" anchor="t">
-            <a:normAutofit fontScale="73809"/>
-          </a:bodyPr>
-          <a:lstStyle xmlns:a="http://schemas.openxmlformats.org/drawingml/2006/main"/>
-          <a:p xmlns:a="http://schemas.openxmlformats.org/drawingml/2006/main">
-            <a:pPr algn="r">
-              <a:buNone/>
-              <a:defRPr sz="1050" b="0">
-                <a:solidFill>
-                  <a:srgbClr val="667085"/>
-                </a:solidFill>
-                <a:latin typeface="PingFang SC"/>
-                <a:ea typeface="PingFang SC"/>
-                <a:cs typeface="PingFang SC"/>
-              </a:defRPr>
-            </a:pPr>
-            <a:r>
-              <a:rPr sz="1050" b="0">
-                <a:solidFill>
-                  <a:srgbClr val="667085"/>
-                </a:solidFill>
-                <a:latin typeface="PingFang SC"/>
-                <a:ea typeface="PingFang SC"/>
-                <a:cs typeface="PingFang SC"/>
-              </a:rPr>
-              <a:t>03</a:t>
-            </a:r>
-          </a:p>
-        </p:txBody>
-      </p:sp>
-      <p:sp>
-        <p:nvSpPr>
-          <p:cNvPr id="5" name="flow-line">
-            <a:extLst xmlns:a="http://schemas.openxmlformats.org/drawingml/2006/main">
-              <a:ext uri="{FF2B5EF4-FFF2-40B4-BE49-F238E27FC236}">
-                <a16:creationId xmlns:a16="http://schemas.microsoft.com/office/drawing/2014/main" id="{A7B0684F-3DE1-469F-B089-30FA9B47F2EB}"/>
-              </a:ext>
-            </a:extLst>
-          </p:cNvPr>
-          <p:cNvSpPr>
-            <a:spLocks xmlns:a="http://schemas.openxmlformats.org/drawingml/2006/main" noGrp="1"/>
-          </p:cNvSpPr>
-          <p:nvPr/>
-        </p:nvSpPr>
-        <p:spPr>
-          <a:xfrm xmlns:a="http://schemas.openxmlformats.org/drawingml/2006/main">
-            <a:off x="1981200" y="2428875"/>
-            <a:ext cx="7600950" cy="38100"/>
-          </a:xfrm>
-          <a:prstGeom xmlns:a="http://schemas.openxmlformats.org/drawingml/2006/main" prst="rect">
-            <a:avLst/>
-          </a:prstGeom>
-          <a:solidFill xmlns:a="http://schemas.openxmlformats.org/drawingml/2006/main">
-            <a:srgbClr val="C9CDD4"/>
-          </a:solidFill>
-          <a:ln xmlns:a="http://schemas.openxmlformats.org/drawingml/2006/main" w="0">
-            <a:noFill/>
-            <a:prstDash val="solid"/>
-          </a:ln>
-        </p:spPr>
-      </p:sp>
-      <p:sp>
-        <p:nvSpPr>
-          <p:cNvPr id="6" name="step-dot-0">
-            <a:extLst xmlns:a="http://schemas.openxmlformats.org/drawingml/2006/main">
-              <a:ext uri="{FF2B5EF4-FFF2-40B4-BE49-F238E27FC236}">
-                <a16:creationId xmlns:a16="http://schemas.microsoft.com/office/drawing/2014/main" id="{3727BDF2-CC2A-4F3C-AA91-4F0E6BFD84B8}"/>
-              </a:ext>
-            </a:extLst>
-          </p:cNvPr>
-          <p:cNvSpPr>
-            <a:spLocks xmlns:a="http://schemas.openxmlformats.org/drawingml/2006/main" noGrp="1"/>
-          </p:cNvSpPr>
-          <p:nvPr/>
-        </p:nvSpPr>
-        <p:spPr>
-          <a:xfrm xmlns:a="http://schemas.openxmlformats.org/drawingml/2006/main">
-            <a:off x="1666875" y="2133600"/>
-            <a:ext cx="628650" cy="628650"/>
-          </a:xfrm>
-          <a:prstGeom xmlns:a="http://schemas.openxmlformats.org/drawingml/2006/main" prst="roundRect">
-            <a:avLst>
-              <a:gd name="adj" fmla="val 18182"/>
-            </a:avLst>
-          </a:prstGeom>
-          <a:solidFill xmlns:a="http://schemas.openxmlformats.org/drawingml/2006/main">
-            <a:srgbClr val="111827"/>
-          </a:solidFill>
-          <a:ln xmlns:a="http://schemas.openxmlformats.org/drawingml/2006/main" w="0">
-            <a:noFill/>
-            <a:prstDash val="solid"/>
-          </a:ln>
-        </p:spPr>
-      </p:sp>
-      <p:sp>
-        <p:nvSpPr>
-          <p:cNvPr id="7" name="step-n-0">
-            <a:extLst xmlns:a="http://schemas.openxmlformats.org/drawingml/2006/main">
-              <a:ext uri="{FF2B5EF4-FFF2-40B4-BE49-F238E27FC236}">
-                <a16:creationId xmlns:a16="http://schemas.microsoft.com/office/drawing/2014/main" id="{20F518E8-7FC6-4EAD-A44E-6E969E72B027}"/>
-              </a:ext>
-            </a:extLst>
-          </p:cNvPr>
-          <p:cNvSpPr>
-            <a:spLocks xmlns:a="http://schemas.openxmlformats.org/drawingml/2006/main" noGrp="1"/>
-          </p:cNvSpPr>
-          <p:nvPr/>
-        </p:nvSpPr>
-        <p:spPr>
-          <a:xfrm xmlns:a="http://schemas.openxmlformats.org/drawingml/2006/main">
-            <a:off x="1666875" y="2190750"/>
-            <a:ext cx="628650" cy="495300"/>
-          </a:xfrm>
-          <a:prstGeom xmlns:a="http://schemas.openxmlformats.org/drawingml/2006/main" prst="rect">
-            <a:avLst/>
-          </a:prstGeom>
-          <a:noFill xmlns:a="http://schemas.openxmlformats.org/drawingml/2006/main"/>
-          <a:ln xmlns:a="http://schemas.openxmlformats.org/drawingml/2006/main" w="0">
-            <a:noFill/>
-            <a:prstDash val="solid"/>
-          </a:ln>
-        </p:spPr>
-        <p:txBody>
-          <a:bodyPr xmlns:a="http://schemas.openxmlformats.org/drawingml/2006/main" anchor="ctr">
-            <a:normAutofit fontScale="100000"/>
-          </a:bodyPr>
-          <a:lstStyle xmlns:a="http://schemas.openxmlformats.org/drawingml/2006/main"/>
-          <a:p xmlns:a="http://schemas.openxmlformats.org/drawingml/2006/main">
-            <a:pPr algn="ctr">
-              <a:buNone/>
-              <a:defRPr sz="2025" b="1">
-                <a:solidFill>
-                  <a:srgbClr val="FFFFFF"/>
-                </a:solidFill>
-                <a:latin typeface="PingFang SC"/>
-                <a:ea typeface="PingFang SC"/>
-                <a:cs typeface="PingFang SC"/>
-              </a:defRPr>
-            </a:pPr>
-            <a:r>
-              <a:rPr sz="2025" b="1">
-                <a:solidFill>
-                  <a:srgbClr val="FFFFFF"/>
-                </a:solidFill>
-                <a:latin typeface="PingFang SC"/>
-                <a:ea typeface="PingFang SC"/>
-                <a:cs typeface="PingFang SC"/>
-              </a:rPr>
-              <a:t>1</a:t>
-            </a:r>
-          </a:p>
-        </p:txBody>
-      </p:sp>
-      <p:sp>
-        <p:nvSpPr>
-          <p:cNvPr id="8" name="step-title-0">
-            <a:extLst xmlns:a="http://schemas.openxmlformats.org/drawingml/2006/main">
-              <a:ext uri="{FF2B5EF4-FFF2-40B4-BE49-F238E27FC236}">
-                <a16:creationId xmlns:a16="http://schemas.microsoft.com/office/drawing/2014/main" id="{51765322-5A09-483C-A66A-C4834132A815}"/>
-              </a:ext>
-            </a:extLst>
-          </p:cNvPr>
-          <p:cNvSpPr>
-            <a:spLocks xmlns:a="http://schemas.openxmlformats.org/drawingml/2006/main" noGrp="1"/>
-          </p:cNvSpPr>
-          <p:nvPr/>
-        </p:nvSpPr>
-        <p:spPr>
-          <a:xfrm xmlns:a="http://schemas.openxmlformats.org/drawingml/2006/main">
-            <a:off x="838200" y="2895600"/>
-            <a:ext cx="2286000" cy="361950"/>
-          </a:xfrm>
-          <a:prstGeom xmlns:a="http://schemas.openxmlformats.org/drawingml/2006/main" prst="rect">
-            <a:avLst/>
-          </a:prstGeom>
-          <a:noFill xmlns:a="http://schemas.openxmlformats.org/drawingml/2006/main"/>
-          <a:ln xmlns:a="http://schemas.openxmlformats.org/drawingml/2006/main" w="0">
-            <a:noFill/>
-            <a:prstDash val="solid"/>
-          </a:ln>
-        </p:spPr>
-        <p:txBody>
-          <a:bodyPr xmlns:a="http://schemas.openxmlformats.org/drawingml/2006/main" anchor="t">
-            <a:normAutofit fontScale="91026"/>
-          </a:bodyPr>
-          <a:lstStyle xmlns:a="http://schemas.openxmlformats.org/drawingml/2006/main"/>
-          <a:p xmlns:a="http://schemas.openxmlformats.org/drawingml/2006/main">
-            <a:pPr algn="ctr">
-              <a:buNone/>
-              <a:defRPr sz="1950" b="1">
-                <a:solidFill>
-                  <a:srgbClr val="111827"/>
-                </a:solidFill>
-                <a:latin typeface="PingFang SC"/>
-                <a:ea typeface="PingFang SC"/>
-                <a:cs typeface="PingFang SC"/>
-              </a:defRPr>
-            </a:pPr>
-            <a:r>
-              <a:rPr sz="1950" b="1">
-                <a:solidFill>
-                  <a:srgbClr val="111827"/>
-                </a:solidFill>
-                <a:latin typeface="PingFang SC"/>
-                <a:ea typeface="PingFang SC"/>
-                <a:cs typeface="PingFang SC"/>
-              </a:rPr>
-              <a:t>冻结测试任务</a:t>
-            </a:r>
-          </a:p>
-        </p:txBody>
-      </p:sp>
-      <p:sp>
-        <p:nvSpPr>
-          <p:cNvPr id="9" name="step-body-0">
-            <a:extLst xmlns:a="http://schemas.openxmlformats.org/drawingml/2006/main">
-              <a:ext uri="{FF2B5EF4-FFF2-40B4-BE49-F238E27FC236}">
-                <a16:creationId xmlns:a16="http://schemas.microsoft.com/office/drawing/2014/main" id="{81D68444-C300-41DA-957D-0CADF615BB22}"/>
-              </a:ext>
-            </a:extLst>
-          </p:cNvPr>
-          <p:cNvSpPr>
-            <a:spLocks xmlns:a="http://schemas.openxmlformats.org/drawingml/2006/main" noGrp="1"/>
-          </p:cNvSpPr>
-          <p:nvPr/>
-        </p:nvSpPr>
-        <p:spPr>
-          <a:xfrm xmlns:a="http://schemas.openxmlformats.org/drawingml/2006/main">
-            <a:off x="742950" y="3314700"/>
-            <a:ext cx="2476500" cy="400050"/>
-          </a:xfrm>
-          <a:prstGeom xmlns:a="http://schemas.openxmlformats.org/drawingml/2006/main" prst="rect">
-            <a:avLst/>
-          </a:prstGeom>
-          <a:noFill xmlns:a="http://schemas.openxmlformats.org/drawingml/2006/main"/>
-          <a:ln xmlns:a="http://schemas.openxmlformats.org/drawingml/2006/main" w="0">
-            <a:noFill/>
-            <a:prstDash val="solid"/>
-          </a:ln>
-        </p:spPr>
-        <p:txBody>
-          <a:bodyPr xmlns:a="http://schemas.openxmlformats.org/drawingml/2006/main" anchor="t">
-            <a:normAutofit fontScale="100000"/>
-          </a:bodyPr>
-          <a:lstStyle xmlns:a="http://schemas.openxmlformats.org/drawingml/2006/main"/>
-          <a:p xmlns:a="http://schemas.openxmlformats.org/drawingml/2006/main">
-            <a:pPr algn="ctr">
-              <a:buNone/>
-              <a:defRPr sz="1350" b="0">
-                <a:solidFill>
-                  <a:srgbClr val="667085"/>
-                </a:solidFill>
-                <a:latin typeface="PingFang SC"/>
-                <a:ea typeface="PingFang SC"/>
-                <a:cs typeface="PingFang SC"/>
-              </a:defRPr>
-            </a:pPr>
-            <a:r>
-              <a:rPr sz="1350" b="0">
-                <a:solidFill>
-                  <a:srgbClr val="667085"/>
-                </a:solidFill>
-                <a:latin typeface="PingFang SC"/>
-                <a:ea typeface="PingFang SC"/>
-                <a:cs typeface="PingFang SC"/>
-              </a:rPr>
-              <a:t>模型 / 输入 / SOP / hash</a:t>
-            </a:r>
-          </a:p>
-        </p:txBody>
-      </p:sp>
-      <p:sp>
-        <p:nvSpPr>
-          <p:cNvPr id="10" name="step-dot-1">
-            <a:extLst xmlns:a="http://schemas.openxmlformats.org/drawingml/2006/main">
-              <a:ext uri="{FF2B5EF4-FFF2-40B4-BE49-F238E27FC236}">
-                <a16:creationId xmlns:a16="http://schemas.microsoft.com/office/drawing/2014/main" id="{C1DF2A64-EBDD-4012-8140-CB091C1FE385}"/>
-              </a:ext>
-            </a:extLst>
-          </p:cNvPr>
-          <p:cNvSpPr>
-            <a:spLocks xmlns:a="http://schemas.openxmlformats.org/drawingml/2006/main" noGrp="1"/>
-          </p:cNvSpPr>
-          <p:nvPr/>
-        </p:nvSpPr>
-        <p:spPr>
-          <a:xfrm xmlns:a="http://schemas.openxmlformats.org/drawingml/2006/main">
-            <a:off x="5467350" y="2133600"/>
-            <a:ext cx="628650" cy="628650"/>
-          </a:xfrm>
-          <a:prstGeom xmlns:a="http://schemas.openxmlformats.org/drawingml/2006/main" prst="roundRect">
-            <a:avLst>
-              <a:gd name="adj" fmla="val 18182"/>
-            </a:avLst>
-          </a:prstGeom>
-          <a:solidFill xmlns:a="http://schemas.openxmlformats.org/drawingml/2006/main">
-            <a:srgbClr val="111827"/>
-          </a:solidFill>
-          <a:ln xmlns:a="http://schemas.openxmlformats.org/drawingml/2006/main" w="0">
-            <a:noFill/>
-            <a:prstDash val="solid"/>
-          </a:ln>
-        </p:spPr>
-      </p:sp>
-      <p:sp>
-        <p:nvSpPr>
-          <p:cNvPr id="11" name="step-n-1">
-            <a:extLst xmlns:a="http://schemas.openxmlformats.org/drawingml/2006/main">
-              <a:ext uri="{FF2B5EF4-FFF2-40B4-BE49-F238E27FC236}">
-                <a16:creationId xmlns:a16="http://schemas.microsoft.com/office/drawing/2014/main" id="{9020754C-4655-4B67-93A1-D6945B1572E0}"/>
-              </a:ext>
-            </a:extLst>
-          </p:cNvPr>
-          <p:cNvSpPr>
-            <a:spLocks xmlns:a="http://schemas.openxmlformats.org/drawingml/2006/main" noGrp="1"/>
-          </p:cNvSpPr>
-          <p:nvPr/>
-        </p:nvSpPr>
-        <p:spPr>
-          <a:xfrm xmlns:a="http://schemas.openxmlformats.org/drawingml/2006/main">
-            <a:off x="5467350" y="2190750"/>
-            <a:ext cx="628650" cy="495300"/>
-          </a:xfrm>
-          <a:prstGeom xmlns:a="http://schemas.openxmlformats.org/drawingml/2006/main" prst="rect">
-            <a:avLst/>
-          </a:prstGeom>
-          <a:noFill xmlns:a="http://schemas.openxmlformats.org/drawingml/2006/main"/>
-          <a:ln xmlns:a="http://schemas.openxmlformats.org/drawingml/2006/main" w="0">
-            <a:noFill/>
-            <a:prstDash val="solid"/>
-          </a:ln>
-        </p:spPr>
-        <p:txBody>
-          <a:bodyPr xmlns:a="http://schemas.openxmlformats.org/drawingml/2006/main" anchor="ctr">
-            <a:normAutofit fontScale="100000"/>
-          </a:bodyPr>
-          <a:lstStyle xmlns:a="http://schemas.openxmlformats.org/drawingml/2006/main"/>
-          <a:p xmlns:a="http://schemas.openxmlformats.org/drawingml/2006/main">
-            <a:pPr algn="ctr">
-              <a:buNone/>
-              <a:defRPr sz="2025" b="1">
-                <a:solidFill>
-                  <a:srgbClr val="FFFFFF"/>
-                </a:solidFill>
-                <a:latin typeface="PingFang SC"/>
-                <a:ea typeface="PingFang SC"/>
-                <a:cs typeface="PingFang SC"/>
-              </a:defRPr>
-            </a:pPr>
-            <a:r>
-              <a:rPr sz="2025" b="1">
-                <a:solidFill>
-                  <a:srgbClr val="FFFFFF"/>
-                </a:solidFill>
-                <a:latin typeface="PingFang SC"/>
-                <a:ea typeface="PingFang SC"/>
-                <a:cs typeface="PingFang SC"/>
-              </a:rPr>
-              <a:t>2</a:t>
-            </a:r>
-          </a:p>
-        </p:txBody>
-      </p:sp>
-      <p:sp>
-        <p:nvSpPr>
-          <p:cNvPr id="12" name="step-title-1">
-            <a:extLst xmlns:a="http://schemas.openxmlformats.org/drawingml/2006/main">
-              <a:ext uri="{FF2B5EF4-FFF2-40B4-BE49-F238E27FC236}">
-                <a16:creationId xmlns:a16="http://schemas.microsoft.com/office/drawing/2014/main" id="{42C15ABA-AF5B-4574-A693-1AE5E7C682AD}"/>
-              </a:ext>
-            </a:extLst>
-          </p:cNvPr>
-          <p:cNvSpPr>
-            <a:spLocks xmlns:a="http://schemas.openxmlformats.org/drawingml/2006/main" noGrp="1"/>
-          </p:cNvSpPr>
-          <p:nvPr/>
-        </p:nvSpPr>
-        <p:spPr>
-          <a:xfrm xmlns:a="http://schemas.openxmlformats.org/drawingml/2006/main">
-            <a:off x="4638675" y="2895600"/>
-            <a:ext cx="2286000" cy="361950"/>
-          </a:xfrm>
-          <a:prstGeom xmlns:a="http://schemas.openxmlformats.org/drawingml/2006/main" prst="rect">
-            <a:avLst/>
-          </a:prstGeom>
-          <a:noFill xmlns:a="http://schemas.openxmlformats.org/drawingml/2006/main"/>
-          <a:ln xmlns:a="http://schemas.openxmlformats.org/drawingml/2006/main" w="0">
-            <a:noFill/>
-            <a:prstDash val="solid"/>
-          </a:ln>
-        </p:spPr>
-        <p:txBody>
-          <a:bodyPr xmlns:a="http://schemas.openxmlformats.org/drawingml/2006/main" anchor="t">
-            <a:normAutofit fontScale="91026"/>
-          </a:bodyPr>
-          <a:lstStyle xmlns:a="http://schemas.openxmlformats.org/drawingml/2006/main"/>
-          <a:p xmlns:a="http://schemas.openxmlformats.org/drawingml/2006/main">
-            <a:pPr algn="ctr">
-              <a:buNone/>
-              <a:defRPr sz="1950" b="1">
-                <a:solidFill>
-                  <a:srgbClr val="111827"/>
-                </a:solidFill>
-                <a:latin typeface="PingFang SC"/>
-                <a:ea typeface="PingFang SC"/>
-                <a:cs typeface="PingFang SC"/>
-              </a:defRPr>
-            </a:pPr>
-            <a:r>
-              <a:rPr sz="1950" b="1">
-                <a:solidFill>
-                  <a:srgbClr val="111827"/>
-                </a:solidFill>
-                <a:latin typeface="PingFang SC"/>
-                <a:ea typeface="PingFang SC"/>
-                <a:cs typeface="PingFang SC"/>
-              </a:rPr>
-              <a:t>编译评分合同</a:t>
-            </a:r>
-          </a:p>
-        </p:txBody>
-      </p:sp>
-      <p:sp>
-        <p:nvSpPr>
-          <p:cNvPr id="13" name="step-body-1">
-            <a:extLst xmlns:a="http://schemas.openxmlformats.org/drawingml/2006/main">
-              <a:ext uri="{FF2B5EF4-FFF2-40B4-BE49-F238E27FC236}">
-                <a16:creationId xmlns:a16="http://schemas.microsoft.com/office/drawing/2014/main" id="{CC81D6D1-3A42-4375-A2DB-05B84F35605D}"/>
-              </a:ext>
-            </a:extLst>
-          </p:cNvPr>
-          <p:cNvSpPr>
-            <a:spLocks xmlns:a="http://schemas.openxmlformats.org/drawingml/2006/main" noGrp="1"/>
-          </p:cNvSpPr>
-          <p:nvPr/>
-        </p:nvSpPr>
-        <p:spPr>
-          <a:xfrm xmlns:a="http://schemas.openxmlformats.org/drawingml/2006/main">
-            <a:off x="4543425" y="3314700"/>
-            <a:ext cx="2476500" cy="400050"/>
-          </a:xfrm>
-          <a:prstGeom xmlns:a="http://schemas.openxmlformats.org/drawingml/2006/main" prst="rect">
-            <a:avLst/>
-          </a:prstGeom>
-          <a:noFill xmlns:a="http://schemas.openxmlformats.org/drawingml/2006/main"/>
-          <a:ln xmlns:a="http://schemas.openxmlformats.org/drawingml/2006/main" w="0">
-            <a:noFill/>
-            <a:prstDash val="solid"/>
-          </a:ln>
-        </p:spPr>
-        <p:txBody>
-          <a:bodyPr xmlns:a="http://schemas.openxmlformats.org/drawingml/2006/main" anchor="t">
-            <a:normAutofit fontScale="100000"/>
-          </a:bodyPr>
-          <a:lstStyle xmlns:a="http://schemas.openxmlformats.org/drawingml/2006/main"/>
-          <a:p xmlns:a="http://schemas.openxmlformats.org/drawingml/2006/main">
-            <a:pPr algn="ctr">
-              <a:buNone/>
-              <a:defRPr sz="1350" b="0">
-                <a:solidFill>
-                  <a:srgbClr val="667085"/>
-                </a:solidFill>
-                <a:latin typeface="PingFang SC"/>
-                <a:ea typeface="PingFang SC"/>
-                <a:cs typeface="PingFang SC"/>
-              </a:defRPr>
-            </a:pPr>
-            <a:r>
-              <a:rPr sz="1350" b="0">
-                <a:solidFill>
-                  <a:srgbClr val="667085"/>
-                </a:solidFill>
-                <a:latin typeface="PingFang SC"/>
-                <a:ea typeface="PingFang SC"/>
-                <a:cs typeface="PingFang SC"/>
-              </a:rPr>
-              <a:t>L0 安全 + L1 业务</a:t>
-            </a:r>
-          </a:p>
-        </p:txBody>
-      </p:sp>
-      <p:sp>
-        <p:nvSpPr>
-          <p:cNvPr id="14" name="step-dot-2">
-            <a:extLst xmlns:a="http://schemas.openxmlformats.org/drawingml/2006/main">
-              <a:ext uri="{FF2B5EF4-FFF2-40B4-BE49-F238E27FC236}">
-                <a16:creationId xmlns:a16="http://schemas.microsoft.com/office/drawing/2014/main" id="{8B21AB0A-0540-4BED-B85C-74B3C3C57000}"/>
-              </a:ext>
-            </a:extLst>
-          </p:cNvPr>
-          <p:cNvSpPr>
-            <a:spLocks xmlns:a="http://schemas.openxmlformats.org/drawingml/2006/main" noGrp="1"/>
-          </p:cNvSpPr>
-          <p:nvPr/>
-        </p:nvSpPr>
-        <p:spPr>
-          <a:xfrm xmlns:a="http://schemas.openxmlformats.org/drawingml/2006/main">
-            <a:off x="9267825" y="2133600"/>
-            <a:ext cx="628650" cy="628650"/>
-          </a:xfrm>
-          <a:prstGeom xmlns:a="http://schemas.openxmlformats.org/drawingml/2006/main" prst="roundRect">
-            <a:avLst>
-              <a:gd name="adj" fmla="val 18182"/>
-            </a:avLst>
-          </a:prstGeom>
-          <a:solidFill xmlns:a="http://schemas.openxmlformats.org/drawingml/2006/main">
-            <a:srgbClr val="111827"/>
-          </a:solidFill>
-          <a:ln xmlns:a="http://schemas.openxmlformats.org/drawingml/2006/main" w="0">
-            <a:noFill/>
-            <a:prstDash val="solid"/>
-          </a:ln>
-        </p:spPr>
-      </p:sp>
-      <p:sp>
-        <p:nvSpPr>
-          <p:cNvPr id="15" name="step-n-2">
-            <a:extLst xmlns:a="http://schemas.openxmlformats.org/drawingml/2006/main">
-              <a:ext uri="{FF2B5EF4-FFF2-40B4-BE49-F238E27FC236}">
-                <a16:creationId xmlns:a16="http://schemas.microsoft.com/office/drawing/2014/main" id="{BE7D4578-4A77-4ECD-A191-6C6D7285889F}"/>
-              </a:ext>
-            </a:extLst>
-          </p:cNvPr>
-          <p:cNvSpPr>
-            <a:spLocks xmlns:a="http://schemas.openxmlformats.org/drawingml/2006/main" noGrp="1"/>
-          </p:cNvSpPr>
-          <p:nvPr/>
-        </p:nvSpPr>
-        <p:spPr>
-          <a:xfrm xmlns:a="http://schemas.openxmlformats.org/drawingml/2006/main">
-            <a:off x="9267825" y="2190750"/>
-            <a:ext cx="628650" cy="495300"/>
-          </a:xfrm>
-          <a:prstGeom xmlns:a="http://schemas.openxmlformats.org/drawingml/2006/main" prst="rect">
-            <a:avLst/>
-          </a:prstGeom>
-          <a:noFill xmlns:a="http://schemas.openxmlformats.org/drawingml/2006/main"/>
-          <a:ln xmlns:a="http://schemas.openxmlformats.org/drawingml/2006/main" w="0">
-            <a:noFill/>
-            <a:prstDash val="solid"/>
-          </a:ln>
-        </p:spPr>
-        <p:txBody>
-          <a:bodyPr xmlns:a="http://schemas.openxmlformats.org/drawingml/2006/main" anchor="ctr">
-            <a:normAutofit fontScale="100000"/>
-          </a:bodyPr>
-          <a:lstStyle xmlns:a="http://schemas.openxmlformats.org/drawingml/2006/main"/>
-          <a:p xmlns:a="http://schemas.openxmlformats.org/drawingml/2006/main">
-            <a:pPr algn="ctr">
-              <a:buNone/>
-              <a:defRPr sz="2025" b="1">
-                <a:solidFill>
-                  <a:srgbClr val="FFFFFF"/>
-                </a:solidFill>
-                <a:latin typeface="PingFang SC"/>
-                <a:ea typeface="PingFang SC"/>
-                <a:cs typeface="PingFang SC"/>
-              </a:defRPr>
-            </a:pPr>
-            <a:r>
-              <a:rPr sz="2025" b="1">
-                <a:solidFill>
-                  <a:srgbClr val="FFFFFF"/>
-                </a:solidFill>
-                <a:latin typeface="PingFang SC"/>
-                <a:ea typeface="PingFang SC"/>
-                <a:cs typeface="PingFang SC"/>
-              </a:rPr>
-              <a:t>3</a:t>
-            </a:r>
-          </a:p>
-        </p:txBody>
-      </p:sp>
-      <p:sp>
-        <p:nvSpPr>
-          <p:cNvPr id="16" name="step-title-2">
-            <a:extLst xmlns:a="http://schemas.openxmlformats.org/drawingml/2006/main">
-              <a:ext uri="{FF2B5EF4-FFF2-40B4-BE49-F238E27FC236}">
-                <a16:creationId xmlns:a16="http://schemas.microsoft.com/office/drawing/2014/main" id="{B5412980-B5B8-41C5-BBC7-CC881B86EDE9}"/>
-              </a:ext>
-            </a:extLst>
-          </p:cNvPr>
-          <p:cNvSpPr>
-            <a:spLocks xmlns:a="http://schemas.openxmlformats.org/drawingml/2006/main" noGrp="1"/>
-          </p:cNvSpPr>
-          <p:nvPr/>
-        </p:nvSpPr>
-        <p:spPr>
-          <a:xfrm xmlns:a="http://schemas.openxmlformats.org/drawingml/2006/main">
-            <a:off x="8439150" y="2895600"/>
-            <a:ext cx="2286000" cy="361950"/>
-          </a:xfrm>
-          <a:prstGeom xmlns:a="http://schemas.openxmlformats.org/drawingml/2006/main" prst="rect">
-            <a:avLst/>
-          </a:prstGeom>
-          <a:noFill xmlns:a="http://schemas.openxmlformats.org/drawingml/2006/main"/>
-          <a:ln xmlns:a="http://schemas.openxmlformats.org/drawingml/2006/main" w="0">
-            <a:noFill/>
-            <a:prstDash val="solid"/>
-          </a:ln>
-        </p:spPr>
-        <p:txBody>
-          <a:bodyPr xmlns:a="http://schemas.openxmlformats.org/drawingml/2006/main" anchor="t">
-            <a:normAutofit fontScale="91026"/>
-          </a:bodyPr>
-          <a:lstStyle xmlns:a="http://schemas.openxmlformats.org/drawingml/2006/main"/>
-          <a:p xmlns:a="http://schemas.openxmlformats.org/drawingml/2006/main">
-            <a:pPr algn="ctr">
-              <a:buNone/>
-              <a:defRPr sz="1950" b="1">
-                <a:solidFill>
-                  <a:srgbClr val="111827"/>
-                </a:solidFill>
-                <a:latin typeface="PingFang SC"/>
-                <a:ea typeface="PingFang SC"/>
-                <a:cs typeface="PingFang SC"/>
-              </a:defRPr>
-            </a:pPr>
-            <a:r>
-              <a:rPr sz="1950" b="1">
-                <a:solidFill>
-                  <a:srgbClr val="111827"/>
-                </a:solidFill>
-                <a:latin typeface="PingFang SC"/>
-                <a:ea typeface="PingFang SC"/>
-                <a:cs typeface="PingFang SC"/>
-              </a:rPr>
-              <a:t>主动测试模型</a:t>
-            </a:r>
-          </a:p>
-        </p:txBody>
-      </p:sp>
-      <p:sp>
-        <p:nvSpPr>
-          <p:cNvPr id="17" name="step-body-2">
-            <a:extLst xmlns:a="http://schemas.openxmlformats.org/drawingml/2006/main">
-              <a:ext uri="{FF2B5EF4-FFF2-40B4-BE49-F238E27FC236}">
-                <a16:creationId xmlns:a16="http://schemas.microsoft.com/office/drawing/2014/main" id="{0472E68F-8D8B-4A37-AF40-5384BD04277E}"/>
-              </a:ext>
-            </a:extLst>
-          </p:cNvPr>
-          <p:cNvSpPr>
-            <a:spLocks xmlns:a="http://schemas.openxmlformats.org/drawingml/2006/main" noGrp="1"/>
-          </p:cNvSpPr>
-          <p:nvPr/>
-        </p:nvSpPr>
-        <p:spPr>
-          <a:xfrm xmlns:a="http://schemas.openxmlformats.org/drawingml/2006/main">
-            <a:off x="8343900" y="3314700"/>
-            <a:ext cx="2476500" cy="400050"/>
-          </a:xfrm>
-          <a:prstGeom xmlns:a="http://schemas.openxmlformats.org/drawingml/2006/main" prst="rect">
-            <a:avLst/>
-          </a:prstGeom>
-          <a:noFill xmlns:a="http://schemas.openxmlformats.org/drawingml/2006/main"/>
-          <a:ln xmlns:a="http://schemas.openxmlformats.org/drawingml/2006/main" w="0">
-            <a:noFill/>
-            <a:prstDash val="solid"/>
-          </a:ln>
-        </p:spPr>
-        <p:txBody>
-          <a:bodyPr xmlns:a="http://schemas.openxmlformats.org/drawingml/2006/main" anchor="t">
-            <a:normAutofit fontScale="100000"/>
-          </a:bodyPr>
-          <a:lstStyle xmlns:a="http://schemas.openxmlformats.org/drawingml/2006/main"/>
-          <a:p xmlns:a="http://schemas.openxmlformats.org/drawingml/2006/main">
-            <a:pPr algn="ctr">
-              <a:buNone/>
-              <a:defRPr sz="1350" b="0">
-                <a:solidFill>
-                  <a:srgbClr val="667085"/>
-                </a:solidFill>
-                <a:latin typeface="PingFang SC"/>
-                <a:ea typeface="PingFang SC"/>
-                <a:cs typeface="PingFang SC"/>
-              </a:defRPr>
-            </a:pPr>
-            <a:r>
-              <a:rPr sz="1350" b="0">
-                <a:solidFill>
-                  <a:srgbClr val="667085"/>
-                </a:solidFill>
-                <a:latin typeface="PingFang SC"/>
-                <a:ea typeface="PingFang SC"/>
-                <a:cs typeface="PingFang SC"/>
-              </a:rPr>
-              <a:t>Persona × 对抗分支</a:t>
-            </a:r>
-          </a:p>
-        </p:txBody>
-      </p:sp>
-      <p:sp>
-        <p:nvSpPr>
-          <p:cNvPr id="18" name="step-dot-3">
-            <a:extLst xmlns:a="http://schemas.openxmlformats.org/drawingml/2006/main">
-              <a:ext uri="{FF2B5EF4-FFF2-40B4-BE49-F238E27FC236}">
-                <a16:creationId xmlns:a16="http://schemas.microsoft.com/office/drawing/2014/main" id="{4F4ED39A-5F4D-4827-A0E0-05B192C4F398}"/>
-              </a:ext>
-            </a:extLst>
-          </p:cNvPr>
-          <p:cNvSpPr>
-            <a:spLocks xmlns:a="http://schemas.openxmlformats.org/drawingml/2006/main" noGrp="1"/>
-          </p:cNvSpPr>
-          <p:nvPr/>
-        </p:nvSpPr>
-        <p:spPr>
-          <a:xfrm xmlns:a="http://schemas.openxmlformats.org/drawingml/2006/main">
-            <a:off x="1666875" y="4095750"/>
-            <a:ext cx="628650" cy="628650"/>
-          </a:xfrm>
-          <a:prstGeom xmlns:a="http://schemas.openxmlformats.org/drawingml/2006/main" prst="roundRect">
-            <a:avLst>
-              <a:gd name="adj" fmla="val 18182"/>
-            </a:avLst>
-          </a:prstGeom>
-          <a:solidFill xmlns:a="http://schemas.openxmlformats.org/drawingml/2006/main">
-            <a:srgbClr val="FFD100"/>
-          </a:solidFill>
-          <a:ln xmlns:a="http://schemas.openxmlformats.org/drawingml/2006/main" w="0">
-            <a:noFill/>
-            <a:prstDash val="solid"/>
-          </a:ln>
-        </p:spPr>
-      </p:sp>
-      <p:sp>
-        <p:nvSpPr>
-          <p:cNvPr id="19" name="step-n-3">
-            <a:extLst xmlns:a="http://schemas.openxmlformats.org/drawingml/2006/main">
-              <a:ext uri="{FF2B5EF4-FFF2-40B4-BE49-F238E27FC236}">
-                <a16:creationId xmlns:a16="http://schemas.microsoft.com/office/drawing/2014/main" id="{F52B6353-AD90-4D20-ADD2-6BAE145C2618}"/>
-              </a:ext>
-            </a:extLst>
-          </p:cNvPr>
-          <p:cNvSpPr>
-            <a:spLocks xmlns:a="http://schemas.openxmlformats.org/drawingml/2006/main" noGrp="1"/>
-          </p:cNvSpPr>
-          <p:nvPr/>
-        </p:nvSpPr>
-        <p:spPr>
-          <a:xfrm xmlns:a="http://schemas.openxmlformats.org/drawingml/2006/main">
-            <a:off x="1666875" y="4152900"/>
-            <a:ext cx="628650" cy="495300"/>
-          </a:xfrm>
-          <a:prstGeom xmlns:a="http://schemas.openxmlformats.org/drawingml/2006/main" prst="rect">
-            <a:avLst/>
-          </a:prstGeom>
-          <a:noFill xmlns:a="http://schemas.openxmlformats.org/drawingml/2006/main"/>
-          <a:ln xmlns:a="http://schemas.openxmlformats.org/drawingml/2006/main" w="0">
-            <a:noFill/>
-            <a:prstDash val="solid"/>
-          </a:ln>
-        </p:spPr>
-        <p:txBody>
-          <a:bodyPr xmlns:a="http://schemas.openxmlformats.org/drawingml/2006/main" anchor="ctr">
-            <a:normAutofit fontScale="100000"/>
-          </a:bodyPr>
-          <a:lstStyle xmlns:a="http://schemas.openxmlformats.org/drawingml/2006/main"/>
-          <a:p xmlns:a="http://schemas.openxmlformats.org/drawingml/2006/main">
-            <a:pPr algn="ctr">
-              <a:buNone/>
-              <a:defRPr sz="2025" b="1">
-                <a:solidFill>
-                  <a:srgbClr val="111827"/>
-                </a:solidFill>
-                <a:latin typeface="PingFang SC"/>
-                <a:ea typeface="PingFang SC"/>
-                <a:cs typeface="PingFang SC"/>
-              </a:defRPr>
-            </a:pPr>
-            <a:r>
-              <a:rPr sz="2025" b="1">
-                <a:solidFill>
-                  <a:srgbClr val="111827"/>
-                </a:solidFill>
-                <a:latin typeface="PingFang SC"/>
-                <a:ea typeface="PingFang SC"/>
-                <a:cs typeface="PingFang SC"/>
-              </a:rPr>
-              <a:t>4</a:t>
-            </a:r>
-          </a:p>
-        </p:txBody>
-      </p:sp>
-      <p:sp>
-        <p:nvSpPr>
-          <p:cNvPr id="20" name="step-title-3">
-            <a:extLst xmlns:a="http://schemas.openxmlformats.org/drawingml/2006/main">
-              <a:ext uri="{FF2B5EF4-FFF2-40B4-BE49-F238E27FC236}">
-                <a16:creationId xmlns:a16="http://schemas.microsoft.com/office/drawing/2014/main" id="{D97F5F26-12C6-452C-A2DF-1949CF7AFA1D}"/>
-              </a:ext>
-            </a:extLst>
-          </p:cNvPr>
-          <p:cNvSpPr>
-            <a:spLocks xmlns:a="http://schemas.openxmlformats.org/drawingml/2006/main" noGrp="1"/>
-          </p:cNvSpPr>
-          <p:nvPr/>
-        </p:nvSpPr>
-        <p:spPr>
-          <a:xfrm xmlns:a="http://schemas.openxmlformats.org/drawingml/2006/main">
-            <a:off x="838200" y="4857750"/>
-            <a:ext cx="2286000" cy="361950"/>
-          </a:xfrm>
-          <a:prstGeom xmlns:a="http://schemas.openxmlformats.org/drawingml/2006/main" prst="rect">
-            <a:avLst/>
-          </a:prstGeom>
-          <a:noFill xmlns:a="http://schemas.openxmlformats.org/drawingml/2006/main"/>
-          <a:ln xmlns:a="http://schemas.openxmlformats.org/drawingml/2006/main" w="0">
-            <a:noFill/>
-            <a:prstDash val="solid"/>
-          </a:ln>
-        </p:spPr>
-        <p:txBody>
-          <a:bodyPr xmlns:a="http://schemas.openxmlformats.org/drawingml/2006/main" anchor="t">
-            <a:normAutofit fontScale="91026"/>
-          </a:bodyPr>
-          <a:lstStyle xmlns:a="http://schemas.openxmlformats.org/drawingml/2006/main"/>
-          <a:p xmlns:a="http://schemas.openxmlformats.org/drawingml/2006/main">
-            <a:pPr algn="ctr">
-              <a:buNone/>
-              <a:defRPr sz="1950" b="1">
-                <a:solidFill>
-                  <a:srgbClr val="111827"/>
-                </a:solidFill>
-                <a:latin typeface="PingFang SC"/>
-                <a:ea typeface="PingFang SC"/>
-                <a:cs typeface="PingFang SC"/>
-              </a:defRPr>
-            </a:pPr>
-            <a:r>
-              <a:rPr sz="1950" b="1">
-                <a:solidFill>
-                  <a:srgbClr val="111827"/>
-                </a:solidFill>
-                <a:latin typeface="PingFang SC"/>
-                <a:ea typeface="PingFang SC"/>
-                <a:cs typeface="PingFang SC"/>
-              </a:rPr>
-              <a:t>决定是否上线</a:t>
-            </a:r>
-          </a:p>
-        </p:txBody>
-      </p:sp>
-      <p:sp>
-        <p:nvSpPr>
-          <p:cNvPr id="21" name="step-body-3">
-            <a:extLst xmlns:a="http://schemas.openxmlformats.org/drawingml/2006/main">
-              <a:ext uri="{FF2B5EF4-FFF2-40B4-BE49-F238E27FC236}">
-                <a16:creationId xmlns:a16="http://schemas.microsoft.com/office/drawing/2014/main" id="{A8E3E6EE-C136-46CD-9B40-5D5E42AF102B}"/>
-              </a:ext>
-            </a:extLst>
-          </p:cNvPr>
-          <p:cNvSpPr>
-            <a:spLocks xmlns:a="http://schemas.openxmlformats.org/drawingml/2006/main" noGrp="1"/>
-          </p:cNvSpPr>
-          <p:nvPr/>
-        </p:nvSpPr>
-        <p:spPr>
-          <a:xfrm xmlns:a="http://schemas.openxmlformats.org/drawingml/2006/main">
-            <a:off x="742950" y="5276850"/>
-            <a:ext cx="2476500" cy="400050"/>
-          </a:xfrm>
-          <a:prstGeom xmlns:a="http://schemas.openxmlformats.org/drawingml/2006/main" prst="rect">
-            <a:avLst/>
-          </a:prstGeom>
-          <a:noFill xmlns:a="http://schemas.openxmlformats.org/drawingml/2006/main"/>
-          <a:ln xmlns:a="http://schemas.openxmlformats.org/drawingml/2006/main" w="0">
-            <a:noFill/>
-            <a:prstDash val="solid"/>
-          </a:ln>
-        </p:spPr>
-        <p:txBody>
-          <a:bodyPr xmlns:a="http://schemas.openxmlformats.org/drawingml/2006/main" anchor="t">
-            <a:normAutofit fontScale="100000"/>
-          </a:bodyPr>
-          <a:lstStyle xmlns:a="http://schemas.openxmlformats.org/drawingml/2006/main"/>
-          <a:p xmlns:a="http://schemas.openxmlformats.org/drawingml/2006/main">
-            <a:pPr algn="ctr">
-              <a:buNone/>
-              <a:defRPr sz="1350" b="0">
-                <a:solidFill>
-                  <a:srgbClr val="667085"/>
-                </a:solidFill>
-                <a:latin typeface="PingFang SC"/>
-                <a:ea typeface="PingFang SC"/>
-                <a:cs typeface="PingFang SC"/>
-              </a:defRPr>
-            </a:pPr>
-            <a:r>
-              <a:rPr sz="1350" b="0">
-                <a:solidFill>
-                  <a:srgbClr val="667085"/>
-                </a:solidFill>
-                <a:latin typeface="PingFang SC"/>
-                <a:ea typeface="PingFang SC"/>
-                <a:cs typeface="PingFang SC"/>
-              </a:rPr>
-              <a:t>门禁 / 履约 / P0 / 证据</a:t>
-            </a:r>
-          </a:p>
-        </p:txBody>
-      </p:sp>
-      <p:sp>
-        <p:nvSpPr>
-          <p:cNvPr id="22" name="decision-note">
-            <a:extLst xmlns:a="http://schemas.openxmlformats.org/drawingml/2006/main">
-              <a:ext uri="{FF2B5EF4-FFF2-40B4-BE49-F238E27FC236}">
-                <a16:creationId xmlns:a16="http://schemas.microsoft.com/office/drawing/2014/main" id="{85B92780-0A54-4176-AE54-80AED4CD714D}"/>
-              </a:ext>
-            </a:extLst>
-          </p:cNvPr>
-          <p:cNvSpPr>
-            <a:spLocks xmlns:a="http://schemas.openxmlformats.org/drawingml/2006/main" noGrp="1"/>
-          </p:cNvSpPr>
-          <p:nvPr/>
-        </p:nvSpPr>
-        <p:spPr>
-          <a:xfrm xmlns:a="http://schemas.openxmlformats.org/drawingml/2006/main">
-            <a:off x="1143000" y="5810250"/>
-            <a:ext cx="9906000" cy="323850"/>
-          </a:xfrm>
-          <a:prstGeom xmlns:a="http://schemas.openxmlformats.org/drawingml/2006/main" prst="rect">
-            <a:avLst/>
-          </a:prstGeom>
-          <a:noFill xmlns:a="http://schemas.openxmlformats.org/drawingml/2006/main"/>
-          <a:ln xmlns:a="http://schemas.openxmlformats.org/drawingml/2006/main" w="0">
-            <a:noFill/>
-            <a:prstDash val="solid"/>
-          </a:ln>
-        </p:spPr>
-        <p:txBody>
-          <a:bodyPr xmlns:a="http://schemas.openxmlformats.org/drawingml/2006/main" anchor="t">
-            <a:normAutofit fontScale="100000"/>
-          </a:bodyPr>
-          <a:lstStyle xmlns:a="http://schemas.openxmlformats.org/drawingml/2006/main"/>
-          <a:p xmlns:a="http://schemas.openxmlformats.org/drawingml/2006/main">
-            <a:pPr algn="ctr">
-              <a:buNone/>
-              <a:defRPr sz="1500" b="1">
-                <a:solidFill>
-                  <a:srgbClr val="111827"/>
-                </a:solidFill>
-                <a:latin typeface="PingFang SC"/>
-                <a:ea typeface="PingFang SC"/>
-                <a:cs typeface="PingFang SC"/>
-              </a:defRPr>
-            </a:pPr>
-            <a:r>
-              <a:rPr sz="1500" b="1">
-                <a:solidFill>
-                  <a:srgbClr val="111827"/>
-                </a:solidFill>
-                <a:latin typeface="PingFang SC"/>
-                <a:ea typeface="PingFang SC"/>
-                <a:cs typeface="PingFang SC"/>
-              </a:rPr>
-              <a:t>跑完六步，精确回答三个问题：能不能上线？失败在哪里？到底该改谁？</a:t>
-            </a:r>
-          </a:p>
-        </p:txBody>
-      </p:sp>
-      <p:sp>
-        <p:nvSpPr>
-          <p:cNvPr id="23" name="source">
-            <a:extLst xmlns:a="http://schemas.openxmlformats.org/drawingml/2006/main">
-              <a:ext uri="{FF2B5EF4-FFF2-40B4-BE49-F238E27FC236}">
-                <a16:creationId xmlns:a16="http://schemas.microsoft.com/office/drawing/2014/main" id="{E648FF3C-1484-417E-9F5E-498A0B757CEE}"/>
-              </a:ext>
-            </a:extLst>
-          </p:cNvPr>
-          <p:cNvSpPr>
-            <a:spLocks xmlns:a="http://schemas.openxmlformats.org/drawingml/2006/main" noGrp="1"/>
-          </p:cNvSpPr>
-          <p:nvPr/>
-        </p:nvSpPr>
-        <p:spPr>
-          <a:xfrm xmlns:a="http://schemas.openxmlformats.org/drawingml/2006/main">
-            <a:off x="533400" y="6372225"/>
-            <a:ext cx="9906000" cy="190500"/>
-          </a:xfrm>
-          <a:prstGeom xmlns:a="http://schemas.openxmlformats.org/drawingml/2006/main" prst="rect">
-            <a:avLst/>
-          </a:prstGeom>
-          <a:noFill xmlns:a="http://schemas.openxmlformats.org/drawingml/2006/main"/>
-          <a:ln xmlns:a="http://schemas.openxmlformats.org/drawingml/2006/main" w="0">
-            <a:noFill/>
-            <a:prstDash val="solid"/>
-          </a:ln>
-        </p:spPr>
-        <p:txBody>
-          <a:bodyPr xmlns:a="http://schemas.openxmlformats.org/drawingml/2006/main" anchor="t">
-            <a:normAutofit fontScale="72222"/>
-          </a:bodyPr>
-          <a:lstStyle xmlns:a="http://schemas.openxmlformats.org/drawingml/2006/main"/>
-          <a:p xmlns:a="http://schemas.openxmlformats.org/drawingml/2006/main">
-            <a:pPr algn="l">
-              <a:buNone/>
-              <a:defRPr sz="900" b="0">
-                <a:solidFill>
-                  <a:srgbClr val="667085"/>
-                </a:solidFill>
-                <a:latin typeface="PingFang SC"/>
-                <a:ea typeface="PingFang SC"/>
-                <a:cs typeface="PingFang SC"/>
-              </a:defRPr>
-            </a:pPr>
-            <a:r>
-              <a:rPr sz="900" b="0">
-                <a:solidFill>
-                  <a:srgbClr val="667085"/>
-                </a:solidFill>
-                <a:latin typeface="PingFang SC"/>
-                <a:ea typeface="PingFang SC"/>
-                <a:cs typeface="PingFang SC"/>
-              </a:rPr>
-              <a:t>PPT 解释为什么这样设计 · Demo 证明真实运行 · 报告与产物负责结果复核</a:t>
-            </a:r>
-          </a:p>
-        </p:txBody>
-      </p:sp>
-      <p:sp>
-        <p:nvSpPr>
-          <p:cNvPr id="24" name="flow-line-row-2">
-            <a:extLst xmlns:a="http://schemas.openxmlformats.org/drawingml/2006/main">
-              <a:ext uri="{FF2B5EF4-FFF2-40B4-BE49-F238E27FC236}">
-                <a16:creationId xmlns:a16="http://schemas.microsoft.com/office/drawing/2014/main" id="{9FF7EABC-BEE2-4BDE-96F0-2075FF5DBD3E}"/>
-              </a:ext>
-            </a:extLst>
-          </p:cNvPr>
-          <p:cNvSpPr>
-            <a:spLocks xmlns:a="http://schemas.openxmlformats.org/drawingml/2006/main" noGrp="1"/>
-          </p:cNvSpPr>
-          <p:nvPr/>
-        </p:nvSpPr>
-        <p:spPr>
-          <a:xfrm xmlns:a="http://schemas.openxmlformats.org/drawingml/2006/main">
-            <a:off x="1981200" y="4391025"/>
-            <a:ext cx="7600950" cy="38100"/>
-          </a:xfrm>
-          <a:prstGeom xmlns:a="http://schemas.openxmlformats.org/drawingml/2006/main" prst="rect">
-            <a:avLst/>
-          </a:prstGeom>
-          <a:solidFill xmlns:a="http://schemas.openxmlformats.org/drawingml/2006/main">
-            <a:srgbClr val="CBD5E1"/>
-          </a:solidFill>
-          <a:ln xmlns:a="http://schemas.openxmlformats.org/drawingml/2006/main" w="0">
-            <a:noFill/>
-            <a:prstDash val="solid"/>
-          </a:ln>
-        </p:spPr>
-      </p:sp>
-      <p:sp>
-        <p:nvSpPr>
-          <p:cNvPr id="25" name="step-dot-5">
-            <a:extLst xmlns:a="http://schemas.openxmlformats.org/drawingml/2006/main">
-              <a:ext uri="{FF2B5EF4-FFF2-40B4-BE49-F238E27FC236}">
-                <a16:creationId xmlns:a16="http://schemas.microsoft.com/office/drawing/2014/main" id="{F9E6E76D-3B64-4136-83D1-EDAB2A48275D}"/>
-              </a:ext>
-            </a:extLst>
-          </p:cNvPr>
-          <p:cNvSpPr>
-            <a:spLocks xmlns:a="http://schemas.openxmlformats.org/drawingml/2006/main" noGrp="1"/>
-          </p:cNvSpPr>
-          <p:nvPr/>
-        </p:nvSpPr>
-        <p:spPr>
-          <a:xfrm xmlns:a="http://schemas.openxmlformats.org/drawingml/2006/main">
-            <a:off x="5467350" y="4095750"/>
-            <a:ext cx="628650" cy="628650"/>
-          </a:xfrm>
-          <a:prstGeom xmlns:a="http://schemas.openxmlformats.org/drawingml/2006/main" prst="ellipse">
-            <a:avLst/>
-          </a:prstGeom>
-          <a:solidFill xmlns:a="http://schemas.openxmlformats.org/drawingml/2006/main">
-            <a:srgbClr val="111827"/>
-          </a:solidFill>
-          <a:ln xmlns:a="http://schemas.openxmlformats.org/drawingml/2006/main" w="9525">
-            <a:solidFill>
-              <a:srgbClr val="111827"/>
-            </a:solidFill>
-            <a:prstDash val="solid"/>
-          </a:ln>
-        </p:spPr>
-      </p:sp>
-      <p:sp>
-        <p:nvSpPr>
-          <p:cNvPr id="26" name="step-n-5">
-            <a:extLst xmlns:a="http://schemas.openxmlformats.org/drawingml/2006/main">
-              <a:ext uri="{FF2B5EF4-FFF2-40B4-BE49-F238E27FC236}">
-                <a16:creationId xmlns:a16="http://schemas.microsoft.com/office/drawing/2014/main" id="{A480B850-43FF-4E9C-8036-9539608A5708}"/>
-              </a:ext>
-            </a:extLst>
-          </p:cNvPr>
-          <p:cNvSpPr>
-            <a:spLocks xmlns:a="http://schemas.openxmlformats.org/drawingml/2006/main" noGrp="1"/>
-          </p:cNvSpPr>
-          <p:nvPr/>
-        </p:nvSpPr>
-        <p:spPr>
-          <a:xfrm xmlns:a="http://schemas.openxmlformats.org/drawingml/2006/main">
-            <a:off x="5467350" y="4152900"/>
-            <a:ext cx="628650" cy="495300"/>
-          </a:xfrm>
-          <a:prstGeom xmlns:a="http://schemas.openxmlformats.org/drawingml/2006/main" prst="rect">
-            <a:avLst/>
-          </a:prstGeom>
-          <a:noFill xmlns:a="http://schemas.openxmlformats.org/drawingml/2006/main"/>
-          <a:ln xmlns:a="http://schemas.openxmlformats.org/drawingml/2006/main" w="0">
-            <a:noFill/>
-            <a:prstDash val="solid"/>
-          </a:ln>
-        </p:spPr>
-        <p:txBody>
-          <a:bodyPr xmlns:a="http://schemas.openxmlformats.org/drawingml/2006/main" anchor="ctr"/>
-          <a:lstStyle xmlns:a="http://schemas.openxmlformats.org/drawingml/2006/main"/>
-          <a:p xmlns:a="http://schemas.openxmlformats.org/drawingml/2006/main">
-            <a:pPr algn="ctr">
-              <a:buNone/>
-              <a:defRPr sz="1350" b="1">
-                <a:solidFill>
-                  <a:srgbClr val="FFFFFF"/>
-                </a:solidFill>
-              </a:defRPr>
-            </a:pPr>
-            <a:r>
-              <a:rPr sz="1350" b="1">
-                <a:solidFill>
-                  <a:srgbClr val="FFFFFF"/>
-                </a:solidFill>
-              </a:rPr>
-              <a:t>5</a:t>
-            </a:r>
-          </a:p>
-        </p:txBody>
-      </p:sp>
-      <p:sp>
-        <p:nvSpPr>
-          <p:cNvPr id="27" name="step-title-5">
-            <a:extLst xmlns:a="http://schemas.openxmlformats.org/drawingml/2006/main">
-              <a:ext uri="{FF2B5EF4-FFF2-40B4-BE49-F238E27FC236}">
-                <a16:creationId xmlns:a16="http://schemas.microsoft.com/office/drawing/2014/main" id="{4879BEE7-933F-434D-9BC8-9F5EF41EB9B3}"/>
-              </a:ext>
-            </a:extLst>
-          </p:cNvPr>
-          <p:cNvSpPr>
-            <a:spLocks xmlns:a="http://schemas.openxmlformats.org/drawingml/2006/main" noGrp="1"/>
-          </p:cNvSpPr>
-          <p:nvPr/>
-        </p:nvSpPr>
-        <p:spPr>
-          <a:xfrm xmlns:a="http://schemas.openxmlformats.org/drawingml/2006/main">
-            <a:off x="4638675" y="4857750"/>
-            <a:ext cx="2286000" cy="361950"/>
-          </a:xfrm>
-          <a:prstGeom xmlns:a="http://schemas.openxmlformats.org/drawingml/2006/main" prst="rect">
-            <a:avLst/>
-          </a:prstGeom>
-          <a:noFill xmlns:a="http://schemas.openxmlformats.org/drawingml/2006/main"/>
-          <a:ln xmlns:a="http://schemas.openxmlformats.org/drawingml/2006/main" w="0">
-            <a:noFill/>
-            <a:prstDash val="solid"/>
-          </a:ln>
-        </p:spPr>
-        <p:txBody>
-          <a:bodyPr xmlns:a="http://schemas.openxmlformats.org/drawingml/2006/main"/>
-          <a:lstStyle xmlns:a="http://schemas.openxmlformats.org/drawingml/2006/main"/>
-          <a:p xmlns:a="http://schemas.openxmlformats.org/drawingml/2006/main">
-            <a:pPr algn="ctr">
-              <a:buNone/>
-              <a:defRPr sz="1500" b="1">
-                <a:solidFill>
-                  <a:srgbClr val="111827"/>
-                </a:solidFill>
-              </a:defRPr>
-            </a:pPr>
-            <a:r>
-              <a:rPr sz="1500" b="1">
-                <a:solidFill>
-                  <a:srgbClr val="111827"/>
-                </a:solidFill>
-              </a:rPr>
-              <a:t>分离真实根因</a:t>
-            </a:r>
-          </a:p>
-        </p:txBody>
-      </p:sp>
-      <p:sp>
-        <p:nvSpPr>
-          <p:cNvPr id="28" name="step-body-5">
-            <a:extLst xmlns:a="http://schemas.openxmlformats.org/drawingml/2006/main">
-              <a:ext uri="{FF2B5EF4-FFF2-40B4-BE49-F238E27FC236}">
-                <a16:creationId xmlns:a16="http://schemas.microsoft.com/office/drawing/2014/main" id="{6A2887F8-74C4-4104-8D6A-242A585D4AA6}"/>
-              </a:ext>
-            </a:extLst>
-          </p:cNvPr>
-          <p:cNvSpPr>
-            <a:spLocks xmlns:a="http://schemas.openxmlformats.org/drawingml/2006/main" noGrp="1"/>
-          </p:cNvSpPr>
-          <p:nvPr/>
-        </p:nvSpPr>
-        <p:spPr>
-          <a:xfrm xmlns:a="http://schemas.openxmlformats.org/drawingml/2006/main">
-            <a:off x="4543425" y="5276850"/>
-            <a:ext cx="2476500" cy="400050"/>
-          </a:xfrm>
-          <a:prstGeom xmlns:a="http://schemas.openxmlformats.org/drawingml/2006/main" prst="rect">
-            <a:avLst/>
-          </a:prstGeom>
-          <a:noFill xmlns:a="http://schemas.openxmlformats.org/drawingml/2006/main"/>
-          <a:ln xmlns:a="http://schemas.openxmlformats.org/drawingml/2006/main" w="0">
-            <a:noFill/>
-            <a:prstDash val="solid"/>
-          </a:ln>
-        </p:spPr>
-        <p:txBody>
-          <a:bodyPr xmlns:a="http://schemas.openxmlformats.org/drawingml/2006/main"/>
-          <a:lstStyle xmlns:a="http://schemas.openxmlformats.org/drawingml/2006/main"/>
-          <a:p xmlns:a="http://schemas.openxmlformats.org/drawingml/2006/main">
-            <a:pPr algn="ctr">
-              <a:buNone/>
-              <a:defRPr sz="900">
-                <a:solidFill>
-                  <a:srgbClr val="64748B"/>
-                </a:solidFill>
-              </a:defRPr>
-            </a:pPr>
-            <a:r>
-              <a:rPr sz="900">
-                <a:solidFill>
-                  <a:srgbClr val="64748B"/>
-                </a:solidFill>
-              </a:rPr>
-              <a:t>模型 / SOP / 裁判 / 数据</a:t>
-            </a:r>
-          </a:p>
-        </p:txBody>
-      </p:sp>
-      <p:sp>
-        <p:nvSpPr>
-          <p:cNvPr id="29" name="step-dot-6">
-            <a:extLst xmlns:a="http://schemas.openxmlformats.org/drawingml/2006/main">
-              <a:ext uri="{FF2B5EF4-FFF2-40B4-BE49-F238E27FC236}">
-                <a16:creationId xmlns:a16="http://schemas.microsoft.com/office/drawing/2014/main" id="{23E73DBE-3366-4643-901F-4A27567DF65A}"/>
-              </a:ext>
-            </a:extLst>
-          </p:cNvPr>
-          <p:cNvSpPr>
-            <a:spLocks xmlns:a="http://schemas.openxmlformats.org/drawingml/2006/main" noGrp="1"/>
-          </p:cNvSpPr>
-          <p:nvPr/>
-        </p:nvSpPr>
-        <p:spPr>
-          <a:xfrm xmlns:a="http://schemas.openxmlformats.org/drawingml/2006/main">
-            <a:off x="9267825" y="4095750"/>
-            <a:ext cx="628650" cy="628650"/>
-          </a:xfrm>
-          <a:prstGeom xmlns:a="http://schemas.openxmlformats.org/drawingml/2006/main" prst="ellipse">
-            <a:avLst/>
-          </a:prstGeom>
-          <a:solidFill xmlns:a="http://schemas.openxmlformats.org/drawingml/2006/main">
-            <a:srgbClr val="FFCC00"/>
-          </a:solidFill>
-          <a:ln xmlns:a="http://schemas.openxmlformats.org/drawingml/2006/main" w="9525">
-            <a:solidFill>
-              <a:srgbClr val="FFCC00"/>
-            </a:solidFill>
-            <a:prstDash val="solid"/>
-          </a:ln>
-        </p:spPr>
-      </p:sp>
-      <p:sp>
-        <p:nvSpPr>
-          <p:cNvPr id="30" name="step-n-6">
-            <a:extLst xmlns:a="http://schemas.openxmlformats.org/drawingml/2006/main">
-              <a:ext uri="{FF2B5EF4-FFF2-40B4-BE49-F238E27FC236}">
-                <a16:creationId xmlns:a16="http://schemas.microsoft.com/office/drawing/2014/main" id="{0AF895B3-0C7D-4F4A-AD53-77115BEBA63A}"/>
-              </a:ext>
-            </a:extLst>
-          </p:cNvPr>
-          <p:cNvSpPr>
-            <a:spLocks xmlns:a="http://schemas.openxmlformats.org/drawingml/2006/main" noGrp="1"/>
-          </p:cNvSpPr>
-          <p:nvPr/>
-        </p:nvSpPr>
-        <p:spPr>
-          <a:xfrm xmlns:a="http://schemas.openxmlformats.org/drawingml/2006/main">
-            <a:off x="9267825" y="4152900"/>
-            <a:ext cx="628650" cy="495300"/>
-          </a:xfrm>
-          <a:prstGeom xmlns:a="http://schemas.openxmlformats.org/drawingml/2006/main" prst="rect">
-            <a:avLst/>
-          </a:prstGeom>
-          <a:noFill xmlns:a="http://schemas.openxmlformats.org/drawingml/2006/main"/>
-          <a:ln xmlns:a="http://schemas.openxmlformats.org/drawingml/2006/main" w="0">
-            <a:noFill/>
-            <a:prstDash val="solid"/>
-          </a:ln>
-        </p:spPr>
-        <p:txBody>
-          <a:bodyPr xmlns:a="http://schemas.openxmlformats.org/drawingml/2006/main" anchor="ctr"/>
-          <a:lstStyle xmlns:a="http://schemas.openxmlformats.org/drawingml/2006/main"/>
-          <a:p xmlns:a="http://schemas.openxmlformats.org/drawingml/2006/main">
-            <a:pPr algn="ctr">
-              <a:buNone/>
-              <a:defRPr sz="1350" b="1">
-                <a:solidFill>
-                  <a:srgbClr val="111827"/>
-                </a:solidFill>
-              </a:defRPr>
-            </a:pPr>
-            <a:r>
-              <a:rPr sz="1350" b="1">
-                <a:solidFill>
-                  <a:srgbClr val="111827"/>
-                </a:solidFill>
-              </a:rPr>
-              <a:t>6</a:t>
-            </a:r>
-          </a:p>
-        </p:txBody>
-      </p:sp>
-      <p:sp>
-        <p:nvSpPr>
-          <p:cNvPr id="31" name="step-title-6">
-            <a:extLst xmlns:a="http://schemas.openxmlformats.org/drawingml/2006/main">
-              <a:ext uri="{FF2B5EF4-FFF2-40B4-BE49-F238E27FC236}">
-                <a16:creationId xmlns:a16="http://schemas.microsoft.com/office/drawing/2014/main" id="{52A093D1-21A9-4D21-AA78-5E4C7BFEB39C}"/>
-              </a:ext>
-            </a:extLst>
-          </p:cNvPr>
-          <p:cNvSpPr>
-            <a:spLocks xmlns:a="http://schemas.openxmlformats.org/drawingml/2006/main" noGrp="1"/>
-          </p:cNvSpPr>
-          <p:nvPr/>
-        </p:nvSpPr>
-        <p:spPr>
-          <a:xfrm xmlns:a="http://schemas.openxmlformats.org/drawingml/2006/main">
-            <a:off x="8439150" y="4857750"/>
-            <a:ext cx="2286000" cy="361950"/>
-          </a:xfrm>
-          <a:prstGeom xmlns:a="http://schemas.openxmlformats.org/drawingml/2006/main" prst="rect">
-            <a:avLst/>
-          </a:prstGeom>
-          <a:noFill xmlns:a="http://schemas.openxmlformats.org/drawingml/2006/main"/>
-          <a:ln xmlns:a="http://schemas.openxmlformats.org/drawingml/2006/main" w="0">
-            <a:noFill/>
-            <a:prstDash val="solid"/>
-          </a:ln>
-        </p:spPr>
-        <p:txBody>
-          <a:bodyPr xmlns:a="http://schemas.openxmlformats.org/drawingml/2006/main"/>
-          <a:lstStyle xmlns:a="http://schemas.openxmlformats.org/drawingml/2006/main"/>
-          <a:p xmlns:a="http://schemas.openxmlformats.org/drawingml/2006/main">
-            <a:pPr algn="ctr">
-              <a:buNone/>
-              <a:defRPr sz="1500" b="1">
-                <a:solidFill>
-                  <a:srgbClr val="111827"/>
-                </a:solidFill>
-              </a:defRPr>
-            </a:pPr>
-            <a:r>
-              <a:rPr sz="1500" b="1">
-                <a:solidFill>
-                  <a:srgbClr val="111827"/>
-                </a:solidFill>
-              </a:rPr>
-              <a:t>同尺回归闭环</a:t>
-            </a:r>
-          </a:p>
-        </p:txBody>
-      </p:sp>
-      <p:sp>
-        <p:nvSpPr>
-          <p:cNvPr id="32" name="step-body-6">
-            <a:extLst xmlns:a="http://schemas.openxmlformats.org/drawingml/2006/main">
-              <a:ext uri="{FF2B5EF4-FFF2-40B4-BE49-F238E27FC236}">
-                <a16:creationId xmlns:a16="http://schemas.microsoft.com/office/drawing/2014/main" id="{230A79F8-88BC-4067-BD59-AED39F7BAC2D}"/>
-              </a:ext>
-            </a:extLst>
-          </p:cNvPr>
-          <p:cNvSpPr>
-            <a:spLocks xmlns:a="http://schemas.openxmlformats.org/drawingml/2006/main" noGrp="1"/>
-          </p:cNvSpPr>
-          <p:nvPr/>
-        </p:nvSpPr>
-        <p:spPr>
-          <a:xfrm xmlns:a="http://schemas.openxmlformats.org/drawingml/2006/main">
-            <a:off x="8343900" y="5276850"/>
-            <a:ext cx="2476500" cy="400050"/>
-          </a:xfrm>
-          <a:prstGeom xmlns:a="http://schemas.openxmlformats.org/drawingml/2006/main" prst="rect">
-            <a:avLst/>
-          </a:prstGeom>
-          <a:noFill xmlns:a="http://schemas.openxmlformats.org/drawingml/2006/main"/>
-          <a:ln xmlns:a="http://schemas.openxmlformats.org/drawingml/2006/main" w="0">
-            <a:noFill/>
-            <a:prstDash val="solid"/>
-          </a:ln>
-        </p:spPr>
-        <p:txBody>
-          <a:bodyPr xmlns:a="http://schemas.openxmlformats.org/drawingml/2006/main"/>
-          <a:lstStyle xmlns:a="http://schemas.openxmlformats.org/drawingml/2006/main"/>
-          <a:p xmlns:a="http://schemas.openxmlformats.org/drawingml/2006/main">
-            <a:pPr algn="ctr">
-              <a:buNone/>
-              <a:defRPr sz="900">
-                <a:solidFill>
-                  <a:srgbClr val="64748B"/>
-                </a:solidFill>
-              </a:defRPr>
-            </a:pPr>
-            <a:r>
-              <a:rPr sz="900">
-                <a:solidFill>
-                  <a:srgbClr val="64748B"/>
-                </a:solidFill>
-              </a:rPr>
-              <a:t>只改责任对象，再测一次</a:t>
-            </a:r>
-          </a:p>
-        </p:txBody>
-      </p:sp>
-      <p:sp>
-        <p:nvSpPr>
           <p:cNvPr id="33" name="live-demo-link-1">
             <a:extLst xmlns:a="http://schemas.openxmlformats.org/drawingml/2006/main">
               <a:ext uri="{FF2B5EF4-FFF2-40B4-BE49-F238E27FC236}">
@@ -5525,7 +3948,7 @@
                 <a:latin typeface="PingFang SC"/>
                 <a:ea typeface="PingFang SC"/>
                 <a:cs typeface="PingFang SC"/>
-                <a:hlinkClick xmlns:r="http://schemas.openxmlformats.org/officeDocument/2006/relationships" r:id="R3352234bac2c4730"/>
+                <a:hlinkClick xmlns:r="http://schemas.openxmlformats.org/officeDocument/2006/relationships" r:id="R03820dcd81b74ead"/>
               </a:rPr>
               <a:t>▶ 在线 Demo</a:t>
             </a:r>
@@ -5577,9 +4000,1580 @@
                 <a:latin typeface="PingFang SC"/>
                 <a:ea typeface="PingFang SC"/>
                 <a:cs typeface="PingFang SC"/>
-                <a:hlinkClick xmlns:r="http://schemas.openxmlformats.org/officeDocument/2006/relationships" r:id="Re1b8640b4fd648ce"/>
+                <a:hlinkClick xmlns:r="http://schemas.openxmlformats.org/officeDocument/2006/relationships" r:id="R4914a3298ce74a05"/>
               </a:rPr>
               <a:t>结果备份 ↗</a:t>
+            </a:r>
+          </a:p>
+        </p:txBody>
+      </p:sp>
+      <p:sp>
+        <p:nvSpPr>
+          <p:cNvPr id="35" name="kicker">
+            <a:extLst xmlns:a="http://schemas.openxmlformats.org/drawingml/2006/main">
+              <a:ext uri="{FF2B5EF4-FFF2-40B4-BE49-F238E27FC236}">
+                <a16:creationId xmlns:a16="http://schemas.microsoft.com/office/drawing/2014/main" id="{E4EA4601-0682-4B94-A3C5-0C99A0C704C9}"/>
+              </a:ext>
+            </a:extLst>
+          </p:cNvPr>
+          <p:cNvSpPr>
+            <a:spLocks xmlns:a="http://schemas.openxmlformats.org/drawingml/2006/main" noGrp="1"/>
+          </p:cNvSpPr>
+          <p:nvPr/>
+        </p:nvSpPr>
+        <p:spPr>
+          <a:xfrm xmlns:a="http://schemas.openxmlformats.org/drawingml/2006/main">
+            <a:off x="533400" y="285750"/>
+            <a:ext cx="4762500" cy="238125"/>
+          </a:xfrm>
+          <a:prstGeom xmlns:a="http://schemas.openxmlformats.org/drawingml/2006/main" prst="rect">
+            <a:avLst/>
+          </a:prstGeom>
+          <a:noFill xmlns:a="http://schemas.openxmlformats.org/drawingml/2006/main"/>
+          <a:ln xmlns:a="http://schemas.openxmlformats.org/drawingml/2006/main" w="0">
+            <a:noFill/>
+            <a:prstDash val="solid"/>
+          </a:ln>
+        </p:spPr>
+        <p:txBody>
+          <a:bodyPr xmlns:a="http://schemas.openxmlformats.org/drawingml/2006/main" wrap="square" lIns="0" tIns="0" rIns="0" bIns="0" anchor="ctr">
+            <a:normAutofit fontScale="100000"/>
+          </a:bodyPr>
+          <a:lstStyle xmlns:a="http://schemas.openxmlformats.org/drawingml/2006/main"/>
+          <a:p xmlns:a="http://schemas.openxmlformats.org/drawingml/2006/main">
+            <a:pPr algn="l">
+              <a:defRPr sz="1050" b="1">
+                <a:solidFill>
+                  <a:srgbClr val="6E7A90"/>
+                </a:solidFill>
+              </a:defRPr>
+            </a:pPr>
+            <a:r>
+              <a:rPr sz="1050" b="1">
+                <a:solidFill>
+                  <a:srgbClr val="6E7A90"/>
+                </a:solidFill>
+              </a:rPr>
+              <a:t>EVALCALL · 六步自我评测迭代系统</a:t>
+            </a:r>
+          </a:p>
+        </p:txBody>
+      </p:sp>
+      <p:sp>
+        <p:nvSpPr>
+          <p:cNvPr id="36" name="title">
+            <a:extLst xmlns:a="http://schemas.openxmlformats.org/drawingml/2006/main">
+              <a:ext uri="{FF2B5EF4-FFF2-40B4-BE49-F238E27FC236}">
+                <a16:creationId xmlns:a16="http://schemas.microsoft.com/office/drawing/2014/main" id="{974D7CE7-BF20-4DD4-97A9-44721BC74C7A}"/>
+              </a:ext>
+            </a:extLst>
+          </p:cNvPr>
+          <p:cNvSpPr>
+            <a:spLocks xmlns:a="http://schemas.openxmlformats.org/drawingml/2006/main" noGrp="1"/>
+          </p:cNvSpPr>
+          <p:nvPr/>
+        </p:nvSpPr>
+        <p:spPr>
+          <a:xfrm xmlns:a="http://schemas.openxmlformats.org/drawingml/2006/main">
+            <a:off x="533400" y="647700"/>
+            <a:ext cx="11125200" cy="609600"/>
+          </a:xfrm>
+          <a:prstGeom xmlns:a="http://schemas.openxmlformats.org/drawingml/2006/main" prst="rect">
+            <a:avLst/>
+          </a:prstGeom>
+          <a:noFill xmlns:a="http://schemas.openxmlformats.org/drawingml/2006/main"/>
+          <a:ln xmlns:a="http://schemas.openxmlformats.org/drawingml/2006/main" w="0">
+            <a:noFill/>
+            <a:prstDash val="solid"/>
+          </a:ln>
+        </p:spPr>
+        <p:txBody>
+          <a:bodyPr xmlns:a="http://schemas.openxmlformats.org/drawingml/2006/main" wrap="square" lIns="0" tIns="0" rIns="0" bIns="0" anchor="ctr">
+            <a:normAutofit fontScale="100000"/>
+          </a:bodyPr>
+          <a:lstStyle xmlns:a="http://schemas.openxmlformats.org/drawingml/2006/main"/>
+          <a:p xmlns:a="http://schemas.openxmlformats.org/drawingml/2006/main">
+            <a:pPr algn="l">
+              <a:defRPr sz="2850" b="1">
+                <a:solidFill>
+                  <a:srgbClr val="111C31"/>
+                </a:solidFill>
+              </a:defRPr>
+            </a:pPr>
+            <a:r>
+              <a:rPr sz="2850" b="1">
+                <a:solidFill>
+                  <a:srgbClr val="111C31"/>
+                </a:solidFill>
+              </a:rPr>
+              <a:t>为了解决刚刚出现的问题，设计的六步自我评测迭代系统</a:t>
+            </a:r>
+          </a:p>
+        </p:txBody>
+      </p:sp>
+      <p:sp>
+        <p:nvSpPr>
+          <p:cNvPr id="37" name="title-rule">
+            <a:extLst xmlns:a="http://schemas.openxmlformats.org/drawingml/2006/main">
+              <a:ext uri="{FF2B5EF4-FFF2-40B4-BE49-F238E27FC236}">
+                <a16:creationId xmlns:a16="http://schemas.microsoft.com/office/drawing/2014/main" id="{98E0F8BE-E8DF-45A7-B8AB-B7C7F2D96016}"/>
+              </a:ext>
+            </a:extLst>
+          </p:cNvPr>
+          <p:cNvSpPr>
+            <a:spLocks xmlns:a="http://schemas.openxmlformats.org/drawingml/2006/main" noGrp="1"/>
+          </p:cNvSpPr>
+          <p:nvPr/>
+        </p:nvSpPr>
+        <p:spPr>
+          <a:xfrm xmlns:a="http://schemas.openxmlformats.org/drawingml/2006/main">
+            <a:off x="533400" y="1381125"/>
+            <a:ext cx="11125200" cy="19050"/>
+          </a:xfrm>
+          <a:prstGeom xmlns:a="http://schemas.openxmlformats.org/drawingml/2006/main" prst="rect">
+            <a:avLst/>
+          </a:prstGeom>
+          <a:solidFill xmlns:a="http://schemas.openxmlformats.org/drawingml/2006/main">
+            <a:srgbClr val="111C31"/>
+          </a:solidFill>
+          <a:ln xmlns:a="http://schemas.openxmlformats.org/drawingml/2006/main" w="0">
+            <a:noFill/>
+            <a:prstDash val="solid"/>
+          </a:ln>
+        </p:spPr>
+      </p:sp>
+      <p:sp>
+        <p:nvSpPr>
+          <p:cNvPr id="38" name="arrow-1-2">
+            <a:extLst xmlns:a="http://schemas.openxmlformats.org/drawingml/2006/main">
+              <a:ext uri="{FF2B5EF4-FFF2-40B4-BE49-F238E27FC236}">
+                <a16:creationId xmlns:a16="http://schemas.microsoft.com/office/drawing/2014/main" id="{E1D9927E-5286-4280-B4D5-F405C2690A26}"/>
+              </a:ext>
+            </a:extLst>
+          </p:cNvPr>
+          <p:cNvSpPr>
+            <a:spLocks xmlns:a="http://schemas.openxmlformats.org/drawingml/2006/main" noGrp="1"/>
+          </p:cNvSpPr>
+          <p:nvPr/>
+        </p:nvSpPr>
+        <p:spPr>
+          <a:xfrm xmlns:a="http://schemas.openxmlformats.org/drawingml/2006/main">
+            <a:off x="2724150" y="2343150"/>
+            <a:ext cx="2457450" cy="171450"/>
+          </a:xfrm>
+          <a:prstGeom xmlns:a="http://schemas.openxmlformats.org/drawingml/2006/main" prst="rightArrow">
+            <a:avLst/>
+          </a:prstGeom>
+          <a:solidFill xmlns:a="http://schemas.openxmlformats.org/drawingml/2006/main">
+            <a:srgbClr val="FFF4BD"/>
+          </a:solidFill>
+          <a:ln xmlns:a="http://schemas.openxmlformats.org/drawingml/2006/main" w="0">
+            <a:noFill/>
+            <a:prstDash val="solid"/>
+          </a:ln>
+        </p:spPr>
+      </p:sp>
+      <p:sp>
+        <p:nvSpPr>
+          <p:cNvPr id="39" name="arrow-2-3">
+            <a:extLst xmlns:a="http://schemas.openxmlformats.org/drawingml/2006/main">
+              <a:ext uri="{FF2B5EF4-FFF2-40B4-BE49-F238E27FC236}">
+                <a16:creationId xmlns:a16="http://schemas.microsoft.com/office/drawing/2014/main" id="{8AC199E6-39C1-4A20-B37E-692666FEB0E0}"/>
+              </a:ext>
+            </a:extLst>
+          </p:cNvPr>
+          <p:cNvSpPr>
+            <a:spLocks xmlns:a="http://schemas.openxmlformats.org/drawingml/2006/main" noGrp="1"/>
+          </p:cNvSpPr>
+          <p:nvPr/>
+        </p:nvSpPr>
+        <p:spPr>
+          <a:xfrm xmlns:a="http://schemas.openxmlformats.org/drawingml/2006/main">
+            <a:off x="6724650" y="2343150"/>
+            <a:ext cx="2457450" cy="171450"/>
+          </a:xfrm>
+          <a:prstGeom xmlns:a="http://schemas.openxmlformats.org/drawingml/2006/main" prst="rightArrow">
+            <a:avLst/>
+          </a:prstGeom>
+          <a:solidFill xmlns:a="http://schemas.openxmlformats.org/drawingml/2006/main">
+            <a:srgbClr val="FFF4BD"/>
+          </a:solidFill>
+          <a:ln xmlns:a="http://schemas.openxmlformats.org/drawingml/2006/main" w="0">
+            <a:noFill/>
+            <a:prstDash val="solid"/>
+          </a:ln>
+        </p:spPr>
+      </p:sp>
+      <p:sp>
+        <p:nvSpPr>
+          <p:cNvPr id="40" name="arrow-3-4">
+            <a:extLst xmlns:a="http://schemas.openxmlformats.org/drawingml/2006/main">
+              <a:ext uri="{FF2B5EF4-FFF2-40B4-BE49-F238E27FC236}">
+                <a16:creationId xmlns:a16="http://schemas.microsoft.com/office/drawing/2014/main" id="{DFA1DE85-0313-496F-AA0D-57A447733D87}"/>
+              </a:ext>
+            </a:extLst>
+          </p:cNvPr>
+          <p:cNvSpPr>
+            <a:spLocks xmlns:a="http://schemas.openxmlformats.org/drawingml/2006/main" noGrp="1"/>
+          </p:cNvSpPr>
+          <p:nvPr/>
+        </p:nvSpPr>
+        <p:spPr>
+          <a:xfrm xmlns:a="http://schemas.openxmlformats.org/drawingml/2006/main">
+            <a:off x="9791700" y="3086100"/>
+            <a:ext cx="228600" cy="590550"/>
+          </a:xfrm>
+          <a:prstGeom xmlns:a="http://schemas.openxmlformats.org/drawingml/2006/main" prst="downArrow">
+            <a:avLst/>
+          </a:prstGeom>
+          <a:solidFill xmlns:a="http://schemas.openxmlformats.org/drawingml/2006/main">
+            <a:srgbClr val="FFF4BD"/>
+          </a:solidFill>
+          <a:ln xmlns:a="http://schemas.openxmlformats.org/drawingml/2006/main" w="0">
+            <a:noFill/>
+            <a:prstDash val="solid"/>
+          </a:ln>
+        </p:spPr>
+      </p:sp>
+      <p:sp>
+        <p:nvSpPr>
+          <p:cNvPr id="41" name="arrow-4-5">
+            <a:extLst xmlns:a="http://schemas.openxmlformats.org/drawingml/2006/main">
+              <a:ext uri="{FF2B5EF4-FFF2-40B4-BE49-F238E27FC236}">
+                <a16:creationId xmlns:a16="http://schemas.microsoft.com/office/drawing/2014/main" id="{3501520E-4E46-4E67-B560-77F095EE6B32}"/>
+              </a:ext>
+            </a:extLst>
+          </p:cNvPr>
+          <p:cNvSpPr>
+            <a:spLocks xmlns:a="http://schemas.openxmlformats.org/drawingml/2006/main" noGrp="1"/>
+          </p:cNvSpPr>
+          <p:nvPr/>
+        </p:nvSpPr>
+        <p:spPr>
+          <a:xfrm xmlns:a="http://schemas.openxmlformats.org/drawingml/2006/main">
+            <a:off x="6724650" y="4286250"/>
+            <a:ext cx="2457450" cy="171450"/>
+          </a:xfrm>
+          <a:prstGeom xmlns:a="http://schemas.openxmlformats.org/drawingml/2006/main" prst="leftArrow">
+            <a:avLst/>
+          </a:prstGeom>
+          <a:solidFill xmlns:a="http://schemas.openxmlformats.org/drawingml/2006/main">
+            <a:srgbClr val="FFF4BD"/>
+          </a:solidFill>
+          <a:ln xmlns:a="http://schemas.openxmlformats.org/drawingml/2006/main" w="0">
+            <a:noFill/>
+            <a:prstDash val="solid"/>
+          </a:ln>
+        </p:spPr>
+      </p:sp>
+      <p:sp>
+        <p:nvSpPr>
+          <p:cNvPr id="42" name="arrow-5-6">
+            <a:extLst xmlns:a="http://schemas.openxmlformats.org/drawingml/2006/main">
+              <a:ext uri="{FF2B5EF4-FFF2-40B4-BE49-F238E27FC236}">
+                <a16:creationId xmlns:a16="http://schemas.microsoft.com/office/drawing/2014/main" id="{7D0EB317-95CE-419F-BBD8-98F655EEAE8B}"/>
+              </a:ext>
+            </a:extLst>
+          </p:cNvPr>
+          <p:cNvSpPr>
+            <a:spLocks xmlns:a="http://schemas.openxmlformats.org/drawingml/2006/main" noGrp="1"/>
+          </p:cNvSpPr>
+          <p:nvPr/>
+        </p:nvSpPr>
+        <p:spPr>
+          <a:xfrm xmlns:a="http://schemas.openxmlformats.org/drawingml/2006/main">
+            <a:off x="2724150" y="4286250"/>
+            <a:ext cx="2457450" cy="171450"/>
+          </a:xfrm>
+          <a:prstGeom xmlns:a="http://schemas.openxmlformats.org/drawingml/2006/main" prst="leftArrow">
+            <a:avLst/>
+          </a:prstGeom>
+          <a:solidFill xmlns:a="http://schemas.openxmlformats.org/drawingml/2006/main">
+            <a:srgbClr val="FFF4BD"/>
+          </a:solidFill>
+          <a:ln xmlns:a="http://schemas.openxmlformats.org/drawingml/2006/main" w="0">
+            <a:noFill/>
+            <a:prstDash val="solid"/>
+          </a:ln>
+        </p:spPr>
+      </p:sp>
+      <p:sp>
+        <p:nvSpPr>
+          <p:cNvPr id="43" name="label-1-2">
+            <a:extLst xmlns:a="http://schemas.openxmlformats.org/drawingml/2006/main">
+              <a:ext uri="{FF2B5EF4-FFF2-40B4-BE49-F238E27FC236}">
+                <a16:creationId xmlns:a16="http://schemas.microsoft.com/office/drawing/2014/main" id="{01C69AAF-2342-4C4D-A361-FB6E16CAE35F}"/>
+              </a:ext>
+            </a:extLst>
+          </p:cNvPr>
+          <p:cNvSpPr>
+            <a:spLocks xmlns:a="http://schemas.openxmlformats.org/drawingml/2006/main" noGrp="1"/>
+          </p:cNvSpPr>
+          <p:nvPr/>
+        </p:nvSpPr>
+        <p:spPr>
+          <a:xfrm xmlns:a="http://schemas.openxmlformats.org/drawingml/2006/main">
+            <a:off x="3162300" y="2057400"/>
+            <a:ext cx="1619250" cy="228600"/>
+          </a:xfrm>
+          <a:prstGeom xmlns:a="http://schemas.openxmlformats.org/drawingml/2006/main" prst="rect">
+            <a:avLst/>
+          </a:prstGeom>
+          <a:noFill xmlns:a="http://schemas.openxmlformats.org/drawingml/2006/main"/>
+          <a:ln xmlns:a="http://schemas.openxmlformats.org/drawingml/2006/main" w="0">
+            <a:noFill/>
+            <a:prstDash val="solid"/>
+          </a:ln>
+        </p:spPr>
+        <p:txBody>
+          <a:bodyPr xmlns:a="http://schemas.openxmlformats.org/drawingml/2006/main" wrap="square" lIns="0" tIns="0" rIns="0" bIns="0" anchor="ctr">
+            <a:normAutofit fontScale="100000"/>
+          </a:bodyPr>
+          <a:lstStyle xmlns:a="http://schemas.openxmlformats.org/drawingml/2006/main"/>
+          <a:p xmlns:a="http://schemas.openxmlformats.org/drawingml/2006/main">
+            <a:pPr algn="ctr">
+              <a:defRPr sz="975" b="1">
+                <a:solidFill>
+                  <a:srgbClr val="6E7A90"/>
+                </a:solidFill>
+              </a:defRPr>
+            </a:pPr>
+            <a:r>
+              <a:rPr sz="975" b="1">
+                <a:solidFill>
+                  <a:srgbClr val="6E7A90"/>
+                </a:solidFill>
+              </a:rPr>
+              <a:t>冻结输入与版本</a:t>
+            </a:r>
+          </a:p>
+        </p:txBody>
+      </p:sp>
+      <p:sp>
+        <p:nvSpPr>
+          <p:cNvPr id="44" name="label-2-3">
+            <a:extLst xmlns:a="http://schemas.openxmlformats.org/drawingml/2006/main">
+              <a:ext uri="{FF2B5EF4-FFF2-40B4-BE49-F238E27FC236}">
+                <a16:creationId xmlns:a16="http://schemas.microsoft.com/office/drawing/2014/main" id="{602ACFEE-7594-43A0-8850-CEE34E2F50FB}"/>
+              </a:ext>
+            </a:extLst>
+          </p:cNvPr>
+          <p:cNvSpPr>
+            <a:spLocks xmlns:a="http://schemas.openxmlformats.org/drawingml/2006/main" noGrp="1"/>
+          </p:cNvSpPr>
+          <p:nvPr/>
+        </p:nvSpPr>
+        <p:spPr>
+          <a:xfrm xmlns:a="http://schemas.openxmlformats.org/drawingml/2006/main">
+            <a:off x="7124700" y="2057400"/>
+            <a:ext cx="1714500" cy="228600"/>
+          </a:xfrm>
+          <a:prstGeom xmlns:a="http://schemas.openxmlformats.org/drawingml/2006/main" prst="rect">
+            <a:avLst/>
+          </a:prstGeom>
+          <a:noFill xmlns:a="http://schemas.openxmlformats.org/drawingml/2006/main"/>
+          <a:ln xmlns:a="http://schemas.openxmlformats.org/drawingml/2006/main" w="0">
+            <a:noFill/>
+            <a:prstDash val="solid"/>
+          </a:ln>
+        </p:spPr>
+        <p:txBody>
+          <a:bodyPr xmlns:a="http://schemas.openxmlformats.org/drawingml/2006/main" wrap="square" lIns="0" tIns="0" rIns="0" bIns="0" anchor="ctr">
+            <a:normAutofit fontScale="100000"/>
+          </a:bodyPr>
+          <a:lstStyle xmlns:a="http://schemas.openxmlformats.org/drawingml/2006/main"/>
+          <a:p xmlns:a="http://schemas.openxmlformats.org/drawingml/2006/main">
+            <a:pPr algn="ctr">
+              <a:defRPr sz="975" b="1">
+                <a:solidFill>
+                  <a:srgbClr val="6E7A90"/>
+                </a:solidFill>
+              </a:defRPr>
+            </a:pPr>
+            <a:r>
+              <a:rPr sz="975" b="1">
+                <a:solidFill>
+                  <a:srgbClr val="6E7A90"/>
+                </a:solidFill>
+              </a:rPr>
+              <a:t>编译成统一评分尺</a:t>
+            </a:r>
+          </a:p>
+        </p:txBody>
+      </p:sp>
+      <p:sp>
+        <p:nvSpPr>
+          <p:cNvPr id="45" name="label-3-4">
+            <a:extLst xmlns:a="http://schemas.openxmlformats.org/drawingml/2006/main">
+              <a:ext uri="{FF2B5EF4-FFF2-40B4-BE49-F238E27FC236}">
+                <a16:creationId xmlns:a16="http://schemas.microsoft.com/office/drawing/2014/main" id="{923FFD88-016C-4C7E-A581-3A49DC3EA7CE}"/>
+              </a:ext>
+            </a:extLst>
+          </p:cNvPr>
+          <p:cNvSpPr>
+            <a:spLocks xmlns:a="http://schemas.openxmlformats.org/drawingml/2006/main" noGrp="1"/>
+          </p:cNvSpPr>
+          <p:nvPr/>
+        </p:nvSpPr>
+        <p:spPr>
+          <a:xfrm xmlns:a="http://schemas.openxmlformats.org/drawingml/2006/main">
+            <a:off x="10077450" y="3219450"/>
+            <a:ext cx="1428750" cy="266700"/>
+          </a:xfrm>
+          <a:prstGeom xmlns:a="http://schemas.openxmlformats.org/drawingml/2006/main" prst="rect">
+            <a:avLst/>
+          </a:prstGeom>
+          <a:noFill xmlns:a="http://schemas.openxmlformats.org/drawingml/2006/main"/>
+          <a:ln xmlns:a="http://schemas.openxmlformats.org/drawingml/2006/main" w="0">
+            <a:noFill/>
+            <a:prstDash val="solid"/>
+          </a:ln>
+        </p:spPr>
+        <p:txBody>
+          <a:bodyPr xmlns:a="http://schemas.openxmlformats.org/drawingml/2006/main" wrap="square" lIns="0" tIns="0" rIns="0" bIns="0" anchor="ctr">
+            <a:normAutofit fontScale="100000"/>
+          </a:bodyPr>
+          <a:lstStyle xmlns:a="http://schemas.openxmlformats.org/drawingml/2006/main"/>
+          <a:p xmlns:a="http://schemas.openxmlformats.org/drawingml/2006/main">
+            <a:pPr algn="l">
+              <a:defRPr sz="975" b="1">
+                <a:solidFill>
+                  <a:srgbClr val="6E7A90"/>
+                </a:solidFill>
+              </a:defRPr>
+            </a:pPr>
+            <a:r>
+              <a:rPr sz="975" b="1">
+                <a:solidFill>
+                  <a:srgbClr val="6E7A90"/>
+                </a:solidFill>
+              </a:rPr>
+              <a:t>生成 / 导入对话</a:t>
+            </a:r>
+          </a:p>
+        </p:txBody>
+      </p:sp>
+      <p:sp>
+        <p:nvSpPr>
+          <p:cNvPr id="46" name="label-4-5">
+            <a:extLst xmlns:a="http://schemas.openxmlformats.org/drawingml/2006/main">
+              <a:ext uri="{FF2B5EF4-FFF2-40B4-BE49-F238E27FC236}">
+                <a16:creationId xmlns:a16="http://schemas.microsoft.com/office/drawing/2014/main" id="{BC28B85B-EDD5-4CDC-93B3-5AC2FDEFEF88}"/>
+              </a:ext>
+            </a:extLst>
+          </p:cNvPr>
+          <p:cNvSpPr>
+            <a:spLocks xmlns:a="http://schemas.openxmlformats.org/drawingml/2006/main" noGrp="1"/>
+          </p:cNvSpPr>
+          <p:nvPr/>
+        </p:nvSpPr>
+        <p:spPr>
+          <a:xfrm xmlns:a="http://schemas.openxmlformats.org/drawingml/2006/main">
+            <a:off x="7124700" y="4552950"/>
+            <a:ext cx="1714500" cy="228600"/>
+          </a:xfrm>
+          <a:prstGeom xmlns:a="http://schemas.openxmlformats.org/drawingml/2006/main" prst="rect">
+            <a:avLst/>
+          </a:prstGeom>
+          <a:noFill xmlns:a="http://schemas.openxmlformats.org/drawingml/2006/main"/>
+          <a:ln xmlns:a="http://schemas.openxmlformats.org/drawingml/2006/main" w="0">
+            <a:noFill/>
+            <a:prstDash val="solid"/>
+          </a:ln>
+        </p:spPr>
+        <p:txBody>
+          <a:bodyPr xmlns:a="http://schemas.openxmlformats.org/drawingml/2006/main" wrap="square" lIns="0" tIns="0" rIns="0" bIns="0" anchor="ctr">
+            <a:normAutofit fontScale="100000"/>
+          </a:bodyPr>
+          <a:lstStyle xmlns:a="http://schemas.openxmlformats.org/drawingml/2006/main"/>
+          <a:p xmlns:a="http://schemas.openxmlformats.org/drawingml/2006/main">
+            <a:pPr algn="ctr">
+              <a:defRPr sz="975" b="1">
+                <a:solidFill>
+                  <a:srgbClr val="6E7A90"/>
+                </a:solidFill>
+              </a:defRPr>
+            </a:pPr>
+            <a:r>
+              <a:rPr sz="975" b="1">
+                <a:solidFill>
+                  <a:srgbClr val="6E7A90"/>
+                </a:solidFill>
+              </a:rPr>
+              <a:t>汇总门禁与证据</a:t>
+            </a:r>
+          </a:p>
+        </p:txBody>
+      </p:sp>
+      <p:sp>
+        <p:nvSpPr>
+          <p:cNvPr id="47" name="label-5-6">
+            <a:extLst xmlns:a="http://schemas.openxmlformats.org/drawingml/2006/main">
+              <a:ext uri="{FF2B5EF4-FFF2-40B4-BE49-F238E27FC236}">
+                <a16:creationId xmlns:a16="http://schemas.microsoft.com/office/drawing/2014/main" id="{F6E88536-54A3-4B0E-89D8-D1C7E91E4EA1}"/>
+              </a:ext>
+            </a:extLst>
+          </p:cNvPr>
+          <p:cNvSpPr>
+            <a:spLocks xmlns:a="http://schemas.openxmlformats.org/drawingml/2006/main" noGrp="1"/>
+          </p:cNvSpPr>
+          <p:nvPr/>
+        </p:nvSpPr>
+        <p:spPr>
+          <a:xfrm xmlns:a="http://schemas.openxmlformats.org/drawingml/2006/main">
+            <a:off x="3086100" y="4552950"/>
+            <a:ext cx="1809750" cy="228600"/>
+          </a:xfrm>
+          <a:prstGeom xmlns:a="http://schemas.openxmlformats.org/drawingml/2006/main" prst="rect">
+            <a:avLst/>
+          </a:prstGeom>
+          <a:noFill xmlns:a="http://schemas.openxmlformats.org/drawingml/2006/main"/>
+          <a:ln xmlns:a="http://schemas.openxmlformats.org/drawingml/2006/main" w="0">
+            <a:noFill/>
+            <a:prstDash val="solid"/>
+          </a:ln>
+        </p:spPr>
+        <p:txBody>
+          <a:bodyPr xmlns:a="http://schemas.openxmlformats.org/drawingml/2006/main" wrap="square" lIns="0" tIns="0" rIns="0" bIns="0" anchor="ctr">
+            <a:normAutofit fontScale="100000"/>
+          </a:bodyPr>
+          <a:lstStyle xmlns:a="http://schemas.openxmlformats.org/drawingml/2006/main"/>
+          <a:p xmlns:a="http://schemas.openxmlformats.org/drawingml/2006/main">
+            <a:pPr algn="ctr">
+              <a:defRPr sz="975" b="1">
+                <a:solidFill>
+                  <a:srgbClr val="6E7A90"/>
+                </a:solidFill>
+              </a:defRPr>
+            </a:pPr>
+            <a:r>
+              <a:rPr sz="975" b="1">
+                <a:solidFill>
+                  <a:srgbClr val="6E7A90"/>
+                </a:solidFill>
+              </a:rPr>
+              <a:t>比较信号，定位责任</a:t>
+            </a:r>
+          </a:p>
+        </p:txBody>
+      </p:sp>
+      <p:sp>
+        <p:nvSpPr>
+          <p:cNvPr id="48" name="node-1">
+            <a:extLst xmlns:a="http://schemas.openxmlformats.org/drawingml/2006/main">
+              <a:ext uri="{FF2B5EF4-FFF2-40B4-BE49-F238E27FC236}">
+                <a16:creationId xmlns:a16="http://schemas.microsoft.com/office/drawing/2014/main" id="{02382F0B-0C88-4EED-A2BD-FA6EE5352A1D}"/>
+              </a:ext>
+            </a:extLst>
+          </p:cNvPr>
+          <p:cNvSpPr>
+            <a:spLocks xmlns:a="http://schemas.openxmlformats.org/drawingml/2006/main" noGrp="1"/>
+          </p:cNvSpPr>
+          <p:nvPr/>
+        </p:nvSpPr>
+        <p:spPr>
+          <a:xfrm xmlns:a="http://schemas.openxmlformats.org/drawingml/2006/main">
+            <a:off x="1790700" y="2133600"/>
+            <a:ext cx="609600" cy="609600"/>
+          </a:xfrm>
+          <a:prstGeom xmlns:a="http://schemas.openxmlformats.org/drawingml/2006/main" prst="roundRect">
+            <a:avLst>
+              <a:gd name="adj" fmla="val 28125"/>
+            </a:avLst>
+          </a:prstGeom>
+          <a:solidFill xmlns:a="http://schemas.openxmlformats.org/drawingml/2006/main">
+            <a:srgbClr val="111C31"/>
+          </a:solidFill>
+          <a:ln xmlns:a="http://schemas.openxmlformats.org/drawingml/2006/main" w="0">
+            <a:noFill/>
+            <a:prstDash val="solid"/>
+          </a:ln>
+        </p:spPr>
+      </p:sp>
+      <p:sp>
+        <p:nvSpPr>
+          <p:cNvPr id="49" name="node-number-1">
+            <a:extLst xmlns:a="http://schemas.openxmlformats.org/drawingml/2006/main">
+              <a:ext uri="{FF2B5EF4-FFF2-40B4-BE49-F238E27FC236}">
+                <a16:creationId xmlns:a16="http://schemas.microsoft.com/office/drawing/2014/main" id="{DD2D366C-3862-4AE8-9D66-FB892F55B8AA}"/>
+              </a:ext>
+            </a:extLst>
+          </p:cNvPr>
+          <p:cNvSpPr>
+            <a:spLocks xmlns:a="http://schemas.openxmlformats.org/drawingml/2006/main" noGrp="1"/>
+          </p:cNvSpPr>
+          <p:nvPr/>
+        </p:nvSpPr>
+        <p:spPr>
+          <a:xfrm xmlns:a="http://schemas.openxmlformats.org/drawingml/2006/main">
+            <a:off x="1790700" y="2133600"/>
+            <a:ext cx="609600" cy="609600"/>
+          </a:xfrm>
+          <a:prstGeom xmlns:a="http://schemas.openxmlformats.org/drawingml/2006/main" prst="rect">
+            <a:avLst/>
+          </a:prstGeom>
+          <a:noFill xmlns:a="http://schemas.openxmlformats.org/drawingml/2006/main"/>
+          <a:ln xmlns:a="http://schemas.openxmlformats.org/drawingml/2006/main" w="0">
+            <a:noFill/>
+            <a:prstDash val="solid"/>
+          </a:ln>
+        </p:spPr>
+        <p:txBody>
+          <a:bodyPr xmlns:a="http://schemas.openxmlformats.org/drawingml/2006/main" wrap="square" lIns="0" tIns="0" rIns="0" bIns="0" anchor="ctr">
+            <a:normAutofit fontScale="100000"/>
+          </a:bodyPr>
+          <a:lstStyle xmlns:a="http://schemas.openxmlformats.org/drawingml/2006/main"/>
+          <a:p xmlns:a="http://schemas.openxmlformats.org/drawingml/2006/main">
+            <a:pPr algn="ctr">
+              <a:defRPr sz="1950" b="1">
+                <a:solidFill>
+                  <a:srgbClr val="FFFFFF"/>
+                </a:solidFill>
+              </a:defRPr>
+            </a:pPr>
+            <a:r>
+              <a:rPr sz="1950" b="1">
+                <a:solidFill>
+                  <a:srgbClr val="FFFFFF"/>
+                </a:solidFill>
+              </a:rPr>
+              <a:t>1</a:t>
+            </a:r>
+          </a:p>
+        </p:txBody>
+      </p:sp>
+      <p:sp>
+        <p:nvSpPr>
+          <p:cNvPr id="50" name="node-title-1">
+            <a:extLst xmlns:a="http://schemas.openxmlformats.org/drawingml/2006/main">
+              <a:ext uri="{FF2B5EF4-FFF2-40B4-BE49-F238E27FC236}">
+                <a16:creationId xmlns:a16="http://schemas.microsoft.com/office/drawing/2014/main" id="{11CF5C54-AB5E-4306-AAF8-F464B1A8603B}"/>
+              </a:ext>
+            </a:extLst>
+          </p:cNvPr>
+          <p:cNvSpPr>
+            <a:spLocks xmlns:a="http://schemas.openxmlformats.org/drawingml/2006/main" noGrp="1"/>
+          </p:cNvSpPr>
+          <p:nvPr/>
+        </p:nvSpPr>
+        <p:spPr>
+          <a:xfrm xmlns:a="http://schemas.openxmlformats.org/drawingml/2006/main">
+            <a:off x="1028700" y="2819400"/>
+            <a:ext cx="2133600" cy="400050"/>
+          </a:xfrm>
+          <a:prstGeom xmlns:a="http://schemas.openxmlformats.org/drawingml/2006/main" prst="rect">
+            <a:avLst/>
+          </a:prstGeom>
+          <a:noFill xmlns:a="http://schemas.openxmlformats.org/drawingml/2006/main"/>
+          <a:ln xmlns:a="http://schemas.openxmlformats.org/drawingml/2006/main" w="0">
+            <a:noFill/>
+            <a:prstDash val="solid"/>
+          </a:ln>
+        </p:spPr>
+        <p:txBody>
+          <a:bodyPr xmlns:a="http://schemas.openxmlformats.org/drawingml/2006/main" wrap="square" lIns="0" tIns="0" rIns="0" bIns="0" anchor="ctr">
+            <a:normAutofit fontScale="100000"/>
+          </a:bodyPr>
+          <a:lstStyle xmlns:a="http://schemas.openxmlformats.org/drawingml/2006/main"/>
+          <a:p xmlns:a="http://schemas.openxmlformats.org/drawingml/2006/main">
+            <a:pPr algn="ctr">
+              <a:defRPr sz="1500" b="1">
+                <a:solidFill>
+                  <a:srgbClr val="111C31"/>
+                </a:solidFill>
+              </a:defRPr>
+            </a:pPr>
+            <a:r>
+              <a:rPr sz="1500" b="1">
+                <a:solidFill>
+                  <a:srgbClr val="111C31"/>
+                </a:solidFill>
+              </a:rPr>
+              <a:t>配置测试任务</a:t>
+            </a:r>
+          </a:p>
+        </p:txBody>
+      </p:sp>
+      <p:sp>
+        <p:nvSpPr>
+          <p:cNvPr id="51" name="node-2">
+            <a:extLst xmlns:a="http://schemas.openxmlformats.org/drawingml/2006/main">
+              <a:ext uri="{FF2B5EF4-FFF2-40B4-BE49-F238E27FC236}">
+                <a16:creationId xmlns:a16="http://schemas.microsoft.com/office/drawing/2014/main" id="{7FD16E6E-FFAB-4B64-8024-291C3229FFF2}"/>
+              </a:ext>
+            </a:extLst>
+          </p:cNvPr>
+          <p:cNvSpPr>
+            <a:spLocks xmlns:a="http://schemas.openxmlformats.org/drawingml/2006/main" noGrp="1"/>
+          </p:cNvSpPr>
+          <p:nvPr/>
+        </p:nvSpPr>
+        <p:spPr>
+          <a:xfrm xmlns:a="http://schemas.openxmlformats.org/drawingml/2006/main">
+            <a:off x="5791200" y="2133600"/>
+            <a:ext cx="609600" cy="609600"/>
+          </a:xfrm>
+          <a:prstGeom xmlns:a="http://schemas.openxmlformats.org/drawingml/2006/main" prst="roundRect">
+            <a:avLst>
+              <a:gd name="adj" fmla="val 28125"/>
+            </a:avLst>
+          </a:prstGeom>
+          <a:solidFill xmlns:a="http://schemas.openxmlformats.org/drawingml/2006/main">
+            <a:srgbClr val="111C31"/>
+          </a:solidFill>
+          <a:ln xmlns:a="http://schemas.openxmlformats.org/drawingml/2006/main" w="0">
+            <a:noFill/>
+            <a:prstDash val="solid"/>
+          </a:ln>
+        </p:spPr>
+      </p:sp>
+      <p:sp>
+        <p:nvSpPr>
+          <p:cNvPr id="52" name="node-number-2">
+            <a:extLst xmlns:a="http://schemas.openxmlformats.org/drawingml/2006/main">
+              <a:ext uri="{FF2B5EF4-FFF2-40B4-BE49-F238E27FC236}">
+                <a16:creationId xmlns:a16="http://schemas.microsoft.com/office/drawing/2014/main" id="{353FAA51-7E37-40A5-92A5-C1DB9A55DB39}"/>
+              </a:ext>
+            </a:extLst>
+          </p:cNvPr>
+          <p:cNvSpPr>
+            <a:spLocks xmlns:a="http://schemas.openxmlformats.org/drawingml/2006/main" noGrp="1"/>
+          </p:cNvSpPr>
+          <p:nvPr/>
+        </p:nvSpPr>
+        <p:spPr>
+          <a:xfrm xmlns:a="http://schemas.openxmlformats.org/drawingml/2006/main">
+            <a:off x="5791200" y="2133600"/>
+            <a:ext cx="609600" cy="609600"/>
+          </a:xfrm>
+          <a:prstGeom xmlns:a="http://schemas.openxmlformats.org/drawingml/2006/main" prst="rect">
+            <a:avLst/>
+          </a:prstGeom>
+          <a:noFill xmlns:a="http://schemas.openxmlformats.org/drawingml/2006/main"/>
+          <a:ln xmlns:a="http://schemas.openxmlformats.org/drawingml/2006/main" w="0">
+            <a:noFill/>
+            <a:prstDash val="solid"/>
+          </a:ln>
+        </p:spPr>
+        <p:txBody>
+          <a:bodyPr xmlns:a="http://schemas.openxmlformats.org/drawingml/2006/main" wrap="square" lIns="0" tIns="0" rIns="0" bIns="0" anchor="ctr">
+            <a:normAutofit fontScale="100000"/>
+          </a:bodyPr>
+          <a:lstStyle xmlns:a="http://schemas.openxmlformats.org/drawingml/2006/main"/>
+          <a:p xmlns:a="http://schemas.openxmlformats.org/drawingml/2006/main">
+            <a:pPr algn="ctr">
+              <a:defRPr sz="1950" b="1">
+                <a:solidFill>
+                  <a:srgbClr val="FFFFFF"/>
+                </a:solidFill>
+              </a:defRPr>
+            </a:pPr>
+            <a:r>
+              <a:rPr sz="1950" b="1">
+                <a:solidFill>
+                  <a:srgbClr val="FFFFFF"/>
+                </a:solidFill>
+              </a:rPr>
+              <a:t>2</a:t>
+            </a:r>
+          </a:p>
+        </p:txBody>
+      </p:sp>
+      <p:sp>
+        <p:nvSpPr>
+          <p:cNvPr id="53" name="node-title-2">
+            <a:extLst xmlns:a="http://schemas.openxmlformats.org/drawingml/2006/main">
+              <a:ext uri="{FF2B5EF4-FFF2-40B4-BE49-F238E27FC236}">
+                <a16:creationId xmlns:a16="http://schemas.microsoft.com/office/drawing/2014/main" id="{CF81628D-7607-41B7-AD09-1B4E96E7E33D}"/>
+              </a:ext>
+            </a:extLst>
+          </p:cNvPr>
+          <p:cNvSpPr>
+            <a:spLocks xmlns:a="http://schemas.openxmlformats.org/drawingml/2006/main" noGrp="1"/>
+          </p:cNvSpPr>
+          <p:nvPr/>
+        </p:nvSpPr>
+        <p:spPr>
+          <a:xfrm xmlns:a="http://schemas.openxmlformats.org/drawingml/2006/main">
+            <a:off x="5029200" y="2819400"/>
+            <a:ext cx="2133600" cy="400050"/>
+          </a:xfrm>
+          <a:prstGeom xmlns:a="http://schemas.openxmlformats.org/drawingml/2006/main" prst="rect">
+            <a:avLst/>
+          </a:prstGeom>
+          <a:noFill xmlns:a="http://schemas.openxmlformats.org/drawingml/2006/main"/>
+          <a:ln xmlns:a="http://schemas.openxmlformats.org/drawingml/2006/main" w="0">
+            <a:noFill/>
+            <a:prstDash val="solid"/>
+          </a:ln>
+        </p:spPr>
+        <p:txBody>
+          <a:bodyPr xmlns:a="http://schemas.openxmlformats.org/drawingml/2006/main" wrap="square" lIns="0" tIns="0" rIns="0" bIns="0" anchor="ctr">
+            <a:normAutofit fontScale="100000"/>
+          </a:bodyPr>
+          <a:lstStyle xmlns:a="http://schemas.openxmlformats.org/drawingml/2006/main"/>
+          <a:p xmlns:a="http://schemas.openxmlformats.org/drawingml/2006/main">
+            <a:pPr algn="ctr">
+              <a:defRPr sz="1500" b="1">
+                <a:solidFill>
+                  <a:srgbClr val="111C31"/>
+                </a:solidFill>
+              </a:defRPr>
+            </a:pPr>
+            <a:r>
+              <a:rPr sz="1500" b="1">
+                <a:solidFill>
+                  <a:srgbClr val="111C31"/>
+                </a:solidFill>
+              </a:rPr>
+              <a:t>建立评分标准</a:t>
+            </a:r>
+          </a:p>
+        </p:txBody>
+      </p:sp>
+      <p:sp>
+        <p:nvSpPr>
+          <p:cNvPr id="54" name="node-3">
+            <a:extLst xmlns:a="http://schemas.openxmlformats.org/drawingml/2006/main">
+              <a:ext uri="{FF2B5EF4-FFF2-40B4-BE49-F238E27FC236}">
+                <a16:creationId xmlns:a16="http://schemas.microsoft.com/office/drawing/2014/main" id="{DD1A01E4-A1F0-488A-B348-CE820547B791}"/>
+              </a:ext>
+            </a:extLst>
+          </p:cNvPr>
+          <p:cNvSpPr>
+            <a:spLocks xmlns:a="http://schemas.openxmlformats.org/drawingml/2006/main" noGrp="1"/>
+          </p:cNvSpPr>
+          <p:nvPr/>
+        </p:nvSpPr>
+        <p:spPr>
+          <a:xfrm xmlns:a="http://schemas.openxmlformats.org/drawingml/2006/main">
+            <a:off x="9791700" y="2133600"/>
+            <a:ext cx="609600" cy="609600"/>
+          </a:xfrm>
+          <a:prstGeom xmlns:a="http://schemas.openxmlformats.org/drawingml/2006/main" prst="roundRect">
+            <a:avLst>
+              <a:gd name="adj" fmla="val 28125"/>
+            </a:avLst>
+          </a:prstGeom>
+          <a:solidFill xmlns:a="http://schemas.openxmlformats.org/drawingml/2006/main">
+            <a:srgbClr val="111C31"/>
+          </a:solidFill>
+          <a:ln xmlns:a="http://schemas.openxmlformats.org/drawingml/2006/main" w="0">
+            <a:noFill/>
+            <a:prstDash val="solid"/>
+          </a:ln>
+        </p:spPr>
+      </p:sp>
+      <p:sp>
+        <p:nvSpPr>
+          <p:cNvPr id="55" name="node-number-3">
+            <a:extLst xmlns:a="http://schemas.openxmlformats.org/drawingml/2006/main">
+              <a:ext uri="{FF2B5EF4-FFF2-40B4-BE49-F238E27FC236}">
+                <a16:creationId xmlns:a16="http://schemas.microsoft.com/office/drawing/2014/main" id="{C6AAF6E3-895F-476E-AF6B-84FEC9956ACC}"/>
+              </a:ext>
+            </a:extLst>
+          </p:cNvPr>
+          <p:cNvSpPr>
+            <a:spLocks xmlns:a="http://schemas.openxmlformats.org/drawingml/2006/main" noGrp="1"/>
+          </p:cNvSpPr>
+          <p:nvPr/>
+        </p:nvSpPr>
+        <p:spPr>
+          <a:xfrm xmlns:a="http://schemas.openxmlformats.org/drawingml/2006/main">
+            <a:off x="9791700" y="2133600"/>
+            <a:ext cx="609600" cy="609600"/>
+          </a:xfrm>
+          <a:prstGeom xmlns:a="http://schemas.openxmlformats.org/drawingml/2006/main" prst="rect">
+            <a:avLst/>
+          </a:prstGeom>
+          <a:noFill xmlns:a="http://schemas.openxmlformats.org/drawingml/2006/main"/>
+          <a:ln xmlns:a="http://schemas.openxmlformats.org/drawingml/2006/main" w="0">
+            <a:noFill/>
+            <a:prstDash val="solid"/>
+          </a:ln>
+        </p:spPr>
+        <p:txBody>
+          <a:bodyPr xmlns:a="http://schemas.openxmlformats.org/drawingml/2006/main" wrap="square" lIns="0" tIns="0" rIns="0" bIns="0" anchor="ctr">
+            <a:normAutofit fontScale="100000"/>
+          </a:bodyPr>
+          <a:lstStyle xmlns:a="http://schemas.openxmlformats.org/drawingml/2006/main"/>
+          <a:p xmlns:a="http://schemas.openxmlformats.org/drawingml/2006/main">
+            <a:pPr algn="ctr">
+              <a:defRPr sz="1950" b="1">
+                <a:solidFill>
+                  <a:srgbClr val="FFFFFF"/>
+                </a:solidFill>
+              </a:defRPr>
+            </a:pPr>
+            <a:r>
+              <a:rPr sz="1950" b="1">
+                <a:solidFill>
+                  <a:srgbClr val="FFFFFF"/>
+                </a:solidFill>
+              </a:rPr>
+              <a:t>3</a:t>
+            </a:r>
+          </a:p>
+        </p:txBody>
+      </p:sp>
+      <p:sp>
+        <p:nvSpPr>
+          <p:cNvPr id="56" name="node-title-3">
+            <a:extLst xmlns:a="http://schemas.openxmlformats.org/drawingml/2006/main">
+              <a:ext uri="{FF2B5EF4-FFF2-40B4-BE49-F238E27FC236}">
+                <a16:creationId xmlns:a16="http://schemas.microsoft.com/office/drawing/2014/main" id="{A7F9E758-2EDC-4F10-A1E6-AE90FFA22162}"/>
+              </a:ext>
+            </a:extLst>
+          </p:cNvPr>
+          <p:cNvSpPr>
+            <a:spLocks xmlns:a="http://schemas.openxmlformats.org/drawingml/2006/main" noGrp="1"/>
+          </p:cNvSpPr>
+          <p:nvPr/>
+        </p:nvSpPr>
+        <p:spPr>
+          <a:xfrm xmlns:a="http://schemas.openxmlformats.org/drawingml/2006/main">
+            <a:off x="9029700" y="2819400"/>
+            <a:ext cx="2133600" cy="400050"/>
+          </a:xfrm>
+          <a:prstGeom xmlns:a="http://schemas.openxmlformats.org/drawingml/2006/main" prst="rect">
+            <a:avLst/>
+          </a:prstGeom>
+          <a:noFill xmlns:a="http://schemas.openxmlformats.org/drawingml/2006/main"/>
+          <a:ln xmlns:a="http://schemas.openxmlformats.org/drawingml/2006/main" w="0">
+            <a:noFill/>
+            <a:prstDash val="solid"/>
+          </a:ln>
+        </p:spPr>
+        <p:txBody>
+          <a:bodyPr xmlns:a="http://schemas.openxmlformats.org/drawingml/2006/main" wrap="square" lIns="0" tIns="0" rIns="0" bIns="0" anchor="ctr">
+            <a:normAutofit fontScale="100000"/>
+          </a:bodyPr>
+          <a:lstStyle xmlns:a="http://schemas.openxmlformats.org/drawingml/2006/main"/>
+          <a:p xmlns:a="http://schemas.openxmlformats.org/drawingml/2006/main">
+            <a:pPr algn="ctr">
+              <a:defRPr sz="1500" b="1">
+                <a:solidFill>
+                  <a:srgbClr val="111C31"/>
+                </a:solidFill>
+              </a:defRPr>
+            </a:pPr>
+            <a:r>
+              <a:rPr sz="1500" b="1">
+                <a:solidFill>
+                  <a:srgbClr val="111C31"/>
+                </a:solidFill>
+              </a:rPr>
+              <a:t>测试外呼模型</a:t>
+            </a:r>
+          </a:p>
+        </p:txBody>
+      </p:sp>
+      <p:sp>
+        <p:nvSpPr>
+          <p:cNvPr id="57" name="node-4">
+            <a:extLst xmlns:a="http://schemas.openxmlformats.org/drawingml/2006/main">
+              <a:ext uri="{FF2B5EF4-FFF2-40B4-BE49-F238E27FC236}">
+                <a16:creationId xmlns:a16="http://schemas.microsoft.com/office/drawing/2014/main" id="{E0D91AC4-85F2-4D9A-95AD-0C1CF784C170}"/>
+              </a:ext>
+            </a:extLst>
+          </p:cNvPr>
+          <p:cNvSpPr>
+            <a:spLocks xmlns:a="http://schemas.openxmlformats.org/drawingml/2006/main" noGrp="1"/>
+          </p:cNvSpPr>
+          <p:nvPr/>
+        </p:nvSpPr>
+        <p:spPr>
+          <a:xfrm xmlns:a="http://schemas.openxmlformats.org/drawingml/2006/main">
+            <a:off x="9791700" y="4000500"/>
+            <a:ext cx="609600" cy="609600"/>
+          </a:xfrm>
+          <a:prstGeom xmlns:a="http://schemas.openxmlformats.org/drawingml/2006/main" prst="roundRect">
+            <a:avLst>
+              <a:gd name="adj" fmla="val 28125"/>
+            </a:avLst>
+          </a:prstGeom>
+          <a:solidFill xmlns:a="http://schemas.openxmlformats.org/drawingml/2006/main">
+            <a:srgbClr val="FFC300"/>
+          </a:solidFill>
+          <a:ln xmlns:a="http://schemas.openxmlformats.org/drawingml/2006/main" w="0">
+            <a:noFill/>
+            <a:prstDash val="solid"/>
+          </a:ln>
+        </p:spPr>
+      </p:sp>
+      <p:sp>
+        <p:nvSpPr>
+          <p:cNvPr id="58" name="node-number-4">
+            <a:extLst xmlns:a="http://schemas.openxmlformats.org/drawingml/2006/main">
+              <a:ext uri="{FF2B5EF4-FFF2-40B4-BE49-F238E27FC236}">
+                <a16:creationId xmlns:a16="http://schemas.microsoft.com/office/drawing/2014/main" id="{63258A44-D205-4F25-A715-FB61F4960B18}"/>
+              </a:ext>
+            </a:extLst>
+          </p:cNvPr>
+          <p:cNvSpPr>
+            <a:spLocks xmlns:a="http://schemas.openxmlformats.org/drawingml/2006/main" noGrp="1"/>
+          </p:cNvSpPr>
+          <p:nvPr/>
+        </p:nvSpPr>
+        <p:spPr>
+          <a:xfrm xmlns:a="http://schemas.openxmlformats.org/drawingml/2006/main">
+            <a:off x="9791700" y="4000500"/>
+            <a:ext cx="609600" cy="609600"/>
+          </a:xfrm>
+          <a:prstGeom xmlns:a="http://schemas.openxmlformats.org/drawingml/2006/main" prst="rect">
+            <a:avLst/>
+          </a:prstGeom>
+          <a:noFill xmlns:a="http://schemas.openxmlformats.org/drawingml/2006/main"/>
+          <a:ln xmlns:a="http://schemas.openxmlformats.org/drawingml/2006/main" w="0">
+            <a:noFill/>
+            <a:prstDash val="solid"/>
+          </a:ln>
+        </p:spPr>
+        <p:txBody>
+          <a:bodyPr xmlns:a="http://schemas.openxmlformats.org/drawingml/2006/main" wrap="square" lIns="0" tIns="0" rIns="0" bIns="0" anchor="ctr">
+            <a:normAutofit fontScale="100000"/>
+          </a:bodyPr>
+          <a:lstStyle xmlns:a="http://schemas.openxmlformats.org/drawingml/2006/main"/>
+          <a:p xmlns:a="http://schemas.openxmlformats.org/drawingml/2006/main">
+            <a:pPr algn="ctr">
+              <a:defRPr sz="1950" b="1">
+                <a:solidFill>
+                  <a:srgbClr val="111C31"/>
+                </a:solidFill>
+              </a:defRPr>
+            </a:pPr>
+            <a:r>
+              <a:rPr sz="1950" b="1">
+                <a:solidFill>
+                  <a:srgbClr val="111C31"/>
+                </a:solidFill>
+              </a:rPr>
+              <a:t>4</a:t>
+            </a:r>
+          </a:p>
+        </p:txBody>
+      </p:sp>
+      <p:sp>
+        <p:nvSpPr>
+          <p:cNvPr id="59" name="node-title-4">
+            <a:extLst xmlns:a="http://schemas.openxmlformats.org/drawingml/2006/main">
+              <a:ext uri="{FF2B5EF4-FFF2-40B4-BE49-F238E27FC236}">
+                <a16:creationId xmlns:a16="http://schemas.microsoft.com/office/drawing/2014/main" id="{F86759BB-574D-43F9-9C8E-C7044D4938E7}"/>
+              </a:ext>
+            </a:extLst>
+          </p:cNvPr>
+          <p:cNvSpPr>
+            <a:spLocks xmlns:a="http://schemas.openxmlformats.org/drawingml/2006/main" noGrp="1"/>
+          </p:cNvSpPr>
+          <p:nvPr/>
+        </p:nvSpPr>
+        <p:spPr>
+          <a:xfrm xmlns:a="http://schemas.openxmlformats.org/drawingml/2006/main">
+            <a:off x="9029700" y="4686300"/>
+            <a:ext cx="2133600" cy="400050"/>
+          </a:xfrm>
+          <a:prstGeom xmlns:a="http://schemas.openxmlformats.org/drawingml/2006/main" prst="rect">
+            <a:avLst/>
+          </a:prstGeom>
+          <a:noFill xmlns:a="http://schemas.openxmlformats.org/drawingml/2006/main"/>
+          <a:ln xmlns:a="http://schemas.openxmlformats.org/drawingml/2006/main" w="0">
+            <a:noFill/>
+            <a:prstDash val="solid"/>
+          </a:ln>
+        </p:spPr>
+        <p:txBody>
+          <a:bodyPr xmlns:a="http://schemas.openxmlformats.org/drawingml/2006/main" wrap="square" lIns="0" tIns="0" rIns="0" bIns="0" anchor="ctr">
+            <a:normAutofit fontScale="100000"/>
+          </a:bodyPr>
+          <a:lstStyle xmlns:a="http://schemas.openxmlformats.org/drawingml/2006/main"/>
+          <a:p xmlns:a="http://schemas.openxmlformats.org/drawingml/2006/main">
+            <a:pPr algn="ctr">
+              <a:defRPr sz="1500" b="1">
+                <a:solidFill>
+                  <a:srgbClr val="111C31"/>
+                </a:solidFill>
+              </a:defRPr>
+            </a:pPr>
+            <a:r>
+              <a:rPr sz="1500" b="1">
+                <a:solidFill>
+                  <a:srgbClr val="111C31"/>
+                </a:solidFill>
+              </a:rPr>
+              <a:t>输出模型评测报告</a:t>
+            </a:r>
+          </a:p>
+        </p:txBody>
+      </p:sp>
+      <p:sp>
+        <p:nvSpPr>
+          <p:cNvPr id="60" name="node-5">
+            <a:extLst xmlns:a="http://schemas.openxmlformats.org/drawingml/2006/main">
+              <a:ext uri="{FF2B5EF4-FFF2-40B4-BE49-F238E27FC236}">
+                <a16:creationId xmlns:a16="http://schemas.microsoft.com/office/drawing/2014/main" id="{F3B769D1-2794-4A05-9920-BF6D55ECFE70}"/>
+              </a:ext>
+            </a:extLst>
+          </p:cNvPr>
+          <p:cNvSpPr>
+            <a:spLocks xmlns:a="http://schemas.openxmlformats.org/drawingml/2006/main" noGrp="1"/>
+          </p:cNvSpPr>
+          <p:nvPr/>
+        </p:nvSpPr>
+        <p:spPr>
+          <a:xfrm xmlns:a="http://schemas.openxmlformats.org/drawingml/2006/main">
+            <a:off x="5791200" y="4000500"/>
+            <a:ext cx="609600" cy="609600"/>
+          </a:xfrm>
+          <a:prstGeom xmlns:a="http://schemas.openxmlformats.org/drawingml/2006/main" prst="roundRect">
+            <a:avLst>
+              <a:gd name="adj" fmla="val 28125"/>
+            </a:avLst>
+          </a:prstGeom>
+          <a:solidFill xmlns:a="http://schemas.openxmlformats.org/drawingml/2006/main">
+            <a:srgbClr val="111C31"/>
+          </a:solidFill>
+          <a:ln xmlns:a="http://schemas.openxmlformats.org/drawingml/2006/main" w="0">
+            <a:noFill/>
+            <a:prstDash val="solid"/>
+          </a:ln>
+        </p:spPr>
+      </p:sp>
+      <p:sp>
+        <p:nvSpPr>
+          <p:cNvPr id="61" name="node-number-5">
+            <a:extLst xmlns:a="http://schemas.openxmlformats.org/drawingml/2006/main">
+              <a:ext uri="{FF2B5EF4-FFF2-40B4-BE49-F238E27FC236}">
+                <a16:creationId xmlns:a16="http://schemas.microsoft.com/office/drawing/2014/main" id="{882FA535-9930-4F88-8F68-FA0EBDCE9C5F}"/>
+              </a:ext>
+            </a:extLst>
+          </p:cNvPr>
+          <p:cNvSpPr>
+            <a:spLocks xmlns:a="http://schemas.openxmlformats.org/drawingml/2006/main" noGrp="1"/>
+          </p:cNvSpPr>
+          <p:nvPr/>
+        </p:nvSpPr>
+        <p:spPr>
+          <a:xfrm xmlns:a="http://schemas.openxmlformats.org/drawingml/2006/main">
+            <a:off x="5791200" y="4000500"/>
+            <a:ext cx="609600" cy="609600"/>
+          </a:xfrm>
+          <a:prstGeom xmlns:a="http://schemas.openxmlformats.org/drawingml/2006/main" prst="rect">
+            <a:avLst/>
+          </a:prstGeom>
+          <a:noFill xmlns:a="http://schemas.openxmlformats.org/drawingml/2006/main"/>
+          <a:ln xmlns:a="http://schemas.openxmlformats.org/drawingml/2006/main" w="0">
+            <a:noFill/>
+            <a:prstDash val="solid"/>
+          </a:ln>
+        </p:spPr>
+        <p:txBody>
+          <a:bodyPr xmlns:a="http://schemas.openxmlformats.org/drawingml/2006/main" wrap="square" lIns="0" tIns="0" rIns="0" bIns="0" anchor="ctr">
+            <a:normAutofit fontScale="100000"/>
+          </a:bodyPr>
+          <a:lstStyle xmlns:a="http://schemas.openxmlformats.org/drawingml/2006/main"/>
+          <a:p xmlns:a="http://schemas.openxmlformats.org/drawingml/2006/main">
+            <a:pPr algn="ctr">
+              <a:defRPr sz="1950" b="1">
+                <a:solidFill>
+                  <a:srgbClr val="FFFFFF"/>
+                </a:solidFill>
+              </a:defRPr>
+            </a:pPr>
+            <a:r>
+              <a:rPr sz="1950" b="1">
+                <a:solidFill>
+                  <a:srgbClr val="FFFFFF"/>
+                </a:solidFill>
+              </a:rPr>
+              <a:t>5</a:t>
+            </a:r>
+          </a:p>
+        </p:txBody>
+      </p:sp>
+      <p:sp>
+        <p:nvSpPr>
+          <p:cNvPr id="62" name="node-title-5">
+            <a:extLst xmlns:a="http://schemas.openxmlformats.org/drawingml/2006/main">
+              <a:ext uri="{FF2B5EF4-FFF2-40B4-BE49-F238E27FC236}">
+                <a16:creationId xmlns:a16="http://schemas.microsoft.com/office/drawing/2014/main" id="{6B0D4D68-414E-4138-9E0F-331EB0A091E5}"/>
+              </a:ext>
+            </a:extLst>
+          </p:cNvPr>
+          <p:cNvSpPr>
+            <a:spLocks xmlns:a="http://schemas.openxmlformats.org/drawingml/2006/main" noGrp="1"/>
+          </p:cNvSpPr>
+          <p:nvPr/>
+        </p:nvSpPr>
+        <p:spPr>
+          <a:xfrm xmlns:a="http://schemas.openxmlformats.org/drawingml/2006/main">
+            <a:off x="5029200" y="4686300"/>
+            <a:ext cx="2133600" cy="400050"/>
+          </a:xfrm>
+          <a:prstGeom xmlns:a="http://schemas.openxmlformats.org/drawingml/2006/main" prst="rect">
+            <a:avLst/>
+          </a:prstGeom>
+          <a:noFill xmlns:a="http://schemas.openxmlformats.org/drawingml/2006/main"/>
+          <a:ln xmlns:a="http://schemas.openxmlformats.org/drawingml/2006/main" w="0">
+            <a:noFill/>
+            <a:prstDash val="solid"/>
+          </a:ln>
+        </p:spPr>
+        <p:txBody>
+          <a:bodyPr xmlns:a="http://schemas.openxmlformats.org/drawingml/2006/main" wrap="square" lIns="0" tIns="0" rIns="0" bIns="0" anchor="ctr">
+            <a:normAutofit fontScale="100000"/>
+          </a:bodyPr>
+          <a:lstStyle xmlns:a="http://schemas.openxmlformats.org/drawingml/2006/main"/>
+          <a:p xmlns:a="http://schemas.openxmlformats.org/drawingml/2006/main">
+            <a:pPr algn="ctr">
+              <a:defRPr sz="1500" b="1">
+                <a:solidFill>
+                  <a:srgbClr val="111C31"/>
+                </a:solidFill>
+              </a:defRPr>
+            </a:pPr>
+            <a:r>
+              <a:rPr sz="1500" b="1">
+                <a:solidFill>
+                  <a:srgbClr val="111C31"/>
+                </a:solidFill>
+              </a:rPr>
+              <a:t>分析失败原因</a:t>
+            </a:r>
+          </a:p>
+        </p:txBody>
+      </p:sp>
+      <p:sp>
+        <p:nvSpPr>
+          <p:cNvPr id="63" name="node-6">
+            <a:extLst xmlns:a="http://schemas.openxmlformats.org/drawingml/2006/main">
+              <a:ext uri="{FF2B5EF4-FFF2-40B4-BE49-F238E27FC236}">
+                <a16:creationId xmlns:a16="http://schemas.microsoft.com/office/drawing/2014/main" id="{8BB69760-1426-4F04-8FAE-AD54F5C664EA}"/>
+              </a:ext>
+            </a:extLst>
+          </p:cNvPr>
+          <p:cNvSpPr>
+            <a:spLocks xmlns:a="http://schemas.openxmlformats.org/drawingml/2006/main" noGrp="1"/>
+          </p:cNvSpPr>
+          <p:nvPr/>
+        </p:nvSpPr>
+        <p:spPr>
+          <a:xfrm xmlns:a="http://schemas.openxmlformats.org/drawingml/2006/main">
+            <a:off x="1790700" y="4000500"/>
+            <a:ext cx="609600" cy="609600"/>
+          </a:xfrm>
+          <a:prstGeom xmlns:a="http://schemas.openxmlformats.org/drawingml/2006/main" prst="roundRect">
+            <a:avLst>
+              <a:gd name="adj" fmla="val 28125"/>
+            </a:avLst>
+          </a:prstGeom>
+          <a:solidFill xmlns:a="http://schemas.openxmlformats.org/drawingml/2006/main">
+            <a:srgbClr val="FFC300"/>
+          </a:solidFill>
+          <a:ln xmlns:a="http://schemas.openxmlformats.org/drawingml/2006/main" w="0">
+            <a:noFill/>
+            <a:prstDash val="solid"/>
+          </a:ln>
+        </p:spPr>
+      </p:sp>
+      <p:sp>
+        <p:nvSpPr>
+          <p:cNvPr id="64" name="node-number-6">
+            <a:extLst xmlns:a="http://schemas.openxmlformats.org/drawingml/2006/main">
+              <a:ext uri="{FF2B5EF4-FFF2-40B4-BE49-F238E27FC236}">
+                <a16:creationId xmlns:a16="http://schemas.microsoft.com/office/drawing/2014/main" id="{7DC90F89-3B5D-4A9E-BBF9-C5682D3B3A88}"/>
+              </a:ext>
+            </a:extLst>
+          </p:cNvPr>
+          <p:cNvSpPr>
+            <a:spLocks xmlns:a="http://schemas.openxmlformats.org/drawingml/2006/main" noGrp="1"/>
+          </p:cNvSpPr>
+          <p:nvPr/>
+        </p:nvSpPr>
+        <p:spPr>
+          <a:xfrm xmlns:a="http://schemas.openxmlformats.org/drawingml/2006/main">
+            <a:off x="1790700" y="4000500"/>
+            <a:ext cx="609600" cy="609600"/>
+          </a:xfrm>
+          <a:prstGeom xmlns:a="http://schemas.openxmlformats.org/drawingml/2006/main" prst="rect">
+            <a:avLst/>
+          </a:prstGeom>
+          <a:noFill xmlns:a="http://schemas.openxmlformats.org/drawingml/2006/main"/>
+          <a:ln xmlns:a="http://schemas.openxmlformats.org/drawingml/2006/main" w="0">
+            <a:noFill/>
+            <a:prstDash val="solid"/>
+          </a:ln>
+        </p:spPr>
+        <p:txBody>
+          <a:bodyPr xmlns:a="http://schemas.openxmlformats.org/drawingml/2006/main" wrap="square" lIns="0" tIns="0" rIns="0" bIns="0" anchor="ctr">
+            <a:normAutofit fontScale="100000"/>
+          </a:bodyPr>
+          <a:lstStyle xmlns:a="http://schemas.openxmlformats.org/drawingml/2006/main"/>
+          <a:p xmlns:a="http://schemas.openxmlformats.org/drawingml/2006/main">
+            <a:pPr algn="ctr">
+              <a:defRPr sz="1950" b="1">
+                <a:solidFill>
+                  <a:srgbClr val="111C31"/>
+                </a:solidFill>
+              </a:defRPr>
+            </a:pPr>
+            <a:r>
+              <a:rPr sz="1950" b="1">
+                <a:solidFill>
+                  <a:srgbClr val="111C31"/>
+                </a:solidFill>
+              </a:rPr>
+              <a:t>6</a:t>
+            </a:r>
+          </a:p>
+        </p:txBody>
+      </p:sp>
+      <p:sp>
+        <p:nvSpPr>
+          <p:cNvPr id="65" name="node-title-6">
+            <a:extLst xmlns:a="http://schemas.openxmlformats.org/drawingml/2006/main">
+              <a:ext uri="{FF2B5EF4-FFF2-40B4-BE49-F238E27FC236}">
+                <a16:creationId xmlns:a16="http://schemas.microsoft.com/office/drawing/2014/main" id="{1B5CCFE9-2A14-4046-9297-2D0A20330CD2}"/>
+              </a:ext>
+            </a:extLst>
+          </p:cNvPr>
+          <p:cNvSpPr>
+            <a:spLocks xmlns:a="http://schemas.openxmlformats.org/drawingml/2006/main" noGrp="1"/>
+          </p:cNvSpPr>
+          <p:nvPr/>
+        </p:nvSpPr>
+        <p:spPr>
+          <a:xfrm xmlns:a="http://schemas.openxmlformats.org/drawingml/2006/main">
+            <a:off x="1028700" y="4686300"/>
+            <a:ext cx="2133600" cy="400050"/>
+          </a:xfrm>
+          <a:prstGeom xmlns:a="http://schemas.openxmlformats.org/drawingml/2006/main" prst="rect">
+            <a:avLst/>
+          </a:prstGeom>
+          <a:noFill xmlns:a="http://schemas.openxmlformats.org/drawingml/2006/main"/>
+          <a:ln xmlns:a="http://schemas.openxmlformats.org/drawingml/2006/main" w="0">
+            <a:noFill/>
+            <a:prstDash val="solid"/>
+          </a:ln>
+        </p:spPr>
+        <p:txBody>
+          <a:bodyPr xmlns:a="http://schemas.openxmlformats.org/drawingml/2006/main" wrap="square" lIns="0" tIns="0" rIns="0" bIns="0" anchor="ctr">
+            <a:normAutofit fontScale="100000"/>
+          </a:bodyPr>
+          <a:lstStyle xmlns:a="http://schemas.openxmlformats.org/drawingml/2006/main"/>
+          <a:p xmlns:a="http://schemas.openxmlformats.org/drawingml/2006/main">
+            <a:pPr algn="ctr">
+              <a:defRPr sz="1500" b="1">
+                <a:solidFill>
+                  <a:srgbClr val="111C31"/>
+                </a:solidFill>
+              </a:defRPr>
+            </a:pPr>
+            <a:r>
+              <a:rPr sz="1500" b="1">
+                <a:solidFill>
+                  <a:srgbClr val="111C31"/>
+                </a:solidFill>
+              </a:rPr>
+              <a:t>优化与同尺回归</a:t>
+            </a:r>
+          </a:p>
+        </p:txBody>
+      </p:sp>
+      <p:sp>
+        <p:nvSpPr>
+          <p:cNvPr id="66" name="loop-band">
+            <a:extLst xmlns:a="http://schemas.openxmlformats.org/drawingml/2006/main">
+              <a:ext uri="{FF2B5EF4-FFF2-40B4-BE49-F238E27FC236}">
+                <a16:creationId xmlns:a16="http://schemas.microsoft.com/office/drawing/2014/main" id="{A5606C01-E9B1-4C95-A1D4-5B640CC911F8}"/>
+              </a:ext>
+            </a:extLst>
+          </p:cNvPr>
+          <p:cNvSpPr>
+            <a:spLocks xmlns:a="http://schemas.openxmlformats.org/drawingml/2006/main" noGrp="1"/>
+          </p:cNvSpPr>
+          <p:nvPr/>
+        </p:nvSpPr>
+        <p:spPr>
+          <a:xfrm xmlns:a="http://schemas.openxmlformats.org/drawingml/2006/main">
+            <a:off x="3143250" y="5410200"/>
+            <a:ext cx="6858000" cy="476250"/>
+          </a:xfrm>
+          <a:prstGeom xmlns:a="http://schemas.openxmlformats.org/drawingml/2006/main" prst="roundRect">
+            <a:avLst>
+              <a:gd name="adj" fmla="val 32000"/>
+            </a:avLst>
+          </a:prstGeom>
+          <a:solidFill xmlns:a="http://schemas.openxmlformats.org/drawingml/2006/main">
+            <a:srgbClr val="FFF4BD"/>
+          </a:solidFill>
+          <a:ln xmlns:a="http://schemas.openxmlformats.org/drawingml/2006/main" w="0">
+            <a:noFill/>
+            <a:prstDash val="solid"/>
+          </a:ln>
+        </p:spPr>
+      </p:sp>
+      <p:sp>
+        <p:nvSpPr>
+          <p:cNvPr id="67" name="loop-copy">
+            <a:extLst xmlns:a="http://schemas.openxmlformats.org/drawingml/2006/main">
+              <a:ext uri="{FF2B5EF4-FFF2-40B4-BE49-F238E27FC236}">
+                <a16:creationId xmlns:a16="http://schemas.microsoft.com/office/drawing/2014/main" id="{B288B09B-9034-40A3-A71A-E90FE0FC6570}"/>
+              </a:ext>
+            </a:extLst>
+          </p:cNvPr>
+          <p:cNvSpPr>
+            <a:spLocks xmlns:a="http://schemas.openxmlformats.org/drawingml/2006/main" noGrp="1"/>
+          </p:cNvSpPr>
+          <p:nvPr/>
+        </p:nvSpPr>
+        <p:spPr>
+          <a:xfrm xmlns:a="http://schemas.openxmlformats.org/drawingml/2006/main">
+            <a:off x="3333750" y="5410200"/>
+            <a:ext cx="6477000" cy="476250"/>
+          </a:xfrm>
+          <a:prstGeom xmlns:a="http://schemas.openxmlformats.org/drawingml/2006/main" prst="rect">
+            <a:avLst/>
+          </a:prstGeom>
+          <a:noFill xmlns:a="http://schemas.openxmlformats.org/drawingml/2006/main"/>
+          <a:ln xmlns:a="http://schemas.openxmlformats.org/drawingml/2006/main" w="0">
+            <a:noFill/>
+            <a:prstDash val="solid"/>
+          </a:ln>
+        </p:spPr>
+        <p:txBody>
+          <a:bodyPr xmlns:a="http://schemas.openxmlformats.org/drawingml/2006/main" wrap="square" lIns="0" tIns="0" rIns="0" bIns="0" anchor="ctr">
+            <a:normAutofit fontScale="100000"/>
+          </a:bodyPr>
+          <a:lstStyle xmlns:a="http://schemas.openxmlformats.org/drawingml/2006/main"/>
+          <a:p xmlns:a="http://schemas.openxmlformats.org/drawingml/2006/main">
+            <a:pPr algn="ctr">
+              <a:defRPr sz="1350" b="1">
+                <a:solidFill>
+                  <a:srgbClr val="111C31"/>
+                </a:solidFill>
+              </a:defRPr>
+            </a:pPr>
+            <a:r>
+              <a:rPr sz="1350" b="1">
+                <a:solidFill>
+                  <a:srgbClr val="111C31"/>
+                </a:solidFill>
+              </a:rPr>
+              <a:t>↻  只改责任对象 · 锁定同一把尺 · 返回第3步重新测试</a:t>
+            </a:r>
+          </a:p>
+        </p:txBody>
+      </p:sp>
+      <p:sp>
+        <p:nvSpPr>
+          <p:cNvPr id="68" name="loop-in">
+            <a:extLst xmlns:a="http://schemas.openxmlformats.org/drawingml/2006/main">
+              <a:ext uri="{FF2B5EF4-FFF2-40B4-BE49-F238E27FC236}">
+                <a16:creationId xmlns:a16="http://schemas.microsoft.com/office/drawing/2014/main" id="{4E47B5C4-E282-44C4-B4FD-6E9D79E04AAF}"/>
+              </a:ext>
+            </a:extLst>
+          </p:cNvPr>
+          <p:cNvSpPr>
+            <a:spLocks xmlns:a="http://schemas.openxmlformats.org/drawingml/2006/main" noGrp="1"/>
+          </p:cNvSpPr>
+          <p:nvPr/>
+        </p:nvSpPr>
+        <p:spPr>
+          <a:xfrm xmlns:a="http://schemas.openxmlformats.org/drawingml/2006/main">
+            <a:off x="2381250" y="5562600"/>
+            <a:ext cx="723900" cy="171450"/>
+          </a:xfrm>
+          <a:prstGeom xmlns:a="http://schemas.openxmlformats.org/drawingml/2006/main" prst="rightArrow">
+            <a:avLst/>
+          </a:prstGeom>
+          <a:solidFill xmlns:a="http://schemas.openxmlformats.org/drawingml/2006/main">
+            <a:srgbClr val="FFC300"/>
+          </a:solidFill>
+          <a:ln xmlns:a="http://schemas.openxmlformats.org/drawingml/2006/main" w="0">
+            <a:noFill/>
+            <a:prstDash val="solid"/>
+          </a:ln>
+        </p:spPr>
+      </p:sp>
+      <p:sp>
+        <p:nvSpPr>
+          <p:cNvPr id="69" name="loop-out">
+            <a:extLst xmlns:a="http://schemas.openxmlformats.org/drawingml/2006/main">
+              <a:ext uri="{FF2B5EF4-FFF2-40B4-BE49-F238E27FC236}">
+                <a16:creationId xmlns:a16="http://schemas.microsoft.com/office/drawing/2014/main" id="{9E116495-D445-4126-9464-A8BF26AFD992}"/>
+              </a:ext>
+            </a:extLst>
+          </p:cNvPr>
+          <p:cNvSpPr>
+            <a:spLocks xmlns:a="http://schemas.openxmlformats.org/drawingml/2006/main" noGrp="1"/>
+          </p:cNvSpPr>
+          <p:nvPr/>
+        </p:nvSpPr>
+        <p:spPr>
+          <a:xfrm xmlns:a="http://schemas.openxmlformats.org/drawingml/2006/main">
+            <a:off x="10039350" y="4933950"/>
+            <a:ext cx="228600" cy="685800"/>
+          </a:xfrm>
+          <a:prstGeom xmlns:a="http://schemas.openxmlformats.org/drawingml/2006/main" prst="upArrow">
+            <a:avLst/>
+          </a:prstGeom>
+          <a:solidFill xmlns:a="http://schemas.openxmlformats.org/drawingml/2006/main">
+            <a:srgbClr val="FFC300"/>
+          </a:solidFill>
+          <a:ln xmlns:a="http://schemas.openxmlformats.org/drawingml/2006/main" w="0">
+            <a:noFill/>
+            <a:prstDash val="solid"/>
+          </a:ln>
+        </p:spPr>
+      </p:sp>
+      <p:sp>
+        <p:nvSpPr>
+          <p:cNvPr id="70" name="page">
+            <a:extLst xmlns:a="http://schemas.openxmlformats.org/drawingml/2006/main">
+              <a:ext uri="{FF2B5EF4-FFF2-40B4-BE49-F238E27FC236}">
+                <a16:creationId xmlns:a16="http://schemas.microsoft.com/office/drawing/2014/main" id="{2EF8497E-5FE8-4075-AB08-3ECB10EF8892}"/>
+              </a:ext>
+            </a:extLst>
+          </p:cNvPr>
+          <p:cNvSpPr>
+            <a:spLocks xmlns:a="http://schemas.openxmlformats.org/drawingml/2006/main" noGrp="1"/>
+          </p:cNvSpPr>
+          <p:nvPr/>
+        </p:nvSpPr>
+        <p:spPr>
+          <a:xfrm xmlns:a="http://schemas.openxmlformats.org/drawingml/2006/main">
+            <a:off x="11144250" y="6419850"/>
+            <a:ext cx="514350" cy="190500"/>
+          </a:xfrm>
+          <a:prstGeom xmlns:a="http://schemas.openxmlformats.org/drawingml/2006/main" prst="rect">
+            <a:avLst/>
+          </a:prstGeom>
+          <a:noFill xmlns:a="http://schemas.openxmlformats.org/drawingml/2006/main"/>
+          <a:ln xmlns:a="http://schemas.openxmlformats.org/drawingml/2006/main" w="0">
+            <a:noFill/>
+            <a:prstDash val="solid"/>
+          </a:ln>
+        </p:spPr>
+        <p:txBody>
+          <a:bodyPr xmlns:a="http://schemas.openxmlformats.org/drawingml/2006/main" wrap="square" lIns="0" tIns="0" rIns="0" bIns="0" anchor="ctr">
+            <a:normAutofit fontScale="100000"/>
+          </a:bodyPr>
+          <a:lstStyle xmlns:a="http://schemas.openxmlformats.org/drawingml/2006/main"/>
+          <a:p xmlns:a="http://schemas.openxmlformats.org/drawingml/2006/main">
+            <a:pPr algn="r">
+              <a:defRPr sz="750" b="0">
+                <a:solidFill>
+                  <a:srgbClr val="6E7A90"/>
+                </a:solidFill>
+              </a:defRPr>
+            </a:pPr>
+            <a:r>
+              <a:rPr sz="750" b="0">
+                <a:solidFill>
+                  <a:srgbClr val="6E7A90"/>
+                </a:solidFill>
+              </a:rPr>
+              <a:t>03</a:t>
             </a:r>
           </a:p>
         </p:txBody>
@@ -6124,14 +6118,14 @@
       </p:sp>
       <p:pic>
         <p:nvPicPr>
-          <p:cNvPr id="41" name=""/>
+          <p:cNvPr id="42" name=""/>
           <p:cNvPicPr>
             <a:picLocks xmlns:a="http://schemas.openxmlformats.org/drawingml/2006/main" noChangeAspect="1"/>
           </p:cNvPicPr>
           <p:nvPr/>
         </p:nvPicPr>
         <p:blipFill>
-          <a:blip xmlns:r="http://schemas.openxmlformats.org/officeDocument/2006/relationships" xmlns:a="http://schemas.openxmlformats.org/drawingml/2006/main" r:embed="R40f1130f7a0f4557"/>
+          <a:blip xmlns:r="http://schemas.openxmlformats.org/officeDocument/2006/relationships" xmlns:a="http://schemas.openxmlformats.org/drawingml/2006/main" r:embed="R8085ad5ec3224e6e"/>
           <a:srcRect xmlns:a="http://schemas.openxmlformats.org/drawingml/2006/main" l="0" t="2174" r="0" b="2174"/>
           <a:stretch xmlns:a="http://schemas.openxmlformats.org/drawingml/2006/main">
             <a:fillRect l="0" t="0" r="0" b="0"/>
@@ -6200,7 +6194,7 @@
                 <a:latin typeface="PingFang SC"/>
                 <a:ea typeface="PingFang SC"/>
                 <a:cs typeface="PingFang SC"/>
-                <a:hlinkClick xmlns:r="http://schemas.openxmlformats.org/officeDocument/2006/relationships" r:id="Rd6b8bc8f5cd04c62"/>
+                <a:hlinkClick xmlns:r="http://schemas.openxmlformats.org/officeDocument/2006/relationships" r:id="R40c1af5816514d7c"/>
               </a:rPr>
               <a:t>▶ 在线 Demo</a:t>
             </a:r>
@@ -6252,7 +6246,7 @@
                 <a:latin typeface="PingFang SC"/>
                 <a:ea typeface="PingFang SC"/>
                 <a:cs typeface="PingFang SC"/>
-                <a:hlinkClick xmlns:r="http://schemas.openxmlformats.org/officeDocument/2006/relationships" r:id="R9d682da392b548a8"/>
+                <a:hlinkClick xmlns:r="http://schemas.openxmlformats.org/officeDocument/2006/relationships" r:id="Re8be0e8d9496440a"/>
               </a:rPr>
               <a:t>结果备份 ↗</a:t>
             </a:r>
@@ -6327,6 +6321,7 @@
           <a:lstStyle xmlns:a="http://schemas.openxmlformats.org/drawingml/2006/main"/>
           <a:p xmlns:a="http://schemas.openxmlformats.org/drawingml/2006/main">
             <a:pPr algn="l">
+              <a:buNone/>
               <a:defRPr sz="1725" b="1">
                 <a:solidFill>
                   <a:srgbClr val="111C31"/>
@@ -6379,6 +6374,7 @@
           <a:lstStyle xmlns:a="http://schemas.openxmlformats.org/drawingml/2006/main"/>
           <a:p xmlns:a="http://schemas.openxmlformats.org/drawingml/2006/main">
             <a:pPr algn="l">
+              <a:buNone/>
               <a:defRPr sz="1238" b="0">
                 <a:solidFill>
                   <a:srgbClr val="6E7A90"/>
@@ -6464,6 +6460,7 @@
           <a:lstStyle xmlns:a="http://schemas.openxmlformats.org/drawingml/2006/main"/>
           <a:p xmlns:a="http://schemas.openxmlformats.org/drawingml/2006/main">
             <a:pPr algn="l">
+              <a:buNone/>
               <a:defRPr sz="1725" b="1">
                 <a:solidFill>
                   <a:srgbClr val="111C31"/>
@@ -6516,6 +6513,7 @@
           <a:lstStyle xmlns:a="http://schemas.openxmlformats.org/drawingml/2006/main"/>
           <a:p xmlns:a="http://schemas.openxmlformats.org/drawingml/2006/main">
             <a:pPr algn="l">
+              <a:buNone/>
               <a:defRPr sz="1238" b="0">
                 <a:solidFill>
                   <a:srgbClr val="6E7A90"/>
@@ -6601,6 +6599,7 @@
           <a:lstStyle xmlns:a="http://schemas.openxmlformats.org/drawingml/2006/main"/>
           <a:p xmlns:a="http://schemas.openxmlformats.org/drawingml/2006/main">
             <a:pPr algn="l">
+              <a:buNone/>
               <a:defRPr sz="1725" b="1">
                 <a:solidFill>
                   <a:srgbClr val="111C31"/>
@@ -6653,6 +6652,7 @@
           <a:lstStyle xmlns:a="http://schemas.openxmlformats.org/drawingml/2006/main"/>
           <a:p xmlns:a="http://schemas.openxmlformats.org/drawingml/2006/main">
             <a:pPr algn="l">
+              <a:buNone/>
               <a:defRPr sz="1238" b="0">
                 <a:solidFill>
                   <a:srgbClr val="6E7A90"/>
@@ -7210,14 +7210,14 @@
       </p:sp>
       <p:pic>
         <p:nvPicPr>
-          <p:cNvPr id="41" name=""/>
+          <p:cNvPr id="42" name=""/>
           <p:cNvPicPr>
             <a:picLocks xmlns:a="http://schemas.openxmlformats.org/drawingml/2006/main" noChangeAspect="1"/>
           </p:cNvPicPr>
           <p:nvPr/>
         </p:nvPicPr>
         <p:blipFill>
-          <a:blip xmlns:r="http://schemas.openxmlformats.org/officeDocument/2006/relationships" xmlns:a="http://schemas.openxmlformats.org/drawingml/2006/main" r:embed="R76bf847efd034428"/>
+          <a:blip xmlns:r="http://schemas.openxmlformats.org/officeDocument/2006/relationships" xmlns:a="http://schemas.openxmlformats.org/drawingml/2006/main" r:embed="R5b9c019baddd46bf"/>
           <a:srcRect xmlns:a="http://schemas.openxmlformats.org/drawingml/2006/main" l="0" t="2174" r="0" b="2174"/>
           <a:stretch xmlns:a="http://schemas.openxmlformats.org/drawingml/2006/main">
             <a:fillRect l="0" t="0" r="0" b="0"/>
@@ -7286,7 +7286,7 @@
                 <a:latin typeface="PingFang SC"/>
                 <a:ea typeface="PingFang SC"/>
                 <a:cs typeface="PingFang SC"/>
-                <a:hlinkClick xmlns:r="http://schemas.openxmlformats.org/officeDocument/2006/relationships" r:id="R146525409b7646cd"/>
+                <a:hlinkClick xmlns:r="http://schemas.openxmlformats.org/officeDocument/2006/relationships" r:id="Rfa8c4044328249f7"/>
               </a:rPr>
               <a:t>▶ 在线 Demo</a:t>
             </a:r>
@@ -7338,7 +7338,7 @@
                 <a:latin typeface="PingFang SC"/>
                 <a:ea typeface="PingFang SC"/>
                 <a:cs typeface="PingFang SC"/>
-                <a:hlinkClick xmlns:r="http://schemas.openxmlformats.org/officeDocument/2006/relationships" r:id="R7760256aa0c64fa5"/>
+                <a:hlinkClick xmlns:r="http://schemas.openxmlformats.org/officeDocument/2006/relationships" r:id="R939a5b3b9b9348a2"/>
               </a:rPr>
               <a:t>结果备份 ↗</a:t>
             </a:r>
@@ -7413,6 +7413,7 @@
           <a:lstStyle xmlns:a="http://schemas.openxmlformats.org/drawingml/2006/main"/>
           <a:p xmlns:a="http://schemas.openxmlformats.org/drawingml/2006/main">
             <a:pPr algn="l">
+              <a:buNone/>
               <a:defRPr sz="1725" b="1">
                 <a:solidFill>
                   <a:srgbClr val="111C31"/>
@@ -7465,6 +7466,7 @@
           <a:lstStyle xmlns:a="http://schemas.openxmlformats.org/drawingml/2006/main"/>
           <a:p xmlns:a="http://schemas.openxmlformats.org/drawingml/2006/main">
             <a:pPr algn="l">
+              <a:buNone/>
               <a:defRPr sz="1238" b="0">
                 <a:solidFill>
                   <a:srgbClr val="6E7A90"/>
@@ -7550,6 +7552,7 @@
           <a:lstStyle xmlns:a="http://schemas.openxmlformats.org/drawingml/2006/main"/>
           <a:p xmlns:a="http://schemas.openxmlformats.org/drawingml/2006/main">
             <a:pPr algn="l">
+              <a:buNone/>
               <a:defRPr sz="1725" b="1">
                 <a:solidFill>
                   <a:srgbClr val="111C31"/>
@@ -7602,6 +7605,7 @@
           <a:lstStyle xmlns:a="http://schemas.openxmlformats.org/drawingml/2006/main"/>
           <a:p xmlns:a="http://schemas.openxmlformats.org/drawingml/2006/main">
             <a:pPr algn="l">
+              <a:buNone/>
               <a:defRPr sz="1238" b="0">
                 <a:solidFill>
                   <a:srgbClr val="6E7A90"/>
@@ -7687,6 +7691,7 @@
           <a:lstStyle xmlns:a="http://schemas.openxmlformats.org/drawingml/2006/main"/>
           <a:p xmlns:a="http://schemas.openxmlformats.org/drawingml/2006/main">
             <a:pPr algn="l">
+              <a:buNone/>
               <a:defRPr sz="1725" b="1">
                 <a:solidFill>
                   <a:srgbClr val="111C31"/>
@@ -7739,6 +7744,7 @@
           <a:lstStyle xmlns:a="http://schemas.openxmlformats.org/drawingml/2006/main"/>
           <a:p xmlns:a="http://schemas.openxmlformats.org/drawingml/2006/main">
             <a:pPr algn="l">
+              <a:buNone/>
               <a:defRPr sz="1238" b="0">
                 <a:solidFill>
                   <a:srgbClr val="6E7A90"/>
@@ -8296,14 +8302,14 @@
       </p:sp>
       <p:pic>
         <p:nvPicPr>
-          <p:cNvPr id="41" name=""/>
+          <p:cNvPr id="42" name=""/>
           <p:cNvPicPr>
             <a:picLocks xmlns:a="http://schemas.openxmlformats.org/drawingml/2006/main" noChangeAspect="1"/>
           </p:cNvPicPr>
           <p:nvPr/>
         </p:nvPicPr>
         <p:blipFill>
-          <a:blip xmlns:r="http://schemas.openxmlformats.org/officeDocument/2006/relationships" xmlns:a="http://schemas.openxmlformats.org/drawingml/2006/main" r:embed="Re8c5d0cf7a694fb9"/>
+          <a:blip xmlns:r="http://schemas.openxmlformats.org/officeDocument/2006/relationships" xmlns:a="http://schemas.openxmlformats.org/drawingml/2006/main" r:embed="R66948803f0be472d"/>
           <a:srcRect xmlns:a="http://schemas.openxmlformats.org/drawingml/2006/main" l="0" t="2174" r="0" b="2174"/>
           <a:stretch xmlns:a="http://schemas.openxmlformats.org/drawingml/2006/main">
             <a:fillRect l="0" t="0" r="0" b="0"/>
@@ -8372,7 +8378,7 @@
                 <a:latin typeface="PingFang SC"/>
                 <a:ea typeface="PingFang SC"/>
                 <a:cs typeface="PingFang SC"/>
-                <a:hlinkClick xmlns:r="http://schemas.openxmlformats.org/officeDocument/2006/relationships" r:id="Rfaa5e54138d74062"/>
+                <a:hlinkClick xmlns:r="http://schemas.openxmlformats.org/officeDocument/2006/relationships" r:id="R2b80941209464b7e"/>
               </a:rPr>
               <a:t>▶ 在线跑六步</a:t>
             </a:r>
@@ -8424,7 +8430,7 @@
                 <a:latin typeface="PingFang SC"/>
                 <a:ea typeface="PingFang SC"/>
                 <a:cs typeface="PingFang SC"/>
-                <a:hlinkClick xmlns:r="http://schemas.openxmlformats.org/officeDocument/2006/relationships" r:id="Re0fe6c5662284923"/>
+                <a:hlinkClick xmlns:r="http://schemas.openxmlformats.org/officeDocument/2006/relationships" r:id="R5813971fd8844019"/>
               </a:rPr>
               <a:t>结果备份 ↗</a:t>
             </a:r>
@@ -8499,6 +8505,7 @@
           <a:lstStyle xmlns:a="http://schemas.openxmlformats.org/drawingml/2006/main"/>
           <a:p xmlns:a="http://schemas.openxmlformats.org/drawingml/2006/main">
             <a:pPr algn="l">
+              <a:buNone/>
               <a:defRPr sz="1725" b="1">
                 <a:solidFill>
                   <a:srgbClr val="111C31"/>
@@ -8551,6 +8558,7 @@
           <a:lstStyle xmlns:a="http://schemas.openxmlformats.org/drawingml/2006/main"/>
           <a:p xmlns:a="http://schemas.openxmlformats.org/drawingml/2006/main">
             <a:pPr algn="l">
+              <a:buNone/>
               <a:defRPr sz="1238" b="0">
                 <a:solidFill>
                   <a:srgbClr val="6E7A90"/>
@@ -8636,6 +8644,7 @@
           <a:lstStyle xmlns:a="http://schemas.openxmlformats.org/drawingml/2006/main"/>
           <a:p xmlns:a="http://schemas.openxmlformats.org/drawingml/2006/main">
             <a:pPr algn="l">
+              <a:buNone/>
               <a:defRPr sz="1725" b="1">
                 <a:solidFill>
                   <a:srgbClr val="111C31"/>
@@ -8688,6 +8697,7 @@
           <a:lstStyle xmlns:a="http://schemas.openxmlformats.org/drawingml/2006/main"/>
           <a:p xmlns:a="http://schemas.openxmlformats.org/drawingml/2006/main">
             <a:pPr algn="l">
+              <a:buNone/>
               <a:defRPr sz="1238" b="0">
                 <a:solidFill>
                   <a:srgbClr val="6E7A90"/>
@@ -8773,6 +8783,7 @@
           <a:lstStyle xmlns:a="http://schemas.openxmlformats.org/drawingml/2006/main"/>
           <a:p xmlns:a="http://schemas.openxmlformats.org/drawingml/2006/main">
             <a:pPr algn="l">
+              <a:buNone/>
               <a:defRPr sz="1725" b="1">
                 <a:solidFill>
                   <a:srgbClr val="111C31"/>
@@ -8825,6 +8836,7 @@
           <a:lstStyle xmlns:a="http://schemas.openxmlformats.org/drawingml/2006/main"/>
           <a:p xmlns:a="http://schemas.openxmlformats.org/drawingml/2006/main">
             <a:pPr algn="l">
+              <a:buNone/>
               <a:defRPr sz="1238" b="0">
                 <a:solidFill>
                   <a:srgbClr val="6E7A90"/>
@@ -9382,14 +9394,14 @@
       </p:sp>
       <p:pic>
         <p:nvPicPr>
-          <p:cNvPr id="41" name=""/>
+          <p:cNvPr id="42" name=""/>
           <p:cNvPicPr>
             <a:picLocks xmlns:a="http://schemas.openxmlformats.org/drawingml/2006/main" noChangeAspect="1"/>
           </p:cNvPicPr>
           <p:nvPr/>
         </p:nvPicPr>
         <p:blipFill>
-          <a:blip xmlns:r="http://schemas.openxmlformats.org/officeDocument/2006/relationships" xmlns:a="http://schemas.openxmlformats.org/drawingml/2006/main" r:embed="R17ef752269df43fd"/>
+          <a:blip xmlns:r="http://schemas.openxmlformats.org/officeDocument/2006/relationships" xmlns:a="http://schemas.openxmlformats.org/drawingml/2006/main" r:embed="R2d4913c9b9b34d0a"/>
           <a:srcRect xmlns:a="http://schemas.openxmlformats.org/drawingml/2006/main" l="0" t="8152" r="0" b="8152"/>
           <a:stretch xmlns:a="http://schemas.openxmlformats.org/drawingml/2006/main">
             <a:fillRect l="0" t="0" r="0" b="0"/>
@@ -9458,7 +9470,7 @@
                 <a:latin typeface="PingFang SC"/>
                 <a:ea typeface="PingFang SC"/>
                 <a:cs typeface="PingFang SC"/>
-                <a:hlinkClick xmlns:r="http://schemas.openxmlformats.org/officeDocument/2006/relationships" r:id="R2a9b2d98098e4c29"/>
+                <a:hlinkClick xmlns:r="http://schemas.openxmlformats.org/officeDocument/2006/relationships" r:id="R3070979f640549f9"/>
               </a:rPr>
               <a:t>▶ 在线 Demo</a:t>
             </a:r>
@@ -9510,7 +9522,7 @@
                 <a:latin typeface="PingFang SC"/>
                 <a:ea typeface="PingFang SC"/>
                 <a:cs typeface="PingFang SC"/>
-                <a:hlinkClick xmlns:r="http://schemas.openxmlformats.org/officeDocument/2006/relationships" r:id="R4514b347417642a8"/>
+                <a:hlinkClick xmlns:r="http://schemas.openxmlformats.org/officeDocument/2006/relationships" r:id="R2b84486177f742a0"/>
               </a:rPr>
               <a:t>结果备份 ↗</a:t>
             </a:r>
@@ -9585,6 +9597,7 @@
           <a:lstStyle xmlns:a="http://schemas.openxmlformats.org/drawingml/2006/main"/>
           <a:p xmlns:a="http://schemas.openxmlformats.org/drawingml/2006/main">
             <a:pPr algn="l">
+              <a:buNone/>
               <a:defRPr sz="1725" b="1">
                 <a:solidFill>
                   <a:srgbClr val="111C31"/>
@@ -9637,6 +9650,7 @@
           <a:lstStyle xmlns:a="http://schemas.openxmlformats.org/drawingml/2006/main"/>
           <a:p xmlns:a="http://schemas.openxmlformats.org/drawingml/2006/main">
             <a:pPr algn="l">
+              <a:buNone/>
               <a:defRPr sz="1238" b="0">
                 <a:solidFill>
                   <a:srgbClr val="6E7A90"/>
@@ -9722,6 +9736,7 @@
           <a:lstStyle xmlns:a="http://schemas.openxmlformats.org/drawingml/2006/main"/>
           <a:p xmlns:a="http://schemas.openxmlformats.org/drawingml/2006/main">
             <a:pPr algn="l">
+              <a:buNone/>
               <a:defRPr sz="1725" b="1">
                 <a:solidFill>
                   <a:srgbClr val="111C31"/>
@@ -9774,6 +9789,7 @@
           <a:lstStyle xmlns:a="http://schemas.openxmlformats.org/drawingml/2006/main"/>
           <a:p xmlns:a="http://schemas.openxmlformats.org/drawingml/2006/main">
             <a:pPr algn="l">
+              <a:buNone/>
               <a:defRPr sz="1238" b="0">
                 <a:solidFill>
                   <a:srgbClr val="6E7A90"/>
@@ -9859,6 +9875,7 @@
           <a:lstStyle xmlns:a="http://schemas.openxmlformats.org/drawingml/2006/main"/>
           <a:p xmlns:a="http://schemas.openxmlformats.org/drawingml/2006/main">
             <a:pPr algn="l">
+              <a:buNone/>
               <a:defRPr sz="1725" b="1">
                 <a:solidFill>
                   <a:srgbClr val="111C31"/>
@@ -9911,6 +9928,7 @@
           <a:lstStyle xmlns:a="http://schemas.openxmlformats.org/drawingml/2006/main"/>
           <a:p xmlns:a="http://schemas.openxmlformats.org/drawingml/2006/main">
             <a:pPr algn="l">
+              <a:buNone/>
               <a:defRPr sz="1238" b="0">
                 <a:solidFill>
                   <a:srgbClr val="6E7A90"/>
@@ -10468,14 +10486,14 @@
       </p:sp>
       <p:pic>
         <p:nvPicPr>
-          <p:cNvPr id="41" name=""/>
+          <p:cNvPr id="42" name=""/>
           <p:cNvPicPr>
             <a:picLocks xmlns:a="http://schemas.openxmlformats.org/drawingml/2006/main" noChangeAspect="1"/>
           </p:cNvPicPr>
           <p:nvPr/>
         </p:nvPicPr>
         <p:blipFill>
-          <a:blip xmlns:r="http://schemas.openxmlformats.org/officeDocument/2006/relationships" xmlns:a="http://schemas.openxmlformats.org/drawingml/2006/main" r:embed="R4576bd49b12848c7"/>
+          <a:blip xmlns:r="http://schemas.openxmlformats.org/officeDocument/2006/relationships" xmlns:a="http://schemas.openxmlformats.org/drawingml/2006/main" r:embed="R19db4d48e7554858"/>
           <a:srcRect xmlns:a="http://schemas.openxmlformats.org/drawingml/2006/main" l="0" t="2174" r="0" b="2174"/>
           <a:stretch xmlns:a="http://schemas.openxmlformats.org/drawingml/2006/main">
             <a:fillRect l="0" t="0" r="0" b="0"/>
@@ -10544,7 +10562,7 @@
                 <a:latin typeface="PingFang SC"/>
                 <a:ea typeface="PingFang SC"/>
                 <a:cs typeface="PingFang SC"/>
-                <a:hlinkClick xmlns:r="http://schemas.openxmlformats.org/officeDocument/2006/relationships" r:id="Rc70b3bfbb9cf4f0b"/>
+                <a:hlinkClick xmlns:r="http://schemas.openxmlformats.org/officeDocument/2006/relationships" r:id="Rff31fb86fa01495e"/>
               </a:rPr>
               <a:t>▶ 在线 Demo</a:t>
             </a:r>
@@ -10596,7 +10614,7 @@
                 <a:latin typeface="PingFang SC"/>
                 <a:ea typeface="PingFang SC"/>
                 <a:cs typeface="PingFang SC"/>
-                <a:hlinkClick xmlns:r="http://schemas.openxmlformats.org/officeDocument/2006/relationships" r:id="Rf723d50c0ef74891"/>
+                <a:hlinkClick xmlns:r="http://schemas.openxmlformats.org/officeDocument/2006/relationships" r:id="Rce631c926e3b49e3"/>
               </a:rPr>
               <a:t>结果备份 ↗</a:t>
             </a:r>
@@ -10671,6 +10689,7 @@
           <a:lstStyle xmlns:a="http://schemas.openxmlformats.org/drawingml/2006/main"/>
           <a:p xmlns:a="http://schemas.openxmlformats.org/drawingml/2006/main">
             <a:pPr algn="l">
+              <a:buNone/>
               <a:defRPr sz="1725" b="1">
                 <a:solidFill>
                   <a:srgbClr val="111C31"/>
@@ -10723,6 +10742,7 @@
           <a:lstStyle xmlns:a="http://schemas.openxmlformats.org/drawingml/2006/main"/>
           <a:p xmlns:a="http://schemas.openxmlformats.org/drawingml/2006/main">
             <a:pPr algn="l">
+              <a:buNone/>
               <a:defRPr sz="1238" b="0">
                 <a:solidFill>
                   <a:srgbClr val="6E7A90"/>
@@ -10808,6 +10828,7 @@
           <a:lstStyle xmlns:a="http://schemas.openxmlformats.org/drawingml/2006/main"/>
           <a:p xmlns:a="http://schemas.openxmlformats.org/drawingml/2006/main">
             <a:pPr algn="l">
+              <a:buNone/>
               <a:defRPr sz="1725" b="1">
                 <a:solidFill>
                   <a:srgbClr val="111C31"/>
@@ -10860,6 +10881,7 @@
           <a:lstStyle xmlns:a="http://schemas.openxmlformats.org/drawingml/2006/main"/>
           <a:p xmlns:a="http://schemas.openxmlformats.org/drawingml/2006/main">
             <a:pPr algn="l">
+              <a:buNone/>
               <a:defRPr sz="1238" b="0">
                 <a:solidFill>
                   <a:srgbClr val="6E7A90"/>
@@ -10945,6 +10967,7 @@
           <a:lstStyle xmlns:a="http://schemas.openxmlformats.org/drawingml/2006/main"/>
           <a:p xmlns:a="http://schemas.openxmlformats.org/drawingml/2006/main">
             <a:pPr algn="l">
+              <a:buNone/>
               <a:defRPr sz="1725" b="1">
                 <a:solidFill>
                   <a:srgbClr val="111C31"/>
@@ -10997,6 +11020,7 @@
           <a:lstStyle xmlns:a="http://schemas.openxmlformats.org/drawingml/2006/main"/>
           <a:p xmlns:a="http://schemas.openxmlformats.org/drawingml/2006/main">
             <a:pPr algn="l">
+              <a:buNone/>
               <a:defRPr sz="1238" b="0">
                 <a:solidFill>
                   <a:srgbClr val="6E7A90"/>
@@ -11554,14 +11578,14 @@
       </p:sp>
       <p:pic>
         <p:nvPicPr>
-          <p:cNvPr id="41" name=""/>
+          <p:cNvPr id="42" name=""/>
           <p:cNvPicPr>
             <a:picLocks xmlns:a="http://schemas.openxmlformats.org/drawingml/2006/main" noChangeAspect="1"/>
           </p:cNvPicPr>
           <p:nvPr/>
         </p:nvPicPr>
         <p:blipFill>
-          <a:blip xmlns:r="http://schemas.openxmlformats.org/officeDocument/2006/relationships" xmlns:a="http://schemas.openxmlformats.org/drawingml/2006/main" r:embed="Rc95162b325864c92"/>
+          <a:blip xmlns:r="http://schemas.openxmlformats.org/officeDocument/2006/relationships" xmlns:a="http://schemas.openxmlformats.org/drawingml/2006/main" r:embed="Rfebf4aa03b654fc0"/>
           <a:srcRect xmlns:a="http://schemas.openxmlformats.org/drawingml/2006/main" l="0" t="8152" r="0" b="8152"/>
           <a:stretch xmlns:a="http://schemas.openxmlformats.org/drawingml/2006/main">
             <a:fillRect l="0" t="0" r="0" b="0"/>
@@ -11630,7 +11654,7 @@
                 <a:latin typeface="PingFang SC"/>
                 <a:ea typeface="PingFang SC"/>
                 <a:cs typeface="PingFang SC"/>
-                <a:hlinkClick xmlns:r="http://schemas.openxmlformats.org/officeDocument/2006/relationships" r:id="R74b7230a8d954be4"/>
+                <a:hlinkClick xmlns:r="http://schemas.openxmlformats.org/officeDocument/2006/relationships" r:id="R53e5d50961254881"/>
               </a:rPr>
               <a:t>▶ 在线 Demo</a:t>
             </a:r>
@@ -11682,7 +11706,7 @@
                 <a:latin typeface="PingFang SC"/>
                 <a:ea typeface="PingFang SC"/>
                 <a:cs typeface="PingFang SC"/>
-                <a:hlinkClick xmlns:r="http://schemas.openxmlformats.org/officeDocument/2006/relationships" r:id="Rfe1196de1277461b"/>
+                <a:hlinkClick xmlns:r="http://schemas.openxmlformats.org/officeDocument/2006/relationships" r:id="Rb298058611de4da2"/>
               </a:rPr>
               <a:t>结果备份 ↗</a:t>
             </a:r>
@@ -11757,6 +11781,7 @@
           <a:lstStyle xmlns:a="http://schemas.openxmlformats.org/drawingml/2006/main"/>
           <a:p xmlns:a="http://schemas.openxmlformats.org/drawingml/2006/main">
             <a:pPr algn="l">
+              <a:buNone/>
               <a:defRPr sz="1725" b="1">
                 <a:solidFill>
                   <a:srgbClr val="111C31"/>
@@ -11809,6 +11834,7 @@
           <a:lstStyle xmlns:a="http://schemas.openxmlformats.org/drawingml/2006/main"/>
           <a:p xmlns:a="http://schemas.openxmlformats.org/drawingml/2006/main">
             <a:pPr algn="l">
+              <a:buNone/>
               <a:defRPr sz="1238" b="0">
                 <a:solidFill>
                   <a:srgbClr val="6E7A90"/>
@@ -11894,6 +11920,7 @@
           <a:lstStyle xmlns:a="http://schemas.openxmlformats.org/drawingml/2006/main"/>
           <a:p xmlns:a="http://schemas.openxmlformats.org/drawingml/2006/main">
             <a:pPr algn="l">
+              <a:buNone/>
               <a:defRPr sz="1725" b="1">
                 <a:solidFill>
                   <a:srgbClr val="111C31"/>
@@ -11946,6 +11973,7 @@
           <a:lstStyle xmlns:a="http://schemas.openxmlformats.org/drawingml/2006/main"/>
           <a:p xmlns:a="http://schemas.openxmlformats.org/drawingml/2006/main">
             <a:pPr algn="l">
+              <a:buNone/>
               <a:defRPr sz="1238" b="0">
                 <a:solidFill>
                   <a:srgbClr val="6E7A90"/>
@@ -12031,6 +12059,7 @@
           <a:lstStyle xmlns:a="http://schemas.openxmlformats.org/drawingml/2006/main"/>
           <a:p xmlns:a="http://schemas.openxmlformats.org/drawingml/2006/main">
             <a:pPr algn="l">
+              <a:buNone/>
               <a:defRPr sz="1725" b="1">
                 <a:solidFill>
                   <a:srgbClr val="111C31"/>
@@ -12083,6 +12112,7 @@
           <a:lstStyle xmlns:a="http://schemas.openxmlformats.org/drawingml/2006/main"/>
           <a:p xmlns:a="http://schemas.openxmlformats.org/drawingml/2006/main">
             <a:pPr algn="l">
+              <a:buNone/>
               <a:defRPr sz="1238" b="0">
                 <a:solidFill>
                   <a:srgbClr val="6E7A90"/>

</xml_diff>

<commit_message>
docs: update EvalCall six-step design copy
</commit_message>
<xml_diff>
--- a/submission/EvalCall决赛提交包-20260715/01_EvalCall决赛PPT-最终提交版.pptx
+++ b/submission/EvalCall决赛提交包-20260715/01_EvalCall决赛PPT-最终提交版.pptx
@@ -2,21 +2,21 @@
 <file path=ppt/presentation.xml><?xml version="1.0" encoding="utf-8"?>
 <p:presentation xmlns:p="http://schemas.openxmlformats.org/presentationml/2006/main">
   <p:sldMasterIdLst>
-    <p:sldMasterId xmlns:r="http://schemas.openxmlformats.org/officeDocument/2006/relationships" id="2147483648" r:id="Raccf9b20c2d845a7"/>
+    <p:sldMasterId xmlns:r="http://schemas.openxmlformats.org/officeDocument/2006/relationships" id="2147483648" r:id="R5d0627675b83420e"/>
   </p:sldMasterIdLst>
   <p:notesMasterIdLst>
-    <p:notesMasterId xmlns:r="http://schemas.openxmlformats.org/officeDocument/2006/relationships" r:id="Ra877ad6c90384a43"/>
+    <p:notesMasterId xmlns:r="http://schemas.openxmlformats.org/officeDocument/2006/relationships" r:id="Rbda9cb0d8a8f4807"/>
   </p:notesMasterIdLst>
   <p:sldIdLst>
-    <p:sldId xmlns:r="http://schemas.openxmlformats.org/officeDocument/2006/relationships" id="256" r:id="R20738b59c50d436f"/>
-    <p:sldId xmlns:r="http://schemas.openxmlformats.org/officeDocument/2006/relationships" id="257" r:id="R0f1a63dca1c14cdf"/>
-    <p:sldId xmlns:r="http://schemas.openxmlformats.org/officeDocument/2006/relationships" id="258" r:id="R1ecb4381e19140e8"/>
-    <p:sldId xmlns:r="http://schemas.openxmlformats.org/officeDocument/2006/relationships" id="259" r:id="R7f3ef8aec69d4ecd"/>
-    <p:sldId xmlns:r="http://schemas.openxmlformats.org/officeDocument/2006/relationships" id="260" r:id="R5fec3e7b371b4619"/>
-    <p:sldId xmlns:r="http://schemas.openxmlformats.org/officeDocument/2006/relationships" id="261" r:id="Rd48c294b4c0a432f"/>
-    <p:sldId xmlns:r="http://schemas.openxmlformats.org/officeDocument/2006/relationships" id="262" r:id="Re33e345d80de4b55"/>
-    <p:sldId xmlns:r="http://schemas.openxmlformats.org/officeDocument/2006/relationships" id="263" r:id="Red15dd8fc50d48b3"/>
-    <p:sldId xmlns:r="http://schemas.openxmlformats.org/officeDocument/2006/relationships" id="264" r:id="R2c813f8b44574722"/>
+    <p:sldId xmlns:r="http://schemas.openxmlformats.org/officeDocument/2006/relationships" id="256" r:id="R02b8ab2037e9416e"/>
+    <p:sldId xmlns:r="http://schemas.openxmlformats.org/officeDocument/2006/relationships" id="257" r:id="R19961b8e0e744c7c"/>
+    <p:sldId xmlns:r="http://schemas.openxmlformats.org/officeDocument/2006/relationships" id="258" r:id="R8432e9d5364e4f93"/>
+    <p:sldId xmlns:r="http://schemas.openxmlformats.org/officeDocument/2006/relationships" id="259" r:id="R2c9a2eb38e154143"/>
+    <p:sldId xmlns:r="http://schemas.openxmlformats.org/officeDocument/2006/relationships" id="260" r:id="Rb6adecab27954998"/>
+    <p:sldId xmlns:r="http://schemas.openxmlformats.org/officeDocument/2006/relationships" id="261" r:id="R1a5a7d249fc84401"/>
+    <p:sldId xmlns:r="http://schemas.openxmlformats.org/officeDocument/2006/relationships" id="262" r:id="R4e15b107001b48fa"/>
+    <p:sldId xmlns:r="http://schemas.openxmlformats.org/officeDocument/2006/relationships" id="263" r:id="R3917fcd3b0b141aa"/>
+    <p:sldId xmlns:r="http://schemas.openxmlformats.org/officeDocument/2006/relationships" id="264" r:id="R4d433e1fab8e4e29"/>
   </p:sldIdLst>
   <p:sldSz cx="12192000" cy="6858000"/>
   <p:notesSz cx="6858000" cy="9144000"/>
@@ -1238,7 +1238,7 @@
   </p:cSld>
   <p:clrMap bg1="lt1" tx1="dk1" bg2="lt2" tx2="dk2" accent1="accent1" accent2="accent2" accent3="accent3" accent4="accent4" accent5="accent5" accent6="accent6" hlink="hlink" folHlink="folHlink"/>
   <p:sldLayoutIdLst>
-    <p:sldLayoutId xmlns:r="http://schemas.openxmlformats.org/officeDocument/2006/relationships" id="2147483649" r:id="R2078dab3c8f54e11"/>
+    <p:sldLayoutId xmlns:r="http://schemas.openxmlformats.org/officeDocument/2006/relationships" id="2147483649" r:id="R844a27c395bc4dea"/>
   </p:sldLayoutIdLst>
   <p:txStyles>
     <p:titleStyle>
@@ -1793,7 +1793,7 @@
           <p:nvPr/>
         </p:nvPicPr>
         <p:blipFill>
-          <a:blip xmlns:r="http://schemas.openxmlformats.org/officeDocument/2006/relationships" xmlns:a="http://schemas.openxmlformats.org/drawingml/2006/main" r:embed="R842447d322514666"/>
+          <a:blip xmlns:r="http://schemas.openxmlformats.org/officeDocument/2006/relationships" xmlns:a="http://schemas.openxmlformats.org/drawingml/2006/main" r:embed="R8fde023e631849dd"/>
           <a:srcRect xmlns:a="http://schemas.openxmlformats.org/drawingml/2006/main" l="0" t="27" r="0" b="27"/>
           <a:stretch xmlns:a="http://schemas.openxmlformats.org/drawingml/2006/main">
             <a:fillRect l="0" t="0" r="0" b="0"/>
@@ -3948,7 +3948,7 @@
                 <a:latin typeface="PingFang SC"/>
                 <a:ea typeface="PingFang SC"/>
                 <a:cs typeface="PingFang SC"/>
-                <a:hlinkClick xmlns:r="http://schemas.openxmlformats.org/officeDocument/2006/relationships" r:id="R03820dcd81b74ead"/>
+                <a:hlinkClick xmlns:r="http://schemas.openxmlformats.org/officeDocument/2006/relationships" r:id="Rf667beebe14f4e5c"/>
               </a:rPr>
               <a:t>▶ 在线 Demo</a:t>
             </a:r>
@@ -4000,7 +4000,7 @@
                 <a:latin typeface="PingFang SC"/>
                 <a:ea typeface="PingFang SC"/>
                 <a:cs typeface="PingFang SC"/>
-                <a:hlinkClick xmlns:r="http://schemas.openxmlformats.org/officeDocument/2006/relationships" r:id="R4914a3298ce74a05"/>
+                <a:hlinkClick xmlns:r="http://schemas.openxmlformats.org/officeDocument/2006/relationships" r:id="Rf70e0b62d9364fc9"/>
               </a:rPr>
               <a:t>结果备份 ↗</a:t>
             </a:r>
@@ -4042,6 +4042,7 @@
           <a:lstStyle xmlns:a="http://schemas.openxmlformats.org/drawingml/2006/main"/>
           <a:p xmlns:a="http://schemas.openxmlformats.org/drawingml/2006/main">
             <a:pPr algn="l">
+              <a:buNone/>
               <a:defRPr sz="1050" b="1">
                 <a:solidFill>
                   <a:srgbClr val="6E7A90"/>
@@ -4094,6 +4095,7 @@
           <a:lstStyle xmlns:a="http://schemas.openxmlformats.org/drawingml/2006/main"/>
           <a:p xmlns:a="http://schemas.openxmlformats.org/drawingml/2006/main">
             <a:pPr algn="l">
+              <a:buNone/>
               <a:defRPr sz="2850" b="1">
                 <a:solidFill>
                   <a:srgbClr val="111C31"/>
@@ -4332,6 +4334,7 @@
           <a:lstStyle xmlns:a="http://schemas.openxmlformats.org/drawingml/2006/main"/>
           <a:p xmlns:a="http://schemas.openxmlformats.org/drawingml/2006/main">
             <a:pPr algn="ctr">
+              <a:buNone/>
               <a:defRPr sz="975" b="1">
                 <a:solidFill>
                   <a:srgbClr val="6E7A90"/>
@@ -4384,6 +4387,7 @@
           <a:lstStyle xmlns:a="http://schemas.openxmlformats.org/drawingml/2006/main"/>
           <a:p xmlns:a="http://schemas.openxmlformats.org/drawingml/2006/main">
             <a:pPr algn="ctr">
+              <a:buNone/>
               <a:defRPr sz="975" b="1">
                 <a:solidFill>
                   <a:srgbClr val="6E7A90"/>
@@ -4436,6 +4440,7 @@
           <a:lstStyle xmlns:a="http://schemas.openxmlformats.org/drawingml/2006/main"/>
           <a:p xmlns:a="http://schemas.openxmlformats.org/drawingml/2006/main">
             <a:pPr algn="l">
+              <a:buNone/>
               <a:defRPr sz="975" b="1">
                 <a:solidFill>
                   <a:srgbClr val="6E7A90"/>
@@ -4488,6 +4493,7 @@
           <a:lstStyle xmlns:a="http://schemas.openxmlformats.org/drawingml/2006/main"/>
           <a:p xmlns:a="http://schemas.openxmlformats.org/drawingml/2006/main">
             <a:pPr algn="ctr">
+              <a:buNone/>
               <a:defRPr sz="975" b="1">
                 <a:solidFill>
                   <a:srgbClr val="6E7A90"/>
@@ -4540,6 +4546,7 @@
           <a:lstStyle xmlns:a="http://schemas.openxmlformats.org/drawingml/2006/main"/>
           <a:p xmlns:a="http://schemas.openxmlformats.org/drawingml/2006/main">
             <a:pPr algn="ctr">
+              <a:buNone/>
               <a:defRPr sz="975" b="1">
                 <a:solidFill>
                   <a:srgbClr val="6E7A90"/>
@@ -4625,6 +4632,7 @@
           <a:lstStyle xmlns:a="http://schemas.openxmlformats.org/drawingml/2006/main"/>
           <a:p xmlns:a="http://schemas.openxmlformats.org/drawingml/2006/main">
             <a:pPr algn="ctr">
+              <a:buNone/>
               <a:defRPr sz="1950" b="1">
                 <a:solidFill>
                   <a:srgbClr val="FFFFFF"/>
@@ -4677,6 +4685,7 @@
           <a:lstStyle xmlns:a="http://schemas.openxmlformats.org/drawingml/2006/main"/>
           <a:p xmlns:a="http://schemas.openxmlformats.org/drawingml/2006/main">
             <a:pPr algn="ctr">
+              <a:buNone/>
               <a:defRPr sz="1500" b="1">
                 <a:solidFill>
                   <a:srgbClr val="111C31"/>
@@ -4762,6 +4771,7 @@
           <a:lstStyle xmlns:a="http://schemas.openxmlformats.org/drawingml/2006/main"/>
           <a:p xmlns:a="http://schemas.openxmlformats.org/drawingml/2006/main">
             <a:pPr algn="ctr">
+              <a:buNone/>
               <a:defRPr sz="1950" b="1">
                 <a:solidFill>
                   <a:srgbClr val="FFFFFF"/>
@@ -4814,6 +4824,7 @@
           <a:lstStyle xmlns:a="http://schemas.openxmlformats.org/drawingml/2006/main"/>
           <a:p xmlns:a="http://schemas.openxmlformats.org/drawingml/2006/main">
             <a:pPr algn="ctr">
+              <a:buNone/>
               <a:defRPr sz="1500" b="1">
                 <a:solidFill>
                   <a:srgbClr val="111C31"/>
@@ -4899,6 +4910,7 @@
           <a:lstStyle xmlns:a="http://schemas.openxmlformats.org/drawingml/2006/main"/>
           <a:p xmlns:a="http://schemas.openxmlformats.org/drawingml/2006/main">
             <a:pPr algn="ctr">
+              <a:buNone/>
               <a:defRPr sz="1950" b="1">
                 <a:solidFill>
                   <a:srgbClr val="FFFFFF"/>
@@ -4951,6 +4963,7 @@
           <a:lstStyle xmlns:a="http://schemas.openxmlformats.org/drawingml/2006/main"/>
           <a:p xmlns:a="http://schemas.openxmlformats.org/drawingml/2006/main">
             <a:pPr algn="ctr">
+              <a:buNone/>
               <a:defRPr sz="1500" b="1">
                 <a:solidFill>
                   <a:srgbClr val="111C31"/>
@@ -5036,6 +5049,7 @@
           <a:lstStyle xmlns:a="http://schemas.openxmlformats.org/drawingml/2006/main"/>
           <a:p xmlns:a="http://schemas.openxmlformats.org/drawingml/2006/main">
             <a:pPr algn="ctr">
+              <a:buNone/>
               <a:defRPr sz="1950" b="1">
                 <a:solidFill>
                   <a:srgbClr val="111C31"/>
@@ -5088,6 +5102,7 @@
           <a:lstStyle xmlns:a="http://schemas.openxmlformats.org/drawingml/2006/main"/>
           <a:p xmlns:a="http://schemas.openxmlformats.org/drawingml/2006/main">
             <a:pPr algn="ctr">
+              <a:buNone/>
               <a:defRPr sz="1500" b="1">
                 <a:solidFill>
                   <a:srgbClr val="111C31"/>
@@ -5173,6 +5188,7 @@
           <a:lstStyle xmlns:a="http://schemas.openxmlformats.org/drawingml/2006/main"/>
           <a:p xmlns:a="http://schemas.openxmlformats.org/drawingml/2006/main">
             <a:pPr algn="ctr">
+              <a:buNone/>
               <a:defRPr sz="1950" b="1">
                 <a:solidFill>
                   <a:srgbClr val="FFFFFF"/>
@@ -5225,6 +5241,7 @@
           <a:lstStyle xmlns:a="http://schemas.openxmlformats.org/drawingml/2006/main"/>
           <a:p xmlns:a="http://schemas.openxmlformats.org/drawingml/2006/main">
             <a:pPr algn="ctr">
+              <a:buNone/>
               <a:defRPr sz="1500" b="1">
                 <a:solidFill>
                   <a:srgbClr val="111C31"/>
@@ -5310,6 +5327,7 @@
           <a:lstStyle xmlns:a="http://schemas.openxmlformats.org/drawingml/2006/main"/>
           <a:p xmlns:a="http://schemas.openxmlformats.org/drawingml/2006/main">
             <a:pPr algn="ctr">
+              <a:buNone/>
               <a:defRPr sz="1950" b="1">
                 <a:solidFill>
                   <a:srgbClr val="111C31"/>
@@ -5362,6 +5380,7 @@
           <a:lstStyle xmlns:a="http://schemas.openxmlformats.org/drawingml/2006/main"/>
           <a:p xmlns:a="http://schemas.openxmlformats.org/drawingml/2006/main">
             <a:pPr algn="ctr">
+              <a:buNone/>
               <a:defRPr sz="1500" b="1">
                 <a:solidFill>
                   <a:srgbClr val="111C31"/>
@@ -5447,6 +5466,7 @@
           <a:lstStyle xmlns:a="http://schemas.openxmlformats.org/drawingml/2006/main"/>
           <a:p xmlns:a="http://schemas.openxmlformats.org/drawingml/2006/main">
             <a:pPr algn="ctr">
+              <a:buNone/>
               <a:defRPr sz="1350" b="1">
                 <a:solidFill>
                   <a:srgbClr val="111C31"/>
@@ -5561,6 +5581,7 @@
           <a:lstStyle xmlns:a="http://schemas.openxmlformats.org/drawingml/2006/main"/>
           <a:p xmlns:a="http://schemas.openxmlformats.org/drawingml/2006/main">
             <a:pPr algn="r">
+              <a:buNone/>
               <a:defRPr sz="750" b="0">
                 <a:solidFill>
                   <a:srgbClr val="6E7A90"/>
@@ -6125,7 +6146,7 @@
           <p:nvPr/>
         </p:nvPicPr>
         <p:blipFill>
-          <a:blip xmlns:r="http://schemas.openxmlformats.org/officeDocument/2006/relationships" xmlns:a="http://schemas.openxmlformats.org/drawingml/2006/main" r:embed="R8085ad5ec3224e6e"/>
+          <a:blip xmlns:r="http://schemas.openxmlformats.org/officeDocument/2006/relationships" xmlns:a="http://schemas.openxmlformats.org/drawingml/2006/main" r:embed="R01cd5a33f4b94c95"/>
           <a:srcRect xmlns:a="http://schemas.openxmlformats.org/drawingml/2006/main" l="0" t="2174" r="0" b="2174"/>
           <a:stretch xmlns:a="http://schemas.openxmlformats.org/drawingml/2006/main">
             <a:fillRect l="0" t="0" r="0" b="0"/>
@@ -6194,7 +6215,7 @@
                 <a:latin typeface="PingFang SC"/>
                 <a:ea typeface="PingFang SC"/>
                 <a:cs typeface="PingFang SC"/>
-                <a:hlinkClick xmlns:r="http://schemas.openxmlformats.org/officeDocument/2006/relationships" r:id="R40c1af5816514d7c"/>
+                <a:hlinkClick xmlns:r="http://schemas.openxmlformats.org/officeDocument/2006/relationships" r:id="Rfe1f8d2ad3664188"/>
               </a:rPr>
               <a:t>▶ 在线 Demo</a:t>
             </a:r>
@@ -6246,7 +6267,7 @@
                 <a:latin typeface="PingFang SC"/>
                 <a:ea typeface="PingFang SC"/>
                 <a:cs typeface="PingFang SC"/>
-                <a:hlinkClick xmlns:r="http://schemas.openxmlformats.org/officeDocument/2006/relationships" r:id="Re8be0e8d9496440a"/>
+                <a:hlinkClick xmlns:r="http://schemas.openxmlformats.org/officeDocument/2006/relationships" r:id="Rdfd34c3ae79a4460"/>
               </a:rPr>
               <a:t>结果备份 ↗</a:t>
             </a:r>
@@ -6387,7 +6408,7 @@
                   <a:srgbClr val="6E7A90"/>
                 </a:solidFill>
               </a:rPr>
-              <a:t>评测输入和版本经常变化，导致不同模型结果无法公平比较。</a:t>
+              <a:t>不同模型缺少统一测试条件，无法判断版本是否真正提升。</a:t>
             </a:r>
           </a:p>
         </p:txBody>
@@ -6473,7 +6494,7 @@
                   <a:srgbClr val="111C31"/>
                 </a:solidFill>
               </a:rPr>
-              <a:t>这么设计是怎么实现的</a:t>
+              <a:t>怎么实现</a:t>
             </a:r>
           </a:p>
         </p:txBody>
@@ -6526,7 +6547,7 @@
                   <a:srgbClr val="6E7A90"/>
                 </a:solidFill>
               </a:rPr>
-              <a:t>同时支持模拟测试和已有日志；将模型、SOP、用户批次统一写入任务包并计算哈希。</a:t>
+              <a:t>编排器统一封装模型、SOP、Persona和测试批次，并生成版本哈希。</a:t>
             </a:r>
           </a:p>
         </p:txBody>
@@ -6612,7 +6633,7 @@
                   <a:srgbClr val="111C31"/>
                 </a:solidFill>
               </a:rPr>
-              <a:t>这么设计的优势</a:t>
+              <a:t>设计优势</a:t>
             </a:r>
           </a:p>
         </p:txBody>
@@ -6665,7 +6686,7 @@
                   <a:srgbClr val="6E7A90"/>
                 </a:solidFill>
               </a:rPr>
-              <a:t>六步始终复用同一份输入事实，结果可复现、可追踪，也能进行真实版本对比。</a:t>
+              <a:t>控制测试变量，让不同模型能够公平比较、复现和追踪。</a:t>
             </a:r>
           </a:p>
         </p:txBody>
@@ -7217,7 +7238,7 @@
           <p:nvPr/>
         </p:nvPicPr>
         <p:blipFill>
-          <a:blip xmlns:r="http://schemas.openxmlformats.org/officeDocument/2006/relationships" xmlns:a="http://schemas.openxmlformats.org/drawingml/2006/main" r:embed="R5b9c019baddd46bf"/>
+          <a:blip xmlns:r="http://schemas.openxmlformats.org/officeDocument/2006/relationships" xmlns:a="http://schemas.openxmlformats.org/drawingml/2006/main" r:embed="R3fe1064bd83f4af7"/>
           <a:srcRect xmlns:a="http://schemas.openxmlformats.org/drawingml/2006/main" l="0" t="2174" r="0" b="2174"/>
           <a:stretch xmlns:a="http://schemas.openxmlformats.org/drawingml/2006/main">
             <a:fillRect l="0" t="0" r="0" b="0"/>
@@ -7286,7 +7307,7 @@
                 <a:latin typeface="PingFang SC"/>
                 <a:ea typeface="PingFang SC"/>
                 <a:cs typeface="PingFang SC"/>
-                <a:hlinkClick xmlns:r="http://schemas.openxmlformats.org/officeDocument/2006/relationships" r:id="Rfa8c4044328249f7"/>
+                <a:hlinkClick xmlns:r="http://schemas.openxmlformats.org/officeDocument/2006/relationships" r:id="R322533cfccbd4dce"/>
               </a:rPr>
               <a:t>▶ 在线 Demo</a:t>
             </a:r>
@@ -7338,7 +7359,7 @@
                 <a:latin typeface="PingFang SC"/>
                 <a:ea typeface="PingFang SC"/>
                 <a:cs typeface="PingFang SC"/>
-                <a:hlinkClick xmlns:r="http://schemas.openxmlformats.org/officeDocument/2006/relationships" r:id="R939a5b3b9b9348a2"/>
+                <a:hlinkClick xmlns:r="http://schemas.openxmlformats.org/officeDocument/2006/relationships" r:id="R21edcde5a4904598"/>
               </a:rPr>
               <a:t>结果备份 ↗</a:t>
             </a:r>
@@ -7479,7 +7500,7 @@
                   <a:srgbClr val="6E7A90"/>
                 </a:solidFill>
               </a:rPr>
-              <a:t>自然语言SOP存在歧义，Judge可能每次按照不同标准打分。</a:t>
+              <a:t>自然语言指令无法直接用于规模化判断模型是否逐条遵循。</a:t>
             </a:r>
           </a:p>
         </p:txBody>
@@ -7565,7 +7586,7 @@
                   <a:srgbClr val="111C31"/>
                 </a:solidFill>
               </a:rPr>
-              <a:t>这么设计是怎么实现的</a:t>
+              <a:t>怎么实现</a:t>
             </a:r>
           </a:p>
         </p:txBody>
@@ -7618,7 +7639,7 @@
                   <a:srgbClr val="6E7A90"/>
                 </a:solidFill>
               </a:rPr>
-              <a:t>把SOP编译成L0通用红线与L1业务规则；每个检查点保留来源、条件和严重度。</a:t>
+              <a:t>Checklist Agent将SOP编译成L0安全规则与L1业务检查点。</a:t>
             </a:r>
           </a:p>
         </p:txBody>
@@ -7704,7 +7725,7 @@
                   <a:srgbClr val="111C31"/>
                 </a:solidFill>
               </a:rPr>
-              <a:t>这么设计的优势</a:t>
+              <a:t>设计优势</a:t>
             </a:r>
           </a:p>
         </p:txBody>
@@ -7757,7 +7778,7 @@
                   <a:srgbClr val="6E7A90"/>
                 </a:solidFill>
               </a:rPr>
-              <a:t>评分标准从提示词变成可执行合同，既能自动评分，也能逐项审计和复核。</a:t>
+              <a:t>把模糊要求变成统一、可执行、可追溯的评分契约。</a:t>
             </a:r>
           </a:p>
         </p:txBody>
@@ -8309,7 +8330,7 @@
           <p:nvPr/>
         </p:nvPicPr>
         <p:blipFill>
-          <a:blip xmlns:r="http://schemas.openxmlformats.org/officeDocument/2006/relationships" xmlns:a="http://schemas.openxmlformats.org/drawingml/2006/main" r:embed="R66948803f0be472d"/>
+          <a:blip xmlns:r="http://schemas.openxmlformats.org/officeDocument/2006/relationships" xmlns:a="http://schemas.openxmlformats.org/drawingml/2006/main" r:embed="R4b21587e42904222"/>
           <a:srcRect xmlns:a="http://schemas.openxmlformats.org/drawingml/2006/main" l="0" t="2174" r="0" b="2174"/>
           <a:stretch xmlns:a="http://schemas.openxmlformats.org/drawingml/2006/main">
             <a:fillRect l="0" t="0" r="0" b="0"/>
@@ -8378,7 +8399,7 @@
                 <a:latin typeface="PingFang SC"/>
                 <a:ea typeface="PingFang SC"/>
                 <a:cs typeface="PingFang SC"/>
-                <a:hlinkClick xmlns:r="http://schemas.openxmlformats.org/officeDocument/2006/relationships" r:id="R2b80941209464b7e"/>
+                <a:hlinkClick xmlns:r="http://schemas.openxmlformats.org/officeDocument/2006/relationships" r:id="Rd6190458e5af44dc"/>
               </a:rPr>
               <a:t>▶ 在线跑六步</a:t>
             </a:r>
@@ -8430,7 +8451,7 @@
                 <a:latin typeface="PingFang SC"/>
                 <a:ea typeface="PingFang SC"/>
                 <a:cs typeface="PingFang SC"/>
-                <a:hlinkClick xmlns:r="http://schemas.openxmlformats.org/officeDocument/2006/relationships" r:id="R5813971fd8844019"/>
+                <a:hlinkClick xmlns:r="http://schemas.openxmlformats.org/officeDocument/2006/relationships" r:id="R0b305e3a67cf4b9b"/>
               </a:rPr>
               <a:t>结果备份 ↗</a:t>
             </a:r>
@@ -8571,7 +8592,7 @@
                   <a:srgbClr val="6E7A90"/>
                 </a:solidFill>
               </a:rPr>
-              <a:t>历史日志覆盖不到拒绝、打断、质疑等高风险对话边界。</a:t>
+              <a:t>历史日志覆盖不足，难以提前暴露高风险对话缺陷。</a:t>
             </a:r>
           </a:p>
         </p:txBody>
@@ -8657,7 +8678,7 @@
                   <a:srgbClr val="111C31"/>
                 </a:solidFill>
               </a:rPr>
-              <a:t>这么设计是怎么实现的</a:t>
+              <a:t>怎么实现</a:t>
             </a:r>
           </a:p>
         </p:txBody>
@@ -8710,7 +8731,7 @@
                   <a:srgbClr val="6E7A90"/>
                 </a:solidFill>
               </a:rPr>
-              <a:t>用户模拟器组合Persona、对抗目标和固定Seed，主动生成可复现的多轮测试对话。</a:t>
+              <a:t>用户模拟器根据Persona生成多轮对话，并追踪检查点覆盖率。</a:t>
             </a:r>
           </a:p>
         </p:txBody>
@@ -8796,7 +8817,7 @@
                   <a:srgbClr val="111C31"/>
                 </a:solidFill>
               </a:rPr>
-              <a:t>这么设计的优势</a:t>
+              <a:t>设计优势</a:t>
             </a:r>
           </a:p>
         </p:txBody>
@@ -8849,7 +8870,7 @@
                   <a:srgbClr val="6E7A90"/>
                 </a:solidFill>
               </a:rPr>
-              <a:t>上线前主动暴露脆弱点，同时保证两个模型版本面对完全相同的测试场景。</a:t>
+              <a:t>从被动抽查升级为主动测试，同时兼容已有日志质检。</a:t>
             </a:r>
           </a:p>
         </p:txBody>
@@ -9401,7 +9422,7 @@
           <p:nvPr/>
         </p:nvPicPr>
         <p:blipFill>
-          <a:blip xmlns:r="http://schemas.openxmlformats.org/officeDocument/2006/relationships" xmlns:a="http://schemas.openxmlformats.org/drawingml/2006/main" r:embed="R2d4913c9b9b34d0a"/>
+          <a:blip xmlns:r="http://schemas.openxmlformats.org/officeDocument/2006/relationships" xmlns:a="http://schemas.openxmlformats.org/drawingml/2006/main" r:embed="R22d60cd08c5646aa"/>
           <a:srcRect xmlns:a="http://schemas.openxmlformats.org/drawingml/2006/main" l="0" t="8152" r="0" b="8152"/>
           <a:stretch xmlns:a="http://schemas.openxmlformats.org/drawingml/2006/main">
             <a:fillRect l="0" t="0" r="0" b="0"/>
@@ -9470,7 +9491,7 @@
                 <a:latin typeface="PingFang SC"/>
                 <a:ea typeface="PingFang SC"/>
                 <a:cs typeface="PingFang SC"/>
-                <a:hlinkClick xmlns:r="http://schemas.openxmlformats.org/officeDocument/2006/relationships" r:id="R3070979f640549f9"/>
+                <a:hlinkClick xmlns:r="http://schemas.openxmlformats.org/officeDocument/2006/relationships" r:id="R03303ae739da4743"/>
               </a:rPr>
               <a:t>▶ 在线 Demo</a:t>
             </a:r>
@@ -9522,7 +9543,7 @@
                 <a:latin typeface="PingFang SC"/>
                 <a:ea typeface="PingFang SC"/>
                 <a:cs typeface="PingFang SC"/>
-                <a:hlinkClick xmlns:r="http://schemas.openxmlformats.org/officeDocument/2006/relationships" r:id="R2b84486177f742a0"/>
+                <a:hlinkClick xmlns:r="http://schemas.openxmlformats.org/officeDocument/2006/relationships" r:id="R987213c3eae54a6f"/>
               </a:rPr>
               <a:t>结果备份 ↗</a:t>
             </a:r>
@@ -9663,7 +9684,7 @@
                   <a:srgbClr val="6E7A90"/>
                 </a:solidFill>
               </a:rPr>
-              <a:t>平均分会掩盖P0、隐私泄露和关键流程中断，无法直接回答能否上线。</a:t>
+              <a:t>平均分无法反映P0风险，也无法直接支持上线决策。</a:t>
             </a:r>
           </a:p>
         </p:txBody>
@@ -9749,7 +9770,7 @@
                   <a:srgbClr val="111C31"/>
                 </a:solidFill>
               </a:rPr>
-              <a:t>这么设计是怎么实现的</a:t>
+              <a:t>怎么实现</a:t>
             </a:r>
           </a:p>
         </p:txBody>
@@ -9802,7 +9823,7 @@
                   <a:srgbClr val="6E7A90"/>
                 </a:solidFill>
               </a:rPr>
-              <a:t>同时计算门禁、履约率、P0和关键失败，并把每个结论绑定到原始对话证据。</a:t>
+              <a:t>Judge逐项引用证据判定，程序汇总履约、P0、覆盖率和门禁。</a:t>
             </a:r>
           </a:p>
         </p:txBody>
@@ -9888,7 +9909,7 @@
                   <a:srgbClr val="111C31"/>
                 </a:solidFill>
               </a:rPr>
-              <a:t>这么设计的优势</a:t>
+              <a:t>设计优势</a:t>
             </a:r>
           </a:p>
         </p:txBody>
@@ -9941,7 +9962,7 @@
                   <a:srgbClr val="6E7A90"/>
                 </a:solidFill>
               </a:rPr>
-              <a:t>报告直接支持发布决策；评委既能看到结论，也能追溯每一次打回的原因。</a:t>
+              <a:t>直接回答能否上线、失败在哪里，以及对应证据是什么。</a:t>
             </a:r>
           </a:p>
         </p:txBody>
@@ -10493,7 +10514,7 @@
           <p:nvPr/>
         </p:nvPicPr>
         <p:blipFill>
-          <a:blip xmlns:r="http://schemas.openxmlformats.org/officeDocument/2006/relationships" xmlns:a="http://schemas.openxmlformats.org/drawingml/2006/main" r:embed="R19db4d48e7554858"/>
+          <a:blip xmlns:r="http://schemas.openxmlformats.org/officeDocument/2006/relationships" xmlns:a="http://schemas.openxmlformats.org/drawingml/2006/main" r:embed="R93ee6c1fbc754254"/>
           <a:srcRect xmlns:a="http://schemas.openxmlformats.org/drawingml/2006/main" l="0" t="2174" r="0" b="2174"/>
           <a:stretch xmlns:a="http://schemas.openxmlformats.org/drawingml/2006/main">
             <a:fillRect l="0" t="0" r="0" b="0"/>
@@ -10562,7 +10583,7 @@
                 <a:latin typeface="PingFang SC"/>
                 <a:ea typeface="PingFang SC"/>
                 <a:cs typeface="PingFang SC"/>
-                <a:hlinkClick xmlns:r="http://schemas.openxmlformats.org/officeDocument/2006/relationships" r:id="Rff31fb86fa01495e"/>
+                <a:hlinkClick xmlns:r="http://schemas.openxmlformats.org/officeDocument/2006/relationships" r:id="R0aca70c6f8e34ec7"/>
               </a:rPr>
               <a:t>▶ 在线 Demo</a:t>
             </a:r>
@@ -10614,7 +10635,7 @@
                 <a:latin typeface="PingFang SC"/>
                 <a:ea typeface="PingFang SC"/>
                 <a:cs typeface="PingFang SC"/>
-                <a:hlinkClick xmlns:r="http://schemas.openxmlformats.org/officeDocument/2006/relationships" r:id="Rce631c926e3b49e3"/>
+                <a:hlinkClick xmlns:r="http://schemas.openxmlformats.org/officeDocument/2006/relationships" r:id="R116f25c1455243fc"/>
               </a:rPr>
               <a:t>结果备份 ↗</a:t>
             </a:r>
@@ -10755,7 +10776,7 @@
                   <a:srgbClr val="6E7A90"/>
                 </a:solidFill>
               </a:rPr>
-              <a:t>低分不一定来自模型，也可能是SOP、裁判或测试覆盖的问题。</a:t>
+              <a:t>低分不一定来自模型，错误归因会导致修改错误对象。</a:t>
             </a:r>
           </a:p>
         </p:txBody>
@@ -10841,7 +10862,7 @@
                   <a:srgbClr val="111C31"/>
                 </a:solidFill>
               </a:rPr>
-              <a:t>这么设计是怎么实现的</a:t>
+              <a:t>怎么实现</a:t>
             </a:r>
           </a:p>
         </p:txBody>
@@ -10894,7 +10915,7 @@
                   <a:srgbClr val="6E7A90"/>
                 </a:solidFill>
               </a:rPr>
-              <a:t>综合打回率、履约率、P0、SOP健康度、NA率与裁判分歧率进行多信号归因。</a:t>
+              <a:t>综合模型表现、SOP健康度、裁判分歧和测试覆盖进行归因。</a:t>
             </a:r>
           </a:p>
         </p:txBody>
@@ -10980,7 +11001,7 @@
                   <a:srgbClr val="111C31"/>
                 </a:solidFill>
               </a:rPr>
-              <a:t>这么设计的优势</a:t>
+              <a:t>设计优势</a:t>
             </a:r>
           </a:p>
         </p:txBody>
@@ -11033,7 +11054,7 @@
                   <a:srgbClr val="6E7A90"/>
                 </a:solidFill>
               </a:rPr>
-              <a:t>避免把系统问题错怪给模型，让优化资源真正投入责任对象。</a:t>
+              <a:t>区分模型、SOP、裁判与测试数据，避免错误归责。</a:t>
             </a:r>
           </a:p>
         </p:txBody>
@@ -11585,7 +11606,7 @@
           <p:nvPr/>
         </p:nvPicPr>
         <p:blipFill>
-          <a:blip xmlns:r="http://schemas.openxmlformats.org/officeDocument/2006/relationships" xmlns:a="http://schemas.openxmlformats.org/drawingml/2006/main" r:embed="Rfebf4aa03b654fc0"/>
+          <a:blip xmlns:r="http://schemas.openxmlformats.org/officeDocument/2006/relationships" xmlns:a="http://schemas.openxmlformats.org/drawingml/2006/main" r:embed="R12d71c291de74625"/>
           <a:srcRect xmlns:a="http://schemas.openxmlformats.org/drawingml/2006/main" l="0" t="8152" r="0" b="8152"/>
           <a:stretch xmlns:a="http://schemas.openxmlformats.org/drawingml/2006/main">
             <a:fillRect l="0" t="0" r="0" b="0"/>
@@ -11654,7 +11675,7 @@
                 <a:latin typeface="PingFang SC"/>
                 <a:ea typeface="PingFang SC"/>
                 <a:cs typeface="PingFang SC"/>
-                <a:hlinkClick xmlns:r="http://schemas.openxmlformats.org/officeDocument/2006/relationships" r:id="R53e5d50961254881"/>
+                <a:hlinkClick xmlns:r="http://schemas.openxmlformats.org/officeDocument/2006/relationships" r:id="Rd5ae7edf3fd4475d"/>
               </a:rPr>
               <a:t>▶ 在线 Demo</a:t>
             </a:r>
@@ -11706,7 +11727,7 @@
                 <a:latin typeface="PingFang SC"/>
                 <a:ea typeface="PingFang SC"/>
                 <a:cs typeface="PingFang SC"/>
-                <a:hlinkClick xmlns:r="http://schemas.openxmlformats.org/officeDocument/2006/relationships" r:id="Rb298058611de4da2"/>
+                <a:hlinkClick xmlns:r="http://schemas.openxmlformats.org/officeDocument/2006/relationships" r:id="Ra5e6f9c5a8644988"/>
               </a:rPr>
               <a:t>结果备份 ↗</a:t>
             </a:r>
@@ -11847,7 +11868,7 @@
                   <a:srgbClr val="6E7A90"/>
                 </a:solidFill>
               </a:rPr>
-              <a:t>模型和评分尺同时变化时，无法证明性能提升究竟由谁造成。</a:t>
+              <a:t>同时改变多个变量，无法证明优化是否真正有效。</a:t>
             </a:r>
           </a:p>
         </p:txBody>
@@ -11933,7 +11954,7 @@
                   <a:srgbClr val="111C31"/>
                 </a:solidFill>
               </a:rPr>
-              <a:t>这么设计是怎么实现的</a:t>
+              <a:t>怎么实现</a:t>
             </a:r>
           </a:p>
         </p:txBody>
@@ -11986,7 +12007,7 @@
                   <a:srgbClr val="6E7A90"/>
                 </a:solidFill>
               </a:rPr>
-              <a:t>只改根因对应对象，锁定SOP、Checklist、Judge与用户批次，再回到第3步回归。</a:t>
+              <a:t>只修改首要责任对象，并锁定其余版本返回对应步骤回归。</a:t>
             </a:r>
           </a:p>
         </p:txBody>
@@ -12072,7 +12093,7 @@
                   <a:srgbClr val="111C31"/>
                 </a:solidFill>
               </a:rPr>
-              <a:t>这么设计的优势</a:t>
+              <a:t>设计优势</a:t>
             </a:r>
           </a:p>
         </p:txBody>
@@ -12125,7 +12146,7 @@
                   <a:srgbClr val="6E7A90"/>
                 </a:solidFill>
               </a:rPr>
-              <a:t>形成单变量、同尺、可审计的改进证据，证明优化有效且没有偷换标准。</a:t>
+              <a:t>形成“定位—修改—验证”闭环，准确证明版本提升。</a:t>
             </a:r>
           </a:p>
         </p:txBody>

</xml_diff>